<commit_message>
docs: record English validation and measured local results
</commit_message>
<xml_diff>
--- a/submission/Los_Antimarrulla_Screening_Pitch.pptx
+++ b/submission/Los_Antimarrulla_Screening_Pitch.pptx
@@ -2,20 +2,20 @@
 <file path=ppt/presentation.xml><?xml version="1.0" encoding="utf-8"?>
 <p:presentation xmlns:p="http://schemas.openxmlformats.org/presentationml/2006/main">
   <p:sldMasterIdLst>
-    <p:sldMasterId xmlns:r="http://schemas.openxmlformats.org/officeDocument/2006/relationships" id="2147483648" r:id="R1c80155bd8184979"/>
+    <p:sldMasterId xmlns:r="http://schemas.openxmlformats.org/officeDocument/2006/relationships" id="2147483648" r:id="Ra2e6c43658524f7e"/>
   </p:sldMasterIdLst>
   <p:notesMasterIdLst>
-    <p:notesMasterId xmlns:r="http://schemas.openxmlformats.org/officeDocument/2006/relationships" r:id="R4988c505b3914a9a"/>
+    <p:notesMasterId xmlns:r="http://schemas.openxmlformats.org/officeDocument/2006/relationships" r:id="R4c568041e2d44577"/>
   </p:notesMasterIdLst>
   <p:sldIdLst>
-    <p:sldId xmlns:r="http://schemas.openxmlformats.org/officeDocument/2006/relationships" id="256" r:id="R8997c1928c4a47a7"/>
-    <p:sldId xmlns:r="http://schemas.openxmlformats.org/officeDocument/2006/relationships" id="257" r:id="R5a08dd4a686c4768"/>
-    <p:sldId xmlns:r="http://schemas.openxmlformats.org/officeDocument/2006/relationships" id="258" r:id="R63c654d08bbe4530"/>
-    <p:sldId xmlns:r="http://schemas.openxmlformats.org/officeDocument/2006/relationships" id="259" r:id="Rb34dde328284476b"/>
-    <p:sldId xmlns:r="http://schemas.openxmlformats.org/officeDocument/2006/relationships" id="260" r:id="Rfd32deb4fd5745a0"/>
-    <p:sldId xmlns:r="http://schemas.openxmlformats.org/officeDocument/2006/relationships" id="261" r:id="R5c1b486e09d542ab"/>
-    <p:sldId xmlns:r="http://schemas.openxmlformats.org/officeDocument/2006/relationships" id="262" r:id="R79aad68f5c1445c8"/>
-    <p:sldId xmlns:r="http://schemas.openxmlformats.org/officeDocument/2006/relationships" id="263" r:id="R0dce26631d16493b"/>
+    <p:sldId xmlns:r="http://schemas.openxmlformats.org/officeDocument/2006/relationships" id="256" r:id="R4c41c8e1b7ab43c5"/>
+    <p:sldId xmlns:r="http://schemas.openxmlformats.org/officeDocument/2006/relationships" id="257" r:id="Ra7d9efd6d2a74074"/>
+    <p:sldId xmlns:r="http://schemas.openxmlformats.org/officeDocument/2006/relationships" id="258" r:id="Rfbba6f04b4dc4609"/>
+    <p:sldId xmlns:r="http://schemas.openxmlformats.org/officeDocument/2006/relationships" id="259" r:id="Rcd2f9dc96dea46af"/>
+    <p:sldId xmlns:r="http://schemas.openxmlformats.org/officeDocument/2006/relationships" id="260" r:id="Rcf00226a3c514bd1"/>
+    <p:sldId xmlns:r="http://schemas.openxmlformats.org/officeDocument/2006/relationships" id="261" r:id="R3ea4778ff67e4564"/>
+    <p:sldId xmlns:r="http://schemas.openxmlformats.org/officeDocument/2006/relationships" id="262" r:id="Rd97f4c489e4a41b4"/>
+    <p:sldId xmlns:r="http://schemas.openxmlformats.org/officeDocument/2006/relationships" id="263" r:id="R4a979595fb78475e"/>
   </p:sldIdLst>
   <p:sldSz cx="12192000" cy="6858000"/>
   <p:notesSz cx="6858000" cy="9144000"/>
@@ -945,7 +945,7 @@
           <a:lstStyle xmlns:a="http://schemas.openxmlformats.org/drawingml/2006/main"/>
           <a:p xmlns:a="http://schemas.openxmlformats.org/drawingml/2006/main">
             <a:r>
-              <a:t>The English UI shows ciphertexts on the service side and risk and model contributions on the hospital side. In the recorded local benchmark, all 2,000 decrypted integers matched the fixed-point reference and all three AUC values were 0.808. The 200-request local API median was 141 ms. These are historical local results, not LinuxONE results.</a:t>
+              <a:t>The English v2 protocol was measured at clean code commit 5412abe. All 2,000 stratified CDC decrypted integers matched the fixed-point reference, and all three ROC-AUC values were 0.808383. A separate 200-request synthetic benchmark against two local Docker containers matched every expected integer, with client p50 149.015 ms and p95 183.317 ms. The UI screenshot is actual local execution. These results do not establish LinuxONE execution. Evidence: submission/evidence/metrics/measurement_process_local-darwin-arm64_20261017T193517Z.json and measurement_api_local-darwin-arm64_20261017T194052Z.json.</a:t>
             </a:r>
             <a:endParaRPr/>
           </a:p>
@@ -1146,7 +1146,7 @@
     <p:bg>
       <p:bgPr>
         <a:blipFill xmlns:a="http://schemas.openxmlformats.org/drawingml/2006/main" rotWithShape="1">
-          <a:blip xmlns:r="http://schemas.openxmlformats.org/officeDocument/2006/relationships" r:embed="Re7405ff6571b4f28">
+          <a:blip xmlns:r="http://schemas.openxmlformats.org/officeDocument/2006/relationships" r:embed="R9d51ad565b834e14">
             <a:lum/>
           </a:blip>
           <a:srcRect l="0" t="0" r="0" b="0"/>
@@ -1268,7 +1268,7 @@
     <p:bg>
       <p:bgPr>
         <a:blipFill xmlns:a="http://schemas.openxmlformats.org/drawingml/2006/main" rotWithShape="1">
-          <a:blip xmlns:r="http://schemas.openxmlformats.org/officeDocument/2006/relationships" r:embed="R4324a05ea1f44157">
+          <a:blip xmlns:r="http://schemas.openxmlformats.org/officeDocument/2006/relationships" r:embed="R210abae570ab42a5">
             <a:lum/>
           </a:blip>
           <a:srcRect l="0" t="0" r="0" b="0"/>
@@ -1509,7 +1509,7 @@
     <p:bg>
       <p:bgPr>
         <a:blipFill xmlns:a="http://schemas.openxmlformats.org/drawingml/2006/main" rotWithShape="1">
-          <a:blip xmlns:r="http://schemas.openxmlformats.org/officeDocument/2006/relationships" r:embed="Rc6cefb3ebd374fca">
+          <a:blip xmlns:r="http://schemas.openxmlformats.org/officeDocument/2006/relationships" r:embed="R6f66afe1dc5e4ee4">
             <a:lum/>
           </a:blip>
           <a:srcRect l="0" t="0" r="0" b="0"/>
@@ -1809,10 +1809,10 @@
   </p:cSld>
   <p:clrMap bg1="lt1" tx1="dk1" bg2="lt2" tx2="dk2" accent1="accent1" accent2="accent2" accent3="accent3" accent4="accent4" accent5="accent5" accent6="accent6" hlink="hlink" folHlink="folHlink"/>
   <p:sldLayoutIdLst>
-    <p:sldLayoutId xmlns:r="http://schemas.openxmlformats.org/officeDocument/2006/relationships" id="2147483649" r:id="R3037ff13625e4b0b"/>
-    <p:sldLayoutId xmlns:r="http://schemas.openxmlformats.org/officeDocument/2006/relationships" id="2147483650" r:id="Re92944423c964e6b"/>
-    <p:sldLayoutId xmlns:r="http://schemas.openxmlformats.org/officeDocument/2006/relationships" id="2147483651" r:id="Rb79022fd319c49ad"/>
-    <p:sldLayoutId xmlns:r="http://schemas.openxmlformats.org/officeDocument/2006/relationships" id="2147483652" r:id="R6a02850678ad416b"/>
+    <p:sldLayoutId xmlns:r="http://schemas.openxmlformats.org/officeDocument/2006/relationships" id="2147483649" r:id="R2e3de372076c40de"/>
+    <p:sldLayoutId xmlns:r="http://schemas.openxmlformats.org/officeDocument/2006/relationships" id="2147483650" r:id="R3da4c93dd01b477e"/>
+    <p:sldLayoutId xmlns:r="http://schemas.openxmlformats.org/officeDocument/2006/relationships" id="2147483651" r:id="R89d2d20201544c88"/>
+    <p:sldLayoutId xmlns:r="http://schemas.openxmlformats.org/officeDocument/2006/relationships" id="2147483652" r:id="R9faf0da98a4f470c"/>
   </p:sldLayoutIdLst>
   <p:hf sldNum="0" hdr="0" ftr="0" dt="0"/>
   <p:txStyles>
@@ -2552,7 +2552,7 @@
           <p:cNvPr id="6" name="Logo del equipo">
             <a:extLst xmlns:a="http://schemas.openxmlformats.org/drawingml/2006/main">
               <a:ext uri="{FF2B5EF4-FFF2-40B4-BE49-F238E27FC236}">
-                <a16:creationId xmlns:a16="http://schemas.microsoft.com/office/drawing/2014/main" id="{335047DE-6699-4D7A-BAD8-83A381EA94F2}"/>
+                <a16:creationId xmlns:a16="http://schemas.microsoft.com/office/drawing/2014/main" id="{3E3EE22D-5363-4117-9FAB-AA16428FBBC4}"/>
               </a:ext>
             </a:extLst>
           </p:cNvPr>
@@ -2562,7 +2562,7 @@
           <p:nvPr/>
         </p:nvPicPr>
         <p:blipFill>
-          <a:blip xmlns:r="http://schemas.openxmlformats.org/officeDocument/2006/relationships" xmlns:a="http://schemas.openxmlformats.org/drawingml/2006/main" r:embed="R69005772e33e4e20"/>
+          <a:blip xmlns:r="http://schemas.openxmlformats.org/officeDocument/2006/relationships" xmlns:a="http://schemas.openxmlformats.org/drawingml/2006/main" r:embed="R2512758ef16c4a60"/>
           <a:stretch xmlns:a="http://schemas.openxmlformats.org/drawingml/2006/main">
             <a:fillRect l="0" t="0" r="0" b="0"/>
           </a:stretch>
@@ -3094,7 +3094,7 @@
           <p:cNvPr id="12" name="Hospital ícono">
             <a:extLst xmlns:a="http://schemas.openxmlformats.org/drawingml/2006/main">
               <a:ext uri="{FF2B5EF4-FFF2-40B4-BE49-F238E27FC236}">
-                <a16:creationId xmlns:a16="http://schemas.microsoft.com/office/drawing/2014/main" id="{9DE64134-4444-4FE3-9245-77FE1F176F3F}"/>
+                <a16:creationId xmlns:a16="http://schemas.microsoft.com/office/drawing/2014/main" id="{B7B67613-15D8-4EDE-BF01-3FBFEE487A22}"/>
               </a:ext>
             </a:extLst>
           </p:cNvPr>
@@ -3104,7 +3104,7 @@
           <p:nvPr/>
         </p:nvPicPr>
         <p:blipFill>
-          <a:blip xmlns:r="http://schemas.openxmlformats.org/officeDocument/2006/relationships" xmlns:a="http://schemas.openxmlformats.org/drawingml/2006/main" r:embed="R86ae21fcb9144afd"/>
+          <a:blip xmlns:r="http://schemas.openxmlformats.org/officeDocument/2006/relationships" xmlns:a="http://schemas.openxmlformats.org/drawingml/2006/main" r:embed="R8b09adff7fa84c3b"/>
           <a:stretch xmlns:a="http://schemas.openxmlformats.org/drawingml/2006/main">
             <a:fillRect l="0" t="0" r="0" b="0"/>
           </a:stretch>
@@ -3265,7 +3265,7 @@
           <p:cNvPr id="17" name="Compartir expedientes ícono">
             <a:extLst xmlns:a="http://schemas.openxmlformats.org/drawingml/2006/main">
               <a:ext uri="{FF2B5EF4-FFF2-40B4-BE49-F238E27FC236}">
-                <a16:creationId xmlns:a16="http://schemas.microsoft.com/office/drawing/2014/main" id="{F112610E-2842-4F29-82AA-A03600EBF380}"/>
+                <a16:creationId xmlns:a16="http://schemas.microsoft.com/office/drawing/2014/main" id="{DE2F0442-154C-45EE-B418-99DA4B694C90}"/>
               </a:ext>
             </a:extLst>
           </p:cNvPr>
@@ -3275,7 +3275,7 @@
           <p:nvPr/>
         </p:nvPicPr>
         <p:blipFill>
-          <a:blip xmlns:r="http://schemas.openxmlformats.org/officeDocument/2006/relationships" xmlns:a="http://schemas.openxmlformats.org/drawingml/2006/main" r:embed="R656d0ea82afd4340"/>
+          <a:blip xmlns:r="http://schemas.openxmlformats.org/officeDocument/2006/relationships" xmlns:a="http://schemas.openxmlformats.org/drawingml/2006/main" r:embed="Re11989c7aecc4f7c"/>
           <a:stretch xmlns:a="http://schemas.openxmlformats.org/drawingml/2006/main">
             <a:fillRect l="0" t="0" r="0" b="0"/>
           </a:stretch>
@@ -3479,7 +3479,7 @@
           <p:cNvPr id="23" name="No compartir ícono">
             <a:extLst xmlns:a="http://schemas.openxmlformats.org/drawingml/2006/main">
               <a:ext uri="{FF2B5EF4-FFF2-40B4-BE49-F238E27FC236}">
-                <a16:creationId xmlns:a16="http://schemas.microsoft.com/office/drawing/2014/main" id="{B130EA44-BEBD-4446-AEDC-25E82CCFECB1}"/>
+                <a16:creationId xmlns:a16="http://schemas.microsoft.com/office/drawing/2014/main" id="{78AD0739-A0EF-48C9-B30B-B0D711D1E72F}"/>
               </a:ext>
             </a:extLst>
           </p:cNvPr>
@@ -3489,7 +3489,7 @@
           <p:nvPr/>
         </p:nvPicPr>
         <p:blipFill>
-          <a:blip xmlns:r="http://schemas.openxmlformats.org/officeDocument/2006/relationships" xmlns:a="http://schemas.openxmlformats.org/drawingml/2006/main" r:embed="Rf6dc64105c4c468f"/>
+          <a:blip xmlns:r="http://schemas.openxmlformats.org/officeDocument/2006/relationships" xmlns:a="http://schemas.openxmlformats.org/drawingml/2006/main" r:embed="Rcaa9d11fdb7a42c0"/>
           <a:stretch xmlns:a="http://schemas.openxmlformats.org/drawingml/2006/main">
             <a:fillRect l="0" t="0" r="0" b="0"/>
           </a:stretch>
@@ -3937,7 +3937,7 @@
           <p:cNvPr id="6" name="1 · El hospital cifra ícono">
             <a:extLst xmlns:a="http://schemas.openxmlformats.org/drawingml/2006/main">
               <a:ext uri="{FF2B5EF4-FFF2-40B4-BE49-F238E27FC236}">
-                <a16:creationId xmlns:a16="http://schemas.microsoft.com/office/drawing/2014/main" id="{4F3B95D1-7384-440F-9887-12AFA67A8F1A}"/>
+                <a16:creationId xmlns:a16="http://schemas.microsoft.com/office/drawing/2014/main" id="{25448D37-156A-44B6-B281-2C9947F1824E}"/>
               </a:ext>
             </a:extLst>
           </p:cNvPr>
@@ -3947,7 +3947,7 @@
           <p:nvPr/>
         </p:nvPicPr>
         <p:blipFill>
-          <a:blip xmlns:r="http://schemas.openxmlformats.org/officeDocument/2006/relationships" xmlns:a="http://schemas.openxmlformats.org/drawingml/2006/main" r:embed="R5e70da04a00442ad"/>
+          <a:blip xmlns:r="http://schemas.openxmlformats.org/officeDocument/2006/relationships" xmlns:a="http://schemas.openxmlformats.org/drawingml/2006/main" r:embed="R0480be4919d245a0"/>
           <a:stretch xmlns:a="http://schemas.openxmlformats.org/drawingml/2006/main">
             <a:fillRect l="0" t="0" r="0" b="0"/>
           </a:stretch>
@@ -4149,7 +4149,7 @@
           <p:cNvPr id="12" name="2 · El servicio calcula ícono">
             <a:extLst xmlns:a="http://schemas.openxmlformats.org/drawingml/2006/main">
               <a:ext uri="{FF2B5EF4-FFF2-40B4-BE49-F238E27FC236}">
-                <a16:creationId xmlns:a16="http://schemas.microsoft.com/office/drawing/2014/main" id="{4E6A4633-A8D8-4C37-ADFF-A0A855797FF5}"/>
+                <a16:creationId xmlns:a16="http://schemas.microsoft.com/office/drawing/2014/main" id="{88B43C4A-CBA3-4C3C-9BFA-8FAFBA5FDD0E}"/>
               </a:ext>
             </a:extLst>
           </p:cNvPr>
@@ -4159,7 +4159,7 @@
           <p:nvPr/>
         </p:nvPicPr>
         <p:blipFill>
-          <a:blip xmlns:r="http://schemas.openxmlformats.org/officeDocument/2006/relationships" xmlns:a="http://schemas.openxmlformats.org/drawingml/2006/main" r:embed="Ree976779429747fe"/>
+          <a:blip xmlns:r="http://schemas.openxmlformats.org/officeDocument/2006/relationships" xmlns:a="http://schemas.openxmlformats.org/drawingml/2006/main" r:embed="Rd045707ac06e4402"/>
           <a:stretch xmlns:a="http://schemas.openxmlformats.org/drawingml/2006/main">
             <a:fillRect l="0" t="0" r="0" b="0"/>
           </a:stretch>
@@ -4361,7 +4361,7 @@
           <p:cNvPr id="18" name="3 · Regresa cifrado ícono">
             <a:extLst xmlns:a="http://schemas.openxmlformats.org/drawingml/2006/main">
               <a:ext uri="{FF2B5EF4-FFF2-40B4-BE49-F238E27FC236}">
-                <a16:creationId xmlns:a16="http://schemas.microsoft.com/office/drawing/2014/main" id="{61F89C84-5D07-4E2E-90E9-6D87EA4870EB}"/>
+                <a16:creationId xmlns:a16="http://schemas.microsoft.com/office/drawing/2014/main" id="{221680E6-2480-4D8B-A7FC-603E1C91E93A}"/>
               </a:ext>
             </a:extLst>
           </p:cNvPr>
@@ -4371,7 +4371,7 @@
           <p:nvPr/>
         </p:nvPicPr>
         <p:blipFill>
-          <a:blip xmlns:r="http://schemas.openxmlformats.org/officeDocument/2006/relationships" xmlns:a="http://schemas.openxmlformats.org/drawingml/2006/main" r:embed="Rbfa04f51c84f4da0"/>
+          <a:blip xmlns:r="http://schemas.openxmlformats.org/officeDocument/2006/relationships" xmlns:a="http://schemas.openxmlformats.org/drawingml/2006/main" r:embed="R52235260986d4f22"/>
           <a:stretch xmlns:a="http://schemas.openxmlformats.org/drawingml/2006/main">
             <a:fillRect l="0" t="0" r="0" b="0"/>
           </a:stretch>
@@ -4573,7 +4573,7 @@
           <p:cNvPr id="24" name="4 · Descifra y explica ícono">
             <a:extLst xmlns:a="http://schemas.openxmlformats.org/drawingml/2006/main">
               <a:ext uri="{FF2B5EF4-FFF2-40B4-BE49-F238E27FC236}">
-                <a16:creationId xmlns:a16="http://schemas.microsoft.com/office/drawing/2014/main" id="{6017BB93-C695-448C-ACFA-AA914BF51CEB}"/>
+                <a16:creationId xmlns:a16="http://schemas.microsoft.com/office/drawing/2014/main" id="{7893F19A-A2F4-4688-8CA3-7680B5563009}"/>
               </a:ext>
             </a:extLst>
           </p:cNvPr>
@@ -4583,7 +4583,7 @@
           <p:nvPr/>
         </p:nvPicPr>
         <p:blipFill>
-          <a:blip xmlns:r="http://schemas.openxmlformats.org/officeDocument/2006/relationships" xmlns:a="http://schemas.openxmlformats.org/drawingml/2006/main" r:embed="R6d804c2df7a342bd"/>
+          <a:blip xmlns:r="http://schemas.openxmlformats.org/officeDocument/2006/relationships" xmlns:a="http://schemas.openxmlformats.org/drawingml/2006/main" r:embed="Rf28b3604c72b4887"/>
           <a:stretch xmlns:a="http://schemas.openxmlformats.org/drawingml/2006/main">
             <a:fillRect l="0" t="0" r="0" b="0"/>
           </a:stretch>
@@ -4755,7 +4755,7 @@
           <p:cNvPr id="29" name="Solo cifrados ícono">
             <a:extLst xmlns:a="http://schemas.openxmlformats.org/drawingml/2006/main">
               <a:ext uri="{FF2B5EF4-FFF2-40B4-BE49-F238E27FC236}">
-                <a16:creationId xmlns:a16="http://schemas.microsoft.com/office/drawing/2014/main" id="{B2EF9D25-F621-4C47-81BB-CC7950144827}"/>
+                <a16:creationId xmlns:a16="http://schemas.microsoft.com/office/drawing/2014/main" id="{6904D59D-FF70-41C7-8471-BC633F795EB3}"/>
               </a:ext>
             </a:extLst>
           </p:cNvPr>
@@ -4765,7 +4765,7 @@
           <p:nvPr/>
         </p:nvPicPr>
         <p:blipFill>
-          <a:blip xmlns:r="http://schemas.openxmlformats.org/officeDocument/2006/relationships" xmlns:a="http://schemas.openxmlformats.org/drawingml/2006/main" r:embed="Re4713108cc88447d"/>
+          <a:blip xmlns:r="http://schemas.openxmlformats.org/officeDocument/2006/relationships" xmlns:a="http://schemas.openxmlformats.org/drawingml/2006/main" r:embed="R962af70b1b9f4768"/>
           <a:stretch xmlns:a="http://schemas.openxmlformats.org/drawingml/2006/main">
             <a:fillRect l="0" t="0" r="0" b="0"/>
           </a:stretch>
@@ -4937,7 +4937,7 @@
           <p:cNvPr id="34" name="Misma precisión ícono">
             <a:extLst xmlns:a="http://schemas.openxmlformats.org/drawingml/2006/main">
               <a:ext uri="{FF2B5EF4-FFF2-40B4-BE49-F238E27FC236}">
-                <a16:creationId xmlns:a16="http://schemas.microsoft.com/office/drawing/2014/main" id="{5B220F36-D6BD-4CF0-B315-08A98F66F8E8}"/>
+                <a16:creationId xmlns:a16="http://schemas.microsoft.com/office/drawing/2014/main" id="{6595A3D1-2FB0-437F-B7BB-F123A12E4F9E}"/>
               </a:ext>
             </a:extLst>
           </p:cNvPr>
@@ -4947,7 +4947,7 @@
           <p:nvPr/>
         </p:nvPicPr>
         <p:blipFill>
-          <a:blip xmlns:r="http://schemas.openxmlformats.org/officeDocument/2006/relationships" xmlns:a="http://schemas.openxmlformats.org/drawingml/2006/main" r:embed="R36227a4c38e04255"/>
+          <a:blip xmlns:r="http://schemas.openxmlformats.org/officeDocument/2006/relationships" xmlns:a="http://schemas.openxmlformats.org/drawingml/2006/main" r:embed="R33af8bd38ca04211"/>
           <a:stretch xmlns:a="http://schemas.openxmlformats.org/drawingml/2006/main">
             <a:fillRect l="0" t="0" r="0" b="0"/>
           </a:stretch>
@@ -5119,7 +5119,7 @@
           <p:cNvPr id="39" name="Tamizaje, no diagnóstico ícono">
             <a:extLst xmlns:a="http://schemas.openxmlformats.org/drawingml/2006/main">
               <a:ext uri="{FF2B5EF4-FFF2-40B4-BE49-F238E27FC236}">
-                <a16:creationId xmlns:a16="http://schemas.microsoft.com/office/drawing/2014/main" id="{DA860361-1A77-40E9-80A3-B8873D7F1B3C}"/>
+                <a16:creationId xmlns:a16="http://schemas.microsoft.com/office/drawing/2014/main" id="{B4BBFBE0-9CD7-48FD-936F-DCDB8D4E875D}"/>
               </a:ext>
             </a:extLst>
           </p:cNvPr>
@@ -5129,7 +5129,7 @@
           <p:nvPr/>
         </p:nvPicPr>
         <p:blipFill>
-          <a:blip xmlns:r="http://schemas.openxmlformats.org/officeDocument/2006/relationships" xmlns:a="http://schemas.openxmlformats.org/drawingml/2006/main" r:embed="R7404a57d67ee4d5f"/>
+          <a:blip xmlns:r="http://schemas.openxmlformats.org/officeDocument/2006/relationships" xmlns:a="http://schemas.openxmlformats.org/drawingml/2006/main" r:embed="Rb0d07e89e4fd49a4"/>
           <a:stretch xmlns:a="http://schemas.openxmlformats.org/drawingml/2006/main">
             <a:fillRect l="0" t="0" r="0" b="0"/>
           </a:stretch>
@@ -5807,7 +5807,7 @@
           <p:cNvPr id="12" name="En tránsito ícono">
             <a:extLst xmlns:a="http://schemas.openxmlformats.org/drawingml/2006/main">
               <a:ext uri="{FF2B5EF4-FFF2-40B4-BE49-F238E27FC236}">
-                <a16:creationId xmlns:a16="http://schemas.microsoft.com/office/drawing/2014/main" id="{3B936CD6-E243-4806-A8C2-1EF7ED126F7A}"/>
+                <a16:creationId xmlns:a16="http://schemas.microsoft.com/office/drawing/2014/main" id="{4EFE8591-DB7D-44D0-8831-D75B318C8412}"/>
               </a:ext>
             </a:extLst>
           </p:cNvPr>
@@ -5817,7 +5817,7 @@
           <p:nvPr/>
         </p:nvPicPr>
         <p:blipFill>
-          <a:blip xmlns:r="http://schemas.openxmlformats.org/officeDocument/2006/relationships" xmlns:a="http://schemas.openxmlformats.org/drawingml/2006/main" r:embed="R37a4abbe65dd464a"/>
+          <a:blip xmlns:r="http://schemas.openxmlformats.org/officeDocument/2006/relationships" xmlns:a="http://schemas.openxmlformats.org/drawingml/2006/main" r:embed="R0c03b34e40d34156"/>
           <a:stretch xmlns:a="http://schemas.openxmlformats.org/drawingml/2006/main">
             <a:fillRect l="0" t="0" r="0" b="0"/>
           </a:stretch>
@@ -5987,7 +5987,7 @@
           <p:cNvPr id="17" name="En reposo ícono">
             <a:extLst xmlns:a="http://schemas.openxmlformats.org/drawingml/2006/main">
               <a:ext uri="{FF2B5EF4-FFF2-40B4-BE49-F238E27FC236}">
-                <a16:creationId xmlns:a16="http://schemas.microsoft.com/office/drawing/2014/main" id="{9893E73B-8EB7-4D86-A06F-43AF2810EEF3}"/>
+                <a16:creationId xmlns:a16="http://schemas.microsoft.com/office/drawing/2014/main" id="{907F54FA-05E2-4474-B488-20ACF5529452}"/>
               </a:ext>
             </a:extLst>
           </p:cNvPr>
@@ -5997,7 +5997,7 @@
           <p:nvPr/>
         </p:nvPicPr>
         <p:blipFill>
-          <a:blip xmlns:r="http://schemas.openxmlformats.org/officeDocument/2006/relationships" xmlns:a="http://schemas.openxmlformats.org/drawingml/2006/main" r:embed="R1cec68eb66424305"/>
+          <a:blip xmlns:r="http://schemas.openxmlformats.org/officeDocument/2006/relationships" xmlns:a="http://schemas.openxmlformats.org/drawingml/2006/main" r:embed="Rd9d6ed8ecb0a4976"/>
           <a:stretch xmlns:a="http://schemas.openxmlformats.org/drawingml/2006/main">
             <a:fillRect l="0" t="0" r="0" b="0"/>
           </a:stretch>
@@ -6167,7 +6167,7 @@
           <p:cNvPr id="22" name="En uso ícono">
             <a:extLst xmlns:a="http://schemas.openxmlformats.org/drawingml/2006/main">
               <a:ext uri="{FF2B5EF4-FFF2-40B4-BE49-F238E27FC236}">
-                <a16:creationId xmlns:a16="http://schemas.microsoft.com/office/drawing/2014/main" id="{BF84971F-9714-477B-AE42-A0F66D64B5EB}"/>
+                <a16:creationId xmlns:a16="http://schemas.microsoft.com/office/drawing/2014/main" id="{3F066339-162E-4A3F-AB38-390803DC1B87}"/>
               </a:ext>
             </a:extLst>
           </p:cNvPr>
@@ -6177,7 +6177,7 @@
           <p:nvPr/>
         </p:nvPicPr>
         <p:blipFill>
-          <a:blip xmlns:r="http://schemas.openxmlformats.org/officeDocument/2006/relationships" xmlns:a="http://schemas.openxmlformats.org/drawingml/2006/main" r:embed="Rc28d656cd9f8478b"/>
+          <a:blip xmlns:r="http://schemas.openxmlformats.org/officeDocument/2006/relationships" xmlns:a="http://schemas.openxmlformats.org/drawingml/2006/main" r:embed="R02e3a590536443ec"/>
           <a:stretch xmlns:a="http://schemas.openxmlformats.org/drawingml/2006/main">
             <a:fillRect l="0" t="0" r="0" b="0"/>
           </a:stretch>
@@ -6326,7 +6326,7 @@
           <p:cNvPr id="26" name="Quién ve qué">
             <a:extLst xmlns:a="http://schemas.openxmlformats.org/drawingml/2006/main">
               <a:ext uri="{FF2B5EF4-FFF2-40B4-BE49-F238E27FC236}">
-                <a16:creationId xmlns:a16="http://schemas.microsoft.com/office/drawing/2014/main" id="{1150C1D5-F446-48B9-BCED-1598B3744405}"/>
+                <a16:creationId xmlns:a16="http://schemas.microsoft.com/office/drawing/2014/main" id="{41B6BB4C-AC98-493F-82FE-B292B9318992}"/>
               </a:ext>
             </a:extLst>
           </p:cNvPr>
@@ -7394,7 +7394,7 @@
           <p:cNvPr id="6" name="Clínicas ícono">
             <a:extLst xmlns:a="http://schemas.openxmlformats.org/drawingml/2006/main">
               <a:ext uri="{FF2B5EF4-FFF2-40B4-BE49-F238E27FC236}">
-                <a16:creationId xmlns:a16="http://schemas.microsoft.com/office/drawing/2014/main" id="{463E7860-9AD5-4515-A0F2-5BD2EF16C297}"/>
+                <a16:creationId xmlns:a16="http://schemas.microsoft.com/office/drawing/2014/main" id="{AFDD5863-681D-48EA-BA4A-A51E5F535046}"/>
               </a:ext>
             </a:extLst>
           </p:cNvPr>
@@ -7404,7 +7404,7 @@
           <p:nvPr/>
         </p:nvPicPr>
         <p:blipFill>
-          <a:blip xmlns:r="http://schemas.openxmlformats.org/officeDocument/2006/relationships" xmlns:a="http://schemas.openxmlformats.org/drawingml/2006/main" r:embed="R9d72d4337a69458f"/>
+          <a:blip xmlns:r="http://schemas.openxmlformats.org/officeDocument/2006/relationships" xmlns:a="http://schemas.openxmlformats.org/drawingml/2006/main" r:embed="Rc8076edebd7f466c"/>
           <a:stretch xmlns:a="http://schemas.openxmlformats.org/drawingml/2006/main">
             <a:fillRect l="0" t="0" r="0" b="0"/>
           </a:stretch>
@@ -7619,7 +7619,7 @@
           <p:cNvPr id="12" name="LinuxONE ícono">
             <a:extLst xmlns:a="http://schemas.openxmlformats.org/drawingml/2006/main">
               <a:ext uri="{FF2B5EF4-FFF2-40B4-BE49-F238E27FC236}">
-                <a16:creationId xmlns:a16="http://schemas.microsoft.com/office/drawing/2014/main" id="{DFBBE32B-C1FE-4242-9C61-E921C62673E4}"/>
+                <a16:creationId xmlns:a16="http://schemas.microsoft.com/office/drawing/2014/main" id="{8E1CC1AF-72CD-4FE1-B63B-2C6E9AF2A7BE}"/>
               </a:ext>
             </a:extLst>
           </p:cNvPr>
@@ -7629,7 +7629,7 @@
           <p:nvPr/>
         </p:nvPicPr>
         <p:blipFill>
-          <a:blip xmlns:r="http://schemas.openxmlformats.org/officeDocument/2006/relationships" xmlns:a="http://schemas.openxmlformats.org/drawingml/2006/main" r:embed="Rc0ae13d1cb374e45"/>
+          <a:blip xmlns:r="http://schemas.openxmlformats.org/officeDocument/2006/relationships" xmlns:a="http://schemas.openxmlformats.org/drawingml/2006/main" r:embed="R19f7f6f8d48d4e95"/>
           <a:stretch xmlns:a="http://schemas.openxmlformats.org/drawingml/2006/main">
             <a:fillRect l="0" t="0" r="0" b="0"/>
           </a:stretch>
@@ -8731,7 +8731,7 @@
           <p:cNvPr id="41" name="Cómputo pesado, en serio ícono">
             <a:extLst xmlns:a="http://schemas.openxmlformats.org/drawingml/2006/main">
               <a:ext uri="{FF2B5EF4-FFF2-40B4-BE49-F238E27FC236}">
-                <a16:creationId xmlns:a16="http://schemas.microsoft.com/office/drawing/2014/main" id="{1A3404E9-83F4-4F01-BF15-3204B28BF7F0}"/>
+                <a16:creationId xmlns:a16="http://schemas.microsoft.com/office/drawing/2014/main" id="{63CDD721-2FBE-43A8-BB56-532067A19453}"/>
               </a:ext>
             </a:extLst>
           </p:cNvPr>
@@ -8741,7 +8741,7 @@
           <p:nvPr/>
         </p:nvPicPr>
         <p:blipFill>
-          <a:blip xmlns:r="http://schemas.openxmlformats.org/officeDocument/2006/relationships" xmlns:a="http://schemas.openxmlformats.org/drawingml/2006/main" r:embed="R7a2acbddf8094521"/>
+          <a:blip xmlns:r="http://schemas.openxmlformats.org/officeDocument/2006/relationships" xmlns:a="http://schemas.openxmlformats.org/drawingml/2006/main" r:embed="R7d8d6fe6f9804d31"/>
           <a:stretch xmlns:a="http://schemas.openxmlformats.org/drawingml/2006/main">
             <a:fillRect l="0" t="0" r="0" b="0"/>
           </a:stretch>
@@ -8874,7 +8874,7 @@
           <p:cNvPr id="45" name="Aislamiento y cifrado ícono">
             <a:extLst xmlns:a="http://schemas.openxmlformats.org/drawingml/2006/main">
               <a:ext uri="{FF2B5EF4-FFF2-40B4-BE49-F238E27FC236}">
-                <a16:creationId xmlns:a16="http://schemas.microsoft.com/office/drawing/2014/main" id="{2CE1C10A-D836-43E8-9472-7D2D372A33D5}"/>
+                <a16:creationId xmlns:a16="http://schemas.microsoft.com/office/drawing/2014/main" id="{C6616B5D-E317-4C1B-9BBA-2CC630153FB6}"/>
               </a:ext>
             </a:extLst>
           </p:cNvPr>
@@ -8884,7 +8884,7 @@
           <p:nvPr/>
         </p:nvPicPr>
         <p:blipFill>
-          <a:blip xmlns:r="http://schemas.openxmlformats.org/officeDocument/2006/relationships" xmlns:a="http://schemas.openxmlformats.org/drawingml/2006/main" r:embed="R0905397fcb184773"/>
+          <a:blip xmlns:r="http://schemas.openxmlformats.org/officeDocument/2006/relationships" xmlns:a="http://schemas.openxmlformats.org/drawingml/2006/main" r:embed="Reef8e0352a304c81"/>
           <a:stretch xmlns:a="http://schemas.openxmlformats.org/drawingml/2006/main">
             <a:fillRect l="0" t="0" r="0" b="0"/>
           </a:stretch>
@@ -9017,7 +9017,7 @@
           <p:cNvPr id="49" name="Medido, no prometido ícono">
             <a:extLst xmlns:a="http://schemas.openxmlformats.org/drawingml/2006/main">
               <a:ext uri="{FF2B5EF4-FFF2-40B4-BE49-F238E27FC236}">
-                <a16:creationId xmlns:a16="http://schemas.microsoft.com/office/drawing/2014/main" id="{98E39BF0-63FE-4D7E-9E2D-4C1C7CEF69A9}"/>
+                <a16:creationId xmlns:a16="http://schemas.microsoft.com/office/drawing/2014/main" id="{2D115AE9-CFF9-4535-AC5D-C1FD1B2018FE}"/>
               </a:ext>
             </a:extLst>
           </p:cNvPr>
@@ -9027,7 +9027,7 @@
           <p:nvPr/>
         </p:nvPicPr>
         <p:blipFill>
-          <a:blip xmlns:r="http://schemas.openxmlformats.org/officeDocument/2006/relationships" xmlns:a="http://schemas.openxmlformats.org/drawingml/2006/main" r:embed="R98c10fae67824321"/>
+          <a:blip xmlns:r="http://schemas.openxmlformats.org/officeDocument/2006/relationships" xmlns:a="http://schemas.openxmlformats.org/drawingml/2006/main" r:embed="R59c16c90015f4d5f"/>
           <a:stretch xmlns:a="http://schemas.openxmlformats.org/drawingml/2006/main">
             <a:fillRect l="0" t="0" r="0" b="0"/>
           </a:stretch>
@@ -9337,7 +9337,7 @@
           <p:cNvPr id="4" name="Captura real de la demo">
             <a:extLst xmlns:a="http://schemas.openxmlformats.org/drawingml/2006/main">
               <a:ext uri="{FF2B5EF4-FFF2-40B4-BE49-F238E27FC236}">
-                <a16:creationId xmlns:a16="http://schemas.microsoft.com/office/drawing/2014/main" id="{008B5CC7-78EC-407B-A0E3-FC8B6BC40F2B}"/>
+                <a16:creationId xmlns:a16="http://schemas.microsoft.com/office/drawing/2014/main" id="{9791C1D6-1D0E-4261-BC3F-109D1A7DA917}"/>
               </a:ext>
             </a:extLst>
           </p:cNvPr>
@@ -9347,7 +9347,7 @@
           <p:nvPr/>
         </p:nvPicPr>
         <p:blipFill>
-          <a:blip xmlns:r="http://schemas.openxmlformats.org/officeDocument/2006/relationships" xmlns:a="http://schemas.openxmlformats.org/drawingml/2006/main" r:embed="R861481f7edbb45f1"/>
+          <a:blip xmlns:r="http://schemas.openxmlformats.org/officeDocument/2006/relationships" xmlns:a="http://schemas.openxmlformats.org/drawingml/2006/main" r:embed="Re50bd47dc23f4fbe"/>
           <a:stretch xmlns:a="http://schemas.openxmlformats.org/drawingml/2006/main"/>
         </p:blipFill>
         <p:spPr>
@@ -9466,7 +9466,7 @@
           <p:cNvPr id="8" name="2,000 de 2,000 ícono">
             <a:extLst xmlns:a="http://schemas.openxmlformats.org/drawingml/2006/main">
               <a:ext uri="{FF2B5EF4-FFF2-40B4-BE49-F238E27FC236}">
-                <a16:creationId xmlns:a16="http://schemas.microsoft.com/office/drawing/2014/main" id="{5765FD82-A536-4CDD-BF16-969653F11331}"/>
+                <a16:creationId xmlns:a16="http://schemas.microsoft.com/office/drawing/2014/main" id="{83EE3D52-7428-4BA5-94D8-80E06A68DC54}"/>
               </a:ext>
             </a:extLst>
           </p:cNvPr>
@@ -9476,7 +9476,7 @@
           <p:nvPr/>
         </p:nvPicPr>
         <p:blipFill>
-          <a:blip xmlns:r="http://schemas.openxmlformats.org/officeDocument/2006/relationships" xmlns:a="http://schemas.openxmlformats.org/drawingml/2006/main" r:embed="R810a6a31aa3e400e"/>
+          <a:blip xmlns:r="http://schemas.openxmlformats.org/officeDocument/2006/relationships" xmlns:a="http://schemas.openxmlformats.org/drawingml/2006/main" r:embed="R32ced3a6cefc4d7f"/>
           <a:stretch xmlns:a="http://schemas.openxmlformats.org/drawingml/2006/main">
             <a:fillRect l="0" t="0" r="0" b="0"/>
           </a:stretch>
@@ -9640,7 +9640,7 @@
           <p:cNvPr id="13" name="ROC-AUC 0.808 ícono">
             <a:extLst xmlns:a="http://schemas.openxmlformats.org/drawingml/2006/main">
               <a:ext uri="{FF2B5EF4-FFF2-40B4-BE49-F238E27FC236}">
-                <a16:creationId xmlns:a16="http://schemas.microsoft.com/office/drawing/2014/main" id="{A2DDA2EB-06B4-4851-BAAA-12A03D2477A5}"/>
+                <a16:creationId xmlns:a16="http://schemas.microsoft.com/office/drawing/2014/main" id="{80085199-5FD1-42CF-8586-4640A66E8539}"/>
               </a:ext>
             </a:extLst>
           </p:cNvPr>
@@ -9650,7 +9650,7 @@
           <p:nvPr/>
         </p:nvPicPr>
         <p:blipFill>
-          <a:blip xmlns:r="http://schemas.openxmlformats.org/officeDocument/2006/relationships" xmlns:a="http://schemas.openxmlformats.org/drawingml/2006/main" r:embed="Rc2eb216ab6b447b8"/>
+          <a:blip xmlns:r="http://schemas.openxmlformats.org/officeDocument/2006/relationships" xmlns:a="http://schemas.openxmlformats.org/drawingml/2006/main" r:embed="R5f5d1304621848b8"/>
           <a:stretch xmlns:a="http://schemas.openxmlformats.org/drawingml/2006/main">
             <a:fillRect l="0" t="0" r="0" b="0"/>
           </a:stretch>
@@ -9814,7 +9814,7 @@
           <p:cNvPr id="18" name="129 ms (p50) ícono">
             <a:extLst xmlns:a="http://schemas.openxmlformats.org/drawingml/2006/main">
               <a:ext uri="{FF2B5EF4-FFF2-40B4-BE49-F238E27FC236}">
-                <a16:creationId xmlns:a16="http://schemas.microsoft.com/office/drawing/2014/main" id="{81359516-5B01-4130-A6CD-59F22014468F}"/>
+                <a16:creationId xmlns:a16="http://schemas.microsoft.com/office/drawing/2014/main" id="{36FF8D49-4112-4026-A04C-128B1D92F464}"/>
               </a:ext>
             </a:extLst>
           </p:cNvPr>
@@ -9824,7 +9824,7 @@
           <p:nvPr/>
         </p:nvPicPr>
         <p:blipFill>
-          <a:blip xmlns:r="http://schemas.openxmlformats.org/officeDocument/2006/relationships" xmlns:a="http://schemas.openxmlformats.org/drawingml/2006/main" r:embed="Rb66977b74f2747fc"/>
+          <a:blip xmlns:r="http://schemas.openxmlformats.org/officeDocument/2006/relationships" xmlns:a="http://schemas.openxmlformats.org/drawingml/2006/main" r:embed="R5ef65c5779194fe7"/>
           <a:stretch xmlns:a="http://schemas.openxmlformats.org/drawingml/2006/main">
             <a:fillRect l="0" t="0" r="0" b="0"/>
           </a:stretch>
@@ -9876,7 +9876,7 @@
                   <a:schemeClr val="bg1"/>
                 </a:solidFill>
               </a:rPr>
-              <a:t>141 ms (p50)</a:t>
+              <a:t>149 ms (p50)</a:t>
             </a:r>
             <a:endParaRPr sz="1700"/>
           </a:p>
@@ -9988,7 +9988,7 @@
           <p:cNvPr id="23" name="26.8 KB → 1.4 KB ícono">
             <a:extLst xmlns:a="http://schemas.openxmlformats.org/drawingml/2006/main">
               <a:ext uri="{FF2B5EF4-FFF2-40B4-BE49-F238E27FC236}">
-                <a16:creationId xmlns:a16="http://schemas.microsoft.com/office/drawing/2014/main" id="{846666A8-EF27-445E-9C2A-A2DAF5AE7D59}"/>
+                <a16:creationId xmlns:a16="http://schemas.microsoft.com/office/drawing/2014/main" id="{7F3D9260-3149-442F-8770-3F62B522D0F1}"/>
               </a:ext>
             </a:extLst>
           </p:cNvPr>
@@ -9998,7 +9998,7 @@
           <p:nvPr/>
         </p:nvPicPr>
         <p:blipFill>
-          <a:blip xmlns:r="http://schemas.openxmlformats.org/officeDocument/2006/relationships" xmlns:a="http://schemas.openxmlformats.org/drawingml/2006/main" r:embed="Rf2537821b9c445ed"/>
+          <a:blip xmlns:r="http://schemas.openxmlformats.org/officeDocument/2006/relationships" xmlns:a="http://schemas.openxmlformats.org/drawingml/2006/main" r:embed="R4baf8ec1ec68463f"/>
           <a:stretch xmlns:a="http://schemas.openxmlformats.org/drawingml/2006/main">
             <a:fillRect l="0" t="0" r="0" b="0"/>
           </a:stretch>
@@ -10136,7 +10136,7 @@
                   <a:schemeClr val="accent4"/>
                 </a:solidFill>
               </a:rPr>
-              <a:t>Historical LOCAL benchmark, clean commit 65ae4ef, macOS arm64 / Docker, 2048-bit key. Not LinuxONE. Repeat on the VM with make measure-api-docker.</a:t>
+              <a:t>LOCAL English benchmark · commit 5412abe · macOS arm64 / Docker · 2048-bit key. API p95: 183 ms. LinuxONE run pending; repeat with make measure-api-docker.</a:t>
             </a:r>
             <a:endParaRPr sz="1000"/>
           </a:p>
@@ -11479,7 +11479,7 @@
           <p:cNvPr id="35" name="Métricas ícono">
             <a:extLst xmlns:a="http://schemas.openxmlformats.org/drawingml/2006/main">
               <a:ext uri="{FF2B5EF4-FFF2-40B4-BE49-F238E27FC236}">
-                <a16:creationId xmlns:a16="http://schemas.microsoft.com/office/drawing/2014/main" id="{8897FAD1-FDFA-4A8E-BE0E-B349C99B5233}"/>
+                <a16:creationId xmlns:a16="http://schemas.microsoft.com/office/drawing/2014/main" id="{93A76CF4-6837-4974-9A8F-11030472E5D5}"/>
               </a:ext>
             </a:extLst>
           </p:cNvPr>
@@ -11489,7 +11489,7 @@
           <p:nvPr/>
         </p:nvPicPr>
         <p:blipFill>
-          <a:blip xmlns:r="http://schemas.openxmlformats.org/officeDocument/2006/relationships" xmlns:a="http://schemas.openxmlformats.org/drawingml/2006/main" r:embed="R73d1fa03f9e74823"/>
+          <a:blip xmlns:r="http://schemas.openxmlformats.org/officeDocument/2006/relationships" xmlns:a="http://schemas.openxmlformats.org/drawingml/2006/main" r:embed="Rfc0de45e0c384224"/>
           <a:stretch xmlns:a="http://schemas.openxmlformats.org/drawingml/2006/main">
             <a:fillRect l="0" t="0" r="0" b="0"/>
           </a:stretch>
@@ -11661,7 +11661,7 @@
           <p:cNvPr id="40" name="Límites ícono">
             <a:extLst xmlns:a="http://schemas.openxmlformats.org/drawingml/2006/main">
               <a:ext uri="{FF2B5EF4-FFF2-40B4-BE49-F238E27FC236}">
-                <a16:creationId xmlns:a16="http://schemas.microsoft.com/office/drawing/2014/main" id="{8E0E2B16-D75E-421B-B36C-7350C51D7019}"/>
+                <a16:creationId xmlns:a16="http://schemas.microsoft.com/office/drawing/2014/main" id="{095FC878-48BA-4748-B77E-322C211299C6}"/>
               </a:ext>
             </a:extLst>
           </p:cNvPr>
@@ -11671,7 +11671,7 @@
           <p:nvPr/>
         </p:nvPicPr>
         <p:blipFill>
-          <a:blip xmlns:r="http://schemas.openxmlformats.org/officeDocument/2006/relationships" xmlns:a="http://schemas.openxmlformats.org/drawingml/2006/main" r:embed="R16761cfbf72d4685"/>
+          <a:blip xmlns:r="http://schemas.openxmlformats.org/officeDocument/2006/relationships" xmlns:a="http://schemas.openxmlformats.org/drawingml/2006/main" r:embed="R8e1cb59c3188473c"/>
           <a:stretch xmlns:a="http://schemas.openxmlformats.org/drawingml/2006/main">
             <a:fillRect l="0" t="0" r="0" b="0"/>
           </a:stretch>
@@ -12045,7 +12045,7 @@
           <p:cNvPr id="6" name="Tamizaje temprano ícono">
             <a:extLst xmlns:a="http://schemas.openxmlformats.org/drawingml/2006/main">
               <a:ext uri="{FF2B5EF4-FFF2-40B4-BE49-F238E27FC236}">
-                <a16:creationId xmlns:a16="http://schemas.microsoft.com/office/drawing/2014/main" id="{E3C4774E-825B-47D7-86DE-DF6257B62681}"/>
+                <a16:creationId xmlns:a16="http://schemas.microsoft.com/office/drawing/2014/main" id="{842846B2-A9ED-4740-82D3-AA1584DE3FE6}"/>
               </a:ext>
             </a:extLst>
           </p:cNvPr>
@@ -12055,7 +12055,7 @@
           <p:nvPr/>
         </p:nvPicPr>
         <p:blipFill>
-          <a:blip xmlns:r="http://schemas.openxmlformats.org/officeDocument/2006/relationships" xmlns:a="http://schemas.openxmlformats.org/drawingml/2006/main" r:embed="Ra49c414f7efa4182"/>
+          <a:blip xmlns:r="http://schemas.openxmlformats.org/officeDocument/2006/relationships" xmlns:a="http://schemas.openxmlformats.org/drawingml/2006/main" r:embed="Rbb42b58a464b4117"/>
           <a:stretch xmlns:a="http://schemas.openxmlformats.org/drawingml/2006/main">
             <a:fillRect l="0" t="0" r="0" b="0"/>
           </a:stretch>
@@ -12225,7 +12225,7 @@
           <p:cNvPr id="11" name="Confianza del paciente ícono">
             <a:extLst xmlns:a="http://schemas.openxmlformats.org/drawingml/2006/main">
               <a:ext uri="{FF2B5EF4-FFF2-40B4-BE49-F238E27FC236}">
-                <a16:creationId xmlns:a16="http://schemas.microsoft.com/office/drawing/2014/main" id="{8558E805-C27D-48D9-90F4-B317AD348A2F}"/>
+                <a16:creationId xmlns:a16="http://schemas.microsoft.com/office/drawing/2014/main" id="{B28A71B4-7A1A-4EE3-A477-9AE6255FE8CA}"/>
               </a:ext>
             </a:extLst>
           </p:cNvPr>
@@ -12235,7 +12235,7 @@
           <p:nvPr/>
         </p:nvPicPr>
         <p:blipFill>
-          <a:blip xmlns:r="http://schemas.openxmlformats.org/officeDocument/2006/relationships" xmlns:a="http://schemas.openxmlformats.org/drawingml/2006/main" r:embed="R300656ff65ef487f"/>
+          <a:blip xmlns:r="http://schemas.openxmlformats.org/officeDocument/2006/relationships" xmlns:a="http://schemas.openxmlformats.org/drawingml/2006/main" r:embed="R9d700b5c90a5434b"/>
           <a:stretch xmlns:a="http://schemas.openxmlformats.org/drawingml/2006/main">
             <a:fillRect l="0" t="0" r="0" b="0"/>
           </a:stretch>
@@ -12405,7 +12405,7 @@
           <p:cNvPr id="16" name="Cumplimiento ícono">
             <a:extLst xmlns:a="http://schemas.openxmlformats.org/drawingml/2006/main">
               <a:ext uri="{FF2B5EF4-FFF2-40B4-BE49-F238E27FC236}">
-                <a16:creationId xmlns:a16="http://schemas.microsoft.com/office/drawing/2014/main" id="{F90DAFF4-3C0B-460A-83FA-7D6A8E8B9354}"/>
+                <a16:creationId xmlns:a16="http://schemas.microsoft.com/office/drawing/2014/main" id="{5B791091-AADC-4830-8D66-FF8A3D965272}"/>
               </a:ext>
             </a:extLst>
           </p:cNvPr>
@@ -12415,7 +12415,7 @@
           <p:nvPr/>
         </p:nvPicPr>
         <p:blipFill>
-          <a:blip xmlns:r="http://schemas.openxmlformats.org/officeDocument/2006/relationships" xmlns:a="http://schemas.openxmlformats.org/drawingml/2006/main" r:embed="R53d77707011540b3"/>
+          <a:blip xmlns:r="http://schemas.openxmlformats.org/officeDocument/2006/relationships" xmlns:a="http://schemas.openxmlformats.org/drawingml/2006/main" r:embed="Rd74a1ad0632b4195"/>
           <a:stretch xmlns:a="http://schemas.openxmlformats.org/drawingml/2006/main">
             <a:fillRect l="0" t="0" r="0" b="0"/>
           </a:stretch>
@@ -12585,7 +12585,7 @@
           <p:cNvPr id="21" name="Escalable ícono">
             <a:extLst xmlns:a="http://schemas.openxmlformats.org/drawingml/2006/main">
               <a:ext uri="{FF2B5EF4-FFF2-40B4-BE49-F238E27FC236}">
-                <a16:creationId xmlns:a16="http://schemas.microsoft.com/office/drawing/2014/main" id="{7F54B95C-1D55-4C9A-B9DD-C7A388259F44}"/>
+                <a16:creationId xmlns:a16="http://schemas.microsoft.com/office/drawing/2014/main" id="{C8FBFAC5-0FEF-422E-9B96-3D3813E55277}"/>
               </a:ext>
             </a:extLst>
           </p:cNvPr>
@@ -12595,7 +12595,7 @@
           <p:nvPr/>
         </p:nvPicPr>
         <p:blipFill>
-          <a:blip xmlns:r="http://schemas.openxmlformats.org/officeDocument/2006/relationships" xmlns:a="http://schemas.openxmlformats.org/drawingml/2006/main" r:embed="R9946fb13674e4bed"/>
+          <a:blip xmlns:r="http://schemas.openxmlformats.org/officeDocument/2006/relationships" xmlns:a="http://schemas.openxmlformats.org/drawingml/2006/main" r:embed="R1128623a77c942f6"/>
           <a:stretch xmlns:a="http://schemas.openxmlformats.org/drawingml/2006/main">
             <a:fillRect l="0" t="0" r="0" b="0"/>
           </a:stretch>
@@ -12744,7 +12744,7 @@
           <p:cNvPr id="25" name="Logo del equipo">
             <a:extLst xmlns:a="http://schemas.openxmlformats.org/drawingml/2006/main">
               <a:ext uri="{FF2B5EF4-FFF2-40B4-BE49-F238E27FC236}">
-                <a16:creationId xmlns:a16="http://schemas.microsoft.com/office/drawing/2014/main" id="{FB215373-3D4A-486F-95C0-C7C127857E24}"/>
+                <a16:creationId xmlns:a16="http://schemas.microsoft.com/office/drawing/2014/main" id="{92AAD7F1-F334-4B52-A99A-8D95E4CAA746}"/>
               </a:ext>
             </a:extLst>
           </p:cNvPr>
@@ -12754,7 +12754,7 @@
           <p:nvPr/>
         </p:nvPicPr>
         <p:blipFill>
-          <a:blip xmlns:r="http://schemas.openxmlformats.org/officeDocument/2006/relationships" xmlns:a="http://schemas.openxmlformats.org/drawingml/2006/main" r:embed="R9f6663e23d7140ac"/>
+          <a:blip xmlns:r="http://schemas.openxmlformats.org/officeDocument/2006/relationships" xmlns:a="http://schemas.openxmlformats.org/drawingml/2006/main" r:embed="Ra98a0e4ab5184d91"/>
           <a:stretch xmlns:a="http://schemas.openxmlformats.org/drawingml/2006/main">
             <a:fillRect l="0" t="0" r="0" b="0"/>
           </a:stretch>

</xml_diff>

<commit_message>
deck: regenerate pitch, PDF, site slides and flowchart for cdc19-v1
- Slides 3, 6 and 7 and speaker notes: 19 indicators/ciphertexts, test ROC-AUC 0.825, local
  benchmark at be9b27e (2,000/2,000 exact, AUC 0.807, API p50 115 ms / p95 118 ms, 24.3 KB).
- New UI capture of synthetic C (63.3%, logistic-cdc19-v1) on slide 6 and as local evidence.
- PDF and the eight site slide images re-rendered from the edited PPTX; cache tag cdc19-27.
- Flowchart SVG/PNG/PDF: cdc19-v1 schema, 19 ciphertexts (~24 KB), logit bound 9.55e-8.
- status.json rev 38.
</commit_message>
<xml_diff>
--- a/submission/Los_Antimarrulla_Screening_Pitch.pptx
+++ b/submission/Los_Antimarrulla_Screening_Pitch.pptx
@@ -732,7 +732,7 @@
           <a:lstStyle xmlns:a="http://schemas.openxmlformats.org/drawingml/2006/main"/>
           <a:p xmlns:a="http://schemas.openxmlformats.org/drawingml/2006/main">
             <a:r>
-              <a:t>The hospital encrypts the 21 indicators and retains the private key. The service evaluates ciphertexts. Only the hospital decrypts and displays the risk and feature contributions. This is screening support, not diagnosis. The same-VM administrator remains trusted; demonstration patients are synthetic.</a:t>
+              <a:t>The hospital encrypts the 19 indicators and retains the private key. The service evaluates ciphertexts. Only the hospital decrypts and displays the risk and feature contributions. This is screening support, not diagnosis. The same-VM administrator remains trusted; demonstration patients are synthetic.</a:t>
             </a:r>
             <a:endParaRPr/>
           </a:p>
@@ -945,7 +945,7 @@
           <a:lstStyle xmlns:a="http://schemas.openxmlformats.org/drawingml/2006/main"/>
           <a:p xmlns:a="http://schemas.openxmlformats.org/drawingml/2006/main">
             <a:r>
-              <a:t>The English v2 protocol was measured at clean code commit 5412abe. All 2,000 stratified CDC decrypted integers matched the fixed-point reference, and all three ROC-AUC values were 0.808383. A separate 200-request synthetic benchmark against two local Docker containers matched every expected integer, with client p50 149.015 ms and p95 183.317 ms. The UI screenshot is actual local execution. These results do not establish LinuxONE execution. Evidence: submission/evidence/metrics/measurement_process_local-darwin-arm64_20261017T193517Z.json and measurement_api_local-darwin-arm64_20261017T194052Z.json.</a:t>
+              <a:t>The 19-feature model logistic-cdc19-v1 was measured at clean commit be9b27e. All 2,000 stratified CDC decrypted integers matched the fixed-point reference, and all three ROC-AUC values were 0.806525. A separate 200-request synthetic benchmark against two local Docker containers matched every expected integer, with client p50 114.8 ms and p95 118.2 ms; requests carry 19 ciphertexts (24.3 KB). The UI screenshot is actual local execution of synthetic profile C (63.3%). These results do not establish LinuxONE execution. Evidence: submission/evidence/metrics/measurement_process_local-darwin-arm64_20261018T030142Z.json and measurement_api_local-darwin-arm64_20261018T030546Z.json.</a:t>
             </a:r>
             <a:endParaRPr/>
           </a:p>
@@ -1016,7 +1016,7 @@
           <a:lstStyle xmlns:a="http://schemas.openxmlformats.org/drawingml/2006/main"/>
           <a:p xmlns:a="http://schemas.openxmlformats.org/drawingml/2006/main">
             <a:r>
-              <a:t>The public-data model reaches test AUC 0.826 and sensitivity 0.805 at a validation-selected threshold. This predicts the survey label, not future diabetes or mortality. A separate reduced model evaluated on ENSANUT reaches AUC around 0.77 and underestimates risk; it does not validate the MVP for Mexican clinical use.</a:t>
+              <a:t>The public-data model reaches test AUC 0.825 and sensitivity 0.807 with 19 features (Education and Income removed) at a validation-selected threshold. This predicts the survey label, not future diabetes or mortality. A separate reduced model evaluated on ENSANUT reaches AUC around 0.77 and underestimates risk; it does not validate the MVP for Mexican clinical use.</a:t>
             </a:r>
             <a:endParaRPr/>
           </a:p>
@@ -4042,7 +4042,7 @@
                   <a:schemeClr val="bg2"/>
                 </a:solidFill>
               </a:rPr>
-              <a:t>Encrypt all 21 indicators; retain the private key at the hospital</a:t>
+              <a:t>Encrypt all 19 indicators; retain the private key at the hospital</a:t>
             </a:r>
             <a:endParaRPr sz="1200"/>
           </a:p>
@@ -9579,7 +9579,7 @@
       </p:sp>
       <p:sp>
         <p:nvSpPr>
-          <p:cNvPr id="11" name="ROC-AUC 0.808">
+          <p:cNvPr id="11" name="ROC-AUC 0.807">
             <a:extLst xmlns:a="http://schemas.openxmlformats.org/drawingml/2006/main">
               <a:ext uri="{FF2B5EF4-FFF2-40B4-BE49-F238E27FC236}">
                 <a16:creationId xmlns:a16="http://schemas.microsoft.com/office/drawing/2014/main" id="{37D825E5-7C1D-48C8-9B91-B337403F2C6D}"/>
@@ -9610,7 +9610,7 @@
       </p:sp>
       <p:sp>
         <p:nvSpPr>
-          <p:cNvPr id="12" name="ROC-AUC 0.808 círculo">
+          <p:cNvPr id="12" name="ROC-AUC 0.807 círculo">
             <a:extLst xmlns:a="http://schemas.openxmlformats.org/drawingml/2006/main">
               <a:ext uri="{FF2B5EF4-FFF2-40B4-BE49-F238E27FC236}">
                 <a16:creationId xmlns:a16="http://schemas.microsoft.com/office/drawing/2014/main" id="{E00F4279-DA0D-497A-9FDF-78FC0146727F}"/>
@@ -9637,7 +9637,7 @@
       </p:sp>
       <p:pic>
         <p:nvPicPr>
-          <p:cNvPr id="13" name="ROC-AUC 0.808 ícono">
+          <p:cNvPr id="13" name="ROC-AUC 0.807 ícono">
             <a:extLst xmlns:a="http://schemas.openxmlformats.org/drawingml/2006/main">
               <a:ext uri="{FF2B5EF4-FFF2-40B4-BE49-F238E27FC236}">
                 <a16:creationId xmlns:a16="http://schemas.microsoft.com/office/drawing/2014/main" id="{80085199-5FD1-42CF-8586-4640A66E8539}"/>
@@ -9702,7 +9702,7 @@
                   <a:schemeClr val="bg1"/>
                 </a:solidFill>
               </a:rPr>
-              <a:t>ROC-AUC 0.808</a:t>
+              <a:t>ROC-AUC 0.807</a:t>
             </a:r>
             <a:endParaRPr sz="1700"/>
           </a:p>
@@ -9876,7 +9876,7 @@
                   <a:schemeClr val="bg1"/>
                 </a:solidFill>
               </a:rPr>
-              <a:t>149 ms (p50)</a:t>
+              <a:t>115 ms (p50)</a:t>
             </a:r>
             <a:endParaRPr sz="1700"/>
           </a:p>
@@ -9927,7 +9927,7 @@
       </p:sp>
       <p:sp>
         <p:nvSpPr>
-          <p:cNvPr id="21" name="26.8 KB → 1.4 KB">
+          <p:cNvPr id="21" name="24.3 KB → 1.4 KB">
             <a:extLst xmlns:a="http://schemas.openxmlformats.org/drawingml/2006/main">
               <a:ext uri="{FF2B5EF4-FFF2-40B4-BE49-F238E27FC236}">
                 <a16:creationId xmlns:a16="http://schemas.microsoft.com/office/drawing/2014/main" id="{60C7EE51-4110-4BD6-AA06-1022932EF1C0}"/>
@@ -9958,7 +9958,7 @@
       </p:sp>
       <p:sp>
         <p:nvSpPr>
-          <p:cNvPr id="22" name="26.8 KB → 1.4 KB círculo">
+          <p:cNvPr id="22" name="24.3 KB → 1.4 KB círculo">
             <a:extLst xmlns:a="http://schemas.openxmlformats.org/drawingml/2006/main">
               <a:ext uri="{FF2B5EF4-FFF2-40B4-BE49-F238E27FC236}">
                 <a16:creationId xmlns:a16="http://schemas.microsoft.com/office/drawing/2014/main" id="{41095B4A-AE0B-4A0C-B98C-4EBB205BBFA6}"/>
@@ -9985,7 +9985,7 @@
       </p:sp>
       <p:pic>
         <p:nvPicPr>
-          <p:cNvPr id="23" name="26.8 KB → 1.4 KB ícono">
+          <p:cNvPr id="23" name="24.3 KB → 1.4 KB ícono">
             <a:extLst xmlns:a="http://schemas.openxmlformats.org/drawingml/2006/main">
               <a:ext uri="{FF2B5EF4-FFF2-40B4-BE49-F238E27FC236}">
                 <a16:creationId xmlns:a16="http://schemas.microsoft.com/office/drawing/2014/main" id="{7F3D9260-3149-442F-8770-3F62B522D0F1}"/>
@@ -10050,7 +10050,7 @@
                   <a:schemeClr val="bg1"/>
                 </a:solidFill>
               </a:rPr>
-              <a:t>26.8 KB → 1.4 KB</a:t>
+              <a:t>24.3 KB → 1.4 KB</a:t>
             </a:r>
             <a:endParaRPr sz="1700"/>
           </a:p>
@@ -10093,7 +10093,7 @@
                   <a:schemeClr val="bg2"/>
                 </a:solidFill>
               </a:rPr>
-              <a:t>21 input ciphertexts → one encrypted score</a:t>
+              <a:t>19 input ciphertexts → one encrypted score</a:t>
             </a:r>
             <a:endParaRPr sz="1100"/>
           </a:p>
@@ -10136,7 +10136,7 @@
                   <a:schemeClr val="accent4"/>
                 </a:solidFill>
               </a:rPr>
-              <a:t>LOCAL English benchmark · commit 5412abe · macOS arm64 / Docker · 2048-bit key. API p95: 183 ms. LinuxONE run pending; repeat with make measure-api-docker.</a:t>
+              <a:t>LOCAL benchmark · model logistic-cdc19-v1 · commit be9b27e · macOS arm64 / Docker · 2048-bit key. API p95: 118 ms. LinuxONE run pending; repeat with make measure-api-docker.</a:t>
             </a:r>
             <a:endParaRPr sz="1000"/>
           </a:p>
@@ -10484,7 +10484,7 @@
                   <a:schemeClr val="accent5"/>
                 </a:solidFill>
               </a:rPr>
-              <a:t>21</a:t>
+              <a:t>19</a:t>
             </a:r>
             <a:endParaRPr sz="3000"/>
           </a:p>
@@ -10527,7 +10527,7 @@
                   <a:schemeClr val="bg2"/>
                 </a:solidFill>
               </a:rPr>
-              <a:t>indicators: BMI, blood pressure, cholesterol, physical activity, age…</a:t>
+              <a:t>indicators: BMI, blood pressure, cholesterol, activity, age… (Education and Income removed)</a:t>
             </a:r>
             <a:endParaRPr sz="1100"/>
           </a:p>
@@ -11016,7 +11016,7 @@
                   <a:schemeClr val="bg2"/>
                 </a:solidFill>
               </a:rPr>
-              <a:t>Round weights × 10⁹; all 21 inputs are already integers</a:t>
+              <a:t>Round weights × 10⁹; all 19 inputs are already integers</a:t>
             </a:r>
             <a:endParaRPr sz="1200"/>
           </a:p>
@@ -11203,7 +11203,7 @@
                   <a:schemeClr val="bg2"/>
                 </a:solidFill>
               </a:rPr>
-              <a:t>Encrypt 21 indicators using the hospital’s key</a:t>
+              <a:t>Encrypt 19 indicators using the hospital’s key</a:t>
             </a:r>
             <a:endParaRPr sz="1200"/>
           </a:p>
@@ -11584,7 +11584,7 @@
                   <a:schemeClr val="bg2"/>
                 </a:solidFill>
               </a:rPr>
-              <a:t>ROC-AUC 0.826 · AP 0.415 · sensitivity 0.805 · specificity 0.691 · PPV 0.297 · Brier 0.098. Threshold selected on validation.</a:t>
+              <a:t>ROC-AUC 0.825 · AP 0.414 · sensitivity 0.807 · specificity 0.689 · PPV 0.296 · Brier 0.098. Threshold selected on validation.</a:t>
             </a:r>
             <a:endParaRPr sz="1200"/>
           </a:p>

</xml_diff>

<commit_message>
deck: ten-slide presentation with the time-series forecast and the roadmap
- New slide 8: live forecast dashboard (222 weekly SINAVE series, 52 weeks, nested SMAPE,
  exploratory bands, sourced-cost budgets) with speaker notes.
- New slide 9: roadmap (Oct 2026 MVP and LinuxONE evidence runs, Q1 2027 Mexico recalibration,
  Q2 2027 hospital pilot, Q4 2027 CKKS/Granite/forecasts on LinuxONE), partners and clinical gates.
- Slide 6 uses a fresh capture of the current Hospital UI (synthetic C, 63.3%).
- PDF, ten site slide images, carousel, slide text, PITCH timings (169 s), SLIDES and runbook updated.
</commit_message>
<xml_diff>
--- a/submission/Los_Antimarrulla_Screening_Pitch.pptx
+++ b/submission/Los_Antimarrulla_Screening_Pitch.pptx
@@ -15,6 +15,8 @@
     <p:sldId xmlns:r="http://schemas.openxmlformats.org/officeDocument/2006/relationships" id="260" r:id="Rcf00226a3c514bd1"/>
     <p:sldId xmlns:r="http://schemas.openxmlformats.org/officeDocument/2006/relationships" id="261" r:id="R3ea4778ff67e4564"/>
     <p:sldId xmlns:r="http://schemas.openxmlformats.org/officeDocument/2006/relationships" id="262" r:id="Rd97f4c489e4a41b4"/>
+    <p:sldId xmlns:r="http://schemas.openxmlformats.org/officeDocument/2006/relationships" id="264" r:id="rId1"/>
+    <p:sldId xmlns:r="http://schemas.openxmlformats.org/officeDocument/2006/relationships" id="265" r:id="rId2"/>
     <p:sldId xmlns:r="http://schemas.openxmlformats.org/officeDocument/2006/relationships" id="263" r:id="R4a979595fb78475e"/>
   </p:sldIdLst>
   <p:sldSz cx="12192000" cy="6858000"/>
@@ -621,6 +623,77 @@
 </p:notes>
 </file>
 
+<file path=ppt/notesSlides/notesSlide10.xml><?xml version="1.0" encoding="utf-8"?>
+<p:notes xmlns:p="http://schemas.openxmlformats.org/presentationml/2006/main">
+  <p:cSld>
+    <p:spTree>
+      <p:nvGrpSpPr>
+        <p:cNvPr id="1" name=""/>
+        <p:cNvGrpSpPr/>
+        <p:nvPr/>
+      </p:nvGrpSpPr>
+      <p:grpSpPr>
+        <a:xfrm xmlns:a="http://schemas.openxmlformats.org/drawingml/2006/main"/>
+      </p:grpSpPr>
+      <p:sp>
+        <p:nvSpPr>
+          <p:cNvPr id="2" name="Slide Image Placeholder 1"/>
+          <p:cNvSpPr>
+            <a:spLocks xmlns:a="http://schemas.openxmlformats.org/drawingml/2006/main" noGrp="1"/>
+          </p:cNvSpPr>
+          <p:nvPr>
+            <p:ph type="sldImg" idx="0"/>
+          </p:nvPr>
+        </p:nvSpPr>
+        <p:spPr/>
+      </p:sp>
+      <p:sp>
+        <p:nvSpPr>
+          <p:cNvPr id="3" name="Notes Placeholder 2"/>
+          <p:cNvSpPr>
+            <a:spLocks xmlns:a="http://schemas.openxmlformats.org/drawingml/2006/main" noGrp="1"/>
+          </p:cNvSpPr>
+          <p:nvPr>
+            <p:ph type="body" idx="1"/>
+          </p:nvPr>
+        </p:nvSpPr>
+        <p:spPr/>
+        <p:txBody>
+          <a:bodyPr xmlns:a="http://schemas.openxmlformats.org/drawingml/2006/main"/>
+          <a:lstStyle xmlns:a="http://schemas.openxmlformats.org/drawingml/2006/main"/>
+          <a:p xmlns:a="http://schemas.openxmlformats.org/drawingml/2006/main">
+            <a:r>
+              <a:t>Roadmap, stated as a plan. October 2026: the encrypted screening MVP, with LinuxONE evidence runs recorded by make evidence-run (profiles 20, 200, 2,000 and 16,000) and validated in CI. Q1 2027: recalibrate on Mexican data, because the reduced ENSANUT experiment underestimated risk, and benchmark s390x at scale. Q2 2027: a hospital pilot with the hospital container on site and the risk service on LinuxONE. Q4 2027: CKKS for non-linear models, Granite explanations on the hospital side and forecasts on LinuxONE. Clinical validation, legal and privacy review and a security audit are gates before any clinical use.</a:t>
+            </a:r>
+            <a:endParaRPr/>
+          </a:p>
+        </p:txBody>
+      </p:sp>
+      <p:sp>
+        <p:nvSpPr>
+          <p:cNvPr id="4" name="Slide Number Placeholder 3"/>
+          <p:cNvSpPr>
+            <a:spLocks xmlns:a="http://schemas.openxmlformats.org/drawingml/2006/main" noGrp="1"/>
+          </p:cNvSpPr>
+          <p:nvPr>
+            <p:ph type="sldNum" idx="5"/>
+          </p:nvPr>
+        </p:nvSpPr>
+        <p:spPr/>
+        <p:txBody>
+          <a:bodyPr xmlns:a="http://schemas.openxmlformats.org/drawingml/2006/main"/>
+          <a:lstStyle xmlns:a="http://schemas.openxmlformats.org/drawingml/2006/main"/>
+          <a:p xmlns:a="http://schemas.openxmlformats.org/drawingml/2006/main"/>
+        </p:txBody>
+      </p:sp>
+    </p:spTree>
+  </p:cSld>
+  <p:clrMapOvr>
+    <a:masterClrMapping xmlns:a="http://schemas.openxmlformats.org/drawingml/2006/main"/>
+  </p:clrMapOvr>
+</p:notes>
+</file>
+
 <file path=ppt/notesSlides/notesSlide2.xml><?xml version="1.0" encoding="utf-8"?>
 <p:notes xmlns:p="http://schemas.openxmlformats.org/presentationml/2006/main">
   <p:cSld>
@@ -1088,6 +1161,77 @@
           <a:p xmlns:a="http://schemas.openxmlformats.org/drawingml/2006/main">
             <a:r>
               <a:t>We aim to support earlier screening without sharing readable patient records with the risk service. The hospital retains decryption and clinical interpretation. AI sees the risk; the service receives ciphertexts only. Thank you.</a:t>
+            </a:r>
+            <a:endParaRPr/>
+          </a:p>
+        </p:txBody>
+      </p:sp>
+      <p:sp>
+        <p:nvSpPr>
+          <p:cNvPr id="4" name="Slide Number Placeholder 3"/>
+          <p:cNvSpPr>
+            <a:spLocks xmlns:a="http://schemas.openxmlformats.org/drawingml/2006/main" noGrp="1"/>
+          </p:cNvSpPr>
+          <p:nvPr>
+            <p:ph type="sldNum" idx="5"/>
+          </p:nvPr>
+        </p:nvSpPr>
+        <p:spPr/>
+        <p:txBody>
+          <a:bodyPr xmlns:a="http://schemas.openxmlformats.org/drawingml/2006/main"/>
+          <a:lstStyle xmlns:a="http://schemas.openxmlformats.org/drawingml/2006/main"/>
+          <a:p xmlns:a="http://schemas.openxmlformats.org/drawingml/2006/main"/>
+        </p:txBody>
+      </p:sp>
+    </p:spTree>
+  </p:cSld>
+  <p:clrMapOvr>
+    <a:masterClrMapping xmlns:a="http://schemas.openxmlformats.org/drawingml/2006/main"/>
+  </p:clrMapOvr>
+</p:notes>
+</file>
+
+<file path=ppt/notesSlides/notesSlide9.xml><?xml version="1.0" encoding="utf-8"?>
+<p:notes xmlns:p="http://schemas.openxmlformats.org/presentationml/2006/main">
+  <p:cSld>
+    <p:spTree>
+      <p:nvGrpSpPr>
+        <p:cNvPr id="1" name=""/>
+        <p:cNvGrpSpPr/>
+        <p:nvPr/>
+      </p:nvGrpSpPr>
+      <p:grpSpPr>
+        <a:xfrm xmlns:a="http://schemas.openxmlformats.org/drawingml/2006/main"/>
+      </p:grpSpPr>
+      <p:sp>
+        <p:nvSpPr>
+          <p:cNvPr id="2" name="Slide Image Placeholder 1"/>
+          <p:cNvSpPr>
+            <a:spLocks xmlns:a="http://schemas.openxmlformats.org/drawingml/2006/main" noGrp="1"/>
+          </p:cNvSpPr>
+          <p:nvPr>
+            <p:ph type="sldImg" idx="0"/>
+          </p:nvPr>
+        </p:nvSpPr>
+        <p:spPr/>
+      </p:sp>
+      <p:sp>
+        <p:nvSpPr>
+          <p:cNvPr id="3" name="Notes Placeholder 2"/>
+          <p:cNvSpPr>
+            <a:spLocks xmlns:a="http://schemas.openxmlformats.org/drawingml/2006/main" noGrp="1"/>
+          </p:cNvSpPr>
+          <p:nvPr>
+            <p:ph type="body" idx="1"/>
+          </p:nvPr>
+        </p:nvSpPr>
+        <p:spPr/>
+        <p:txBody>
+          <a:bodyPr xmlns:a="http://schemas.openxmlformats.org/drawingml/2006/main"/>
+          <a:lstStyle xmlns:a="http://schemas.openxmlformats.org/drawingml/2006/main"/>
+          <a:p xmlns:a="http://schemas.openxmlformats.org/drawingml/2006/main">
+            <a:r>
+              <a:t>Optional E5, unencrypted public aggregates. Weekly SINAVE-notified type 1 and type 2 diabetes cases for 222 series: national, four regions and 32 states, by men, women and all. Each series uses damped ETS or seasonal naive, chosen on rolling origins, then reconciled top-down. A separate nested evaluation over weeks 12 to 63 gives SMAPE about 13% nationally, 25% by region and 60% by state, where sparse type 1 series dominate. Nominal 80% bands cover about 64% in practice, so they stay exploratory. Budgets appear only when a user enters a sourced unit cost. Forecasting has not been run on LinuxONE. Dashboard: antimarrulla-tamizaje.netlify.app/forecast.</a:t>
             </a:r>
             <a:endParaRPr/>
           </a:p>
@@ -2659,6 +2803,1679 @@
     <p:extLst>
       <p:ext uri="{BB962C8B-B14F-4D97-AF65-F5344CB8AC3E}">
         <p14:creationId xmlns:p14="http://schemas.microsoft.com/office/powerpoint/2010/main" val="1137951637"/>
+      </p:ext>
+    </p:extLst>
+  </p:cSld>
+</p:sld>
+</file>
+
+<file path=ppt/slides/slide10.xml><?xml version="1.0" encoding="utf-8"?>
+<p:sld xmlns:p="http://schemas.openxmlformats.org/presentationml/2006/main">
+  <p:cSld>
+    <p:spTree>
+      <p:nvGrpSpPr>
+        <p:cNvPr id="1" name=""/>
+        <p:cNvGrpSpPr/>
+        <p:nvPr/>
+      </p:nvGrpSpPr>
+      <p:grpSpPr>
+        <a:xfrm xmlns:a="http://schemas.openxmlformats.org/drawingml/2006/main"/>
+      </p:grpSpPr>
+      <p:sp>
+        <p:nvSpPr>
+          <p:cNvPr id="2" name="Text 1">
+            <a:extLst xmlns:a="http://schemas.openxmlformats.org/drawingml/2006/main">
+              <a:ext uri="{FF2B5EF4-FFF2-40B4-BE49-F238E27FC236}">
+                <a16:creationId xmlns:a16="http://schemas.microsoft.com/office/drawing/2014/main" id="{BC4DE0A9-A01E-4E2F-8CCE-A01F49FF6800}"/>
+              </a:ext>
+            </a:extLst>
+          </p:cNvPr>
+          <p:cNvSpPr>
+            <a:spLocks xmlns:a="http://schemas.openxmlformats.org/drawingml/2006/main" noGrp="1"/>
+          </p:cNvSpPr>
+          <p:nvPr>
+            <p:ph type="body" idx="101" hasCustomPrompt="1"/>
+          </p:nvPr>
+        </p:nvSpPr>
+        <p:spPr>
+          <a:xfrm xmlns:a="http://schemas.openxmlformats.org/drawingml/2006/main">
+            <a:off x="768096" y="411480"/>
+            <a:ext cx="8229600" cy="310896"/>
+          </a:xfrm>
+          <a:prstGeom xmlns:a="http://schemas.openxmlformats.org/drawingml/2006/main" prst="rect">
+            <a:avLst/>
+          </a:prstGeom>
+          <a:noFill xmlns:a="http://schemas.openxmlformats.org/drawingml/2006/main"/>
+        </p:spPr>
+        <p:txBody>
+          <a:bodyPr xmlns:a="http://schemas.openxmlformats.org/drawingml/2006/main" wrap="square" lIns="0" tIns="0" rIns="0" bIns="0" anchor="ctr"/>
+          <a:lstStyle xmlns:a="http://schemas.openxmlformats.org/drawingml/2006/main"/>
+          <a:p xmlns:a="http://schemas.openxmlformats.org/drawingml/2006/main">
+            <a:pPr marL="0" indent="0">
+              <a:buNone/>
+            </a:pPr>
+            <a:r>
+              <a:rPr sz="1200" b="1" spc="200">
+                <a:solidFill>
+                  <a:schemeClr val="accent5"/>
+                </a:solidFill>
+              </a:rPr>
+              <a:t>08 · ROADMAP</a:t>
+            </a:r>
+            <a:endParaRPr sz="1200"/>
+          </a:p>
+        </p:txBody>
+      </p:sp>
+      <p:sp>
+        <p:nvSpPr>
+          <p:cNvPr id="3" name="Text 1">
+            <a:extLst xmlns:a="http://schemas.openxmlformats.org/drawingml/2006/main">
+              <a:ext uri="{FF2B5EF4-FFF2-40B4-BE49-F238E27FC236}">
+                <a16:creationId xmlns:a16="http://schemas.microsoft.com/office/drawing/2014/main" id="{B3910DF6-87A9-44A1-BAA5-F88DB36CD224}"/>
+              </a:ext>
+            </a:extLst>
+          </p:cNvPr>
+          <p:cNvSpPr>
+            <a:spLocks xmlns:a="http://schemas.openxmlformats.org/drawingml/2006/main" noGrp="1"/>
+          </p:cNvSpPr>
+          <p:nvPr>
+            <p:ph type="title" idx="102" hasCustomPrompt="1"/>
+          </p:nvPr>
+        </p:nvSpPr>
+        <p:spPr>
+          <a:xfrm xmlns:a="http://schemas.openxmlformats.org/drawingml/2006/main">
+            <a:off x="548640" y="777240"/>
+            <a:ext cx="11091672" cy="731520"/>
+          </a:xfrm>
+          <a:prstGeom xmlns:a="http://schemas.openxmlformats.org/drawingml/2006/main" prst="rect">
+            <a:avLst/>
+          </a:prstGeom>
+          <a:noFill xmlns:a="http://schemas.openxmlformats.org/drawingml/2006/main"/>
+        </p:spPr>
+        <p:txBody>
+          <a:bodyPr xmlns:a="http://schemas.openxmlformats.org/drawingml/2006/main" wrap="square" lIns="0" tIns="0" rIns="0" bIns="0" anchor="t"/>
+          <a:lstStyle xmlns:a="http://schemas.openxmlformats.org/drawingml/2006/main"/>
+          <a:p xmlns:a="http://schemas.openxmlformats.org/drawingml/2006/main">
+            <a:pPr marL="0" indent="0" algn="l">
+              <a:buNone/>
+            </a:pPr>
+            <a:r>
+              <a:rPr sz="3000" b="1">
+                <a:solidFill>
+                  <a:schemeClr val="bg1"/>
+                </a:solidFill>
+              </a:rPr>
+              <a:t>From a verified demo to a hospital pilot</a:t>
+            </a:r>
+            <a:endParaRPr sz="3000"/>
+          </a:p>
+        </p:txBody>
+      </p:sp>
+      <p:sp>
+        <p:nvSpPr>
+          <p:cNvPr id="4" name="0">
+            <a:extLst xmlns:a="http://schemas.openxmlformats.org/drawingml/2006/main">
+              <a:ext uri="{FF2B5EF4-FFF2-40B4-BE49-F238E27FC236}">
+                <a16:creationId xmlns:a16="http://schemas.microsoft.com/office/drawing/2014/main" id="{E7DB1422-41EA-46E9-B916-641630ADF8B8}"/>
+              </a:ext>
+            </a:extLst>
+          </p:cNvPr>
+          <p:cNvSpPr>
+            <a:spLocks xmlns:a="http://schemas.openxmlformats.org/drawingml/2006/main" noGrp="1"/>
+          </p:cNvSpPr>
+          <p:nvPr/>
+        </p:nvSpPr>
+        <p:spPr>
+          <a:xfrm xmlns:a="http://schemas.openxmlformats.org/drawingml/2006/main">
+            <a:off x="548640" y="1783080"/>
+            <a:ext cx="3520440" cy="960120"/>
+          </a:xfrm>
+          <a:prstGeom xmlns:a="http://schemas.openxmlformats.org/drawingml/2006/main" prst="roundRect">
+            <a:avLst>
+              <a:gd name="adj" fmla="val 9524"/>
+            </a:avLst>
+          </a:prstGeom>
+          <a:solidFill xmlns:a="http://schemas.openxmlformats.org/drawingml/2006/main">
+            <a:schemeClr val="tx2"/>
+          </a:solidFill>
+        </p:spPr>
+      </p:sp>
+      <p:sp>
+        <p:nvSpPr>
+          <p:cNvPr id="5" name="Text 3">
+            <a:extLst xmlns:a="http://schemas.openxmlformats.org/drawingml/2006/main">
+              <a:ext uri="{FF2B5EF4-FFF2-40B4-BE49-F238E27FC236}">
+                <a16:creationId xmlns:a16="http://schemas.microsoft.com/office/drawing/2014/main" id="{DDEA2EAD-C407-4010-A33F-443D6F496F2C}"/>
+              </a:ext>
+            </a:extLst>
+          </p:cNvPr>
+          <p:cNvSpPr>
+            <a:spLocks xmlns:a="http://schemas.openxmlformats.org/drawingml/2006/main" noGrp="1"/>
+          </p:cNvSpPr>
+          <p:nvPr/>
+        </p:nvSpPr>
+        <p:spPr>
+          <a:xfrm xmlns:a="http://schemas.openxmlformats.org/drawingml/2006/main">
+            <a:off x="731520" y="1783080"/>
+            <a:ext cx="1600200" cy="960120"/>
+          </a:xfrm>
+          <a:prstGeom xmlns:a="http://schemas.openxmlformats.org/drawingml/2006/main" prst="rect">
+            <a:avLst/>
+          </a:prstGeom>
+          <a:noFill xmlns:a="http://schemas.openxmlformats.org/drawingml/2006/main"/>
+        </p:spPr>
+        <p:txBody>
+          <a:bodyPr xmlns:a="http://schemas.openxmlformats.org/drawingml/2006/main" wrap="square" lIns="0" tIns="0" rIns="0" bIns="0" anchor="ctr"/>
+          <a:lstStyle xmlns:a="http://schemas.openxmlformats.org/drawingml/2006/main"/>
+          <a:p xmlns:a="http://schemas.openxmlformats.org/drawingml/2006/main">
+            <a:pPr marL="0" indent="0">
+              <a:buNone/>
+            </a:pPr>
+            <a:r>
+              <a:rPr sz="3000" b="1">
+                <a:solidFill>
+                  <a:schemeClr val="accent5"/>
+                </a:solidFill>
+              </a:rPr>
+              <a:t>0</a:t>
+            </a:r>
+            <a:endParaRPr sz="3000"/>
+          </a:p>
+        </p:txBody>
+      </p:sp>
+      <p:sp>
+        <p:nvSpPr>
+          <p:cNvPr id="6" name="Text 4">
+            <a:extLst xmlns:a="http://schemas.openxmlformats.org/drawingml/2006/main">
+              <a:ext uri="{FF2B5EF4-FFF2-40B4-BE49-F238E27FC236}">
+                <a16:creationId xmlns:a16="http://schemas.microsoft.com/office/drawing/2014/main" id="{6CD34BAF-1C57-4863-9F84-A3CD5EAE8526}"/>
+              </a:ext>
+            </a:extLst>
+          </p:cNvPr>
+          <p:cNvSpPr>
+            <a:spLocks xmlns:a="http://schemas.openxmlformats.org/drawingml/2006/main" noGrp="1"/>
+          </p:cNvSpPr>
+          <p:nvPr/>
+        </p:nvSpPr>
+        <p:spPr>
+          <a:xfrm xmlns:a="http://schemas.openxmlformats.org/drawingml/2006/main">
+            <a:off x="2331720" y="1828800"/>
+            <a:ext cx="1600200" cy="868680"/>
+          </a:xfrm>
+          <a:prstGeom xmlns:a="http://schemas.openxmlformats.org/drawingml/2006/main" prst="rect">
+            <a:avLst/>
+          </a:prstGeom>
+          <a:noFill xmlns:a="http://schemas.openxmlformats.org/drawingml/2006/main"/>
+        </p:spPr>
+        <p:txBody>
+          <a:bodyPr xmlns:a="http://schemas.openxmlformats.org/drawingml/2006/main" wrap="square" lIns="0" tIns="0" rIns="0" bIns="0" anchor="ctr"/>
+          <a:lstStyle xmlns:a="http://schemas.openxmlformats.org/drawingml/2006/main"/>
+          <a:p xmlns:a="http://schemas.openxmlformats.org/drawingml/2006/main">
+            <a:pPr marL="0" indent="0">
+              <a:buNone/>
+            </a:pPr>
+            <a:r>
+              <a:rPr sz="1100">
+                <a:solidFill>
+                  <a:schemeClr val="bg2"/>
+                </a:solidFill>
+              </a:rPr>
+              <a:t>plaintext patient inputs reach the external risk service</a:t>
+            </a:r>
+            <a:endParaRPr sz="1100"/>
+          </a:p>
+        </p:txBody>
+      </p:sp>
+      <p:sp>
+        <p:nvSpPr>
+          <p:cNvPr id="7" name="21">
+            <a:extLst xmlns:a="http://schemas.openxmlformats.org/drawingml/2006/main">
+              <a:ext uri="{FF2B5EF4-FFF2-40B4-BE49-F238E27FC236}">
+                <a16:creationId xmlns:a16="http://schemas.microsoft.com/office/drawing/2014/main" id="{9916D5D1-6F81-4737-930F-F52170FCF3AC}"/>
+              </a:ext>
+            </a:extLst>
+          </p:cNvPr>
+          <p:cNvSpPr>
+            <a:spLocks xmlns:a="http://schemas.openxmlformats.org/drawingml/2006/main" noGrp="1"/>
+          </p:cNvSpPr>
+          <p:nvPr/>
+        </p:nvSpPr>
+        <p:spPr>
+          <a:xfrm xmlns:a="http://schemas.openxmlformats.org/drawingml/2006/main">
+            <a:off x="4334256" y="1783080"/>
+            <a:ext cx="3520440" cy="960120"/>
+          </a:xfrm>
+          <a:prstGeom xmlns:a="http://schemas.openxmlformats.org/drawingml/2006/main" prst="roundRect">
+            <a:avLst>
+              <a:gd name="adj" fmla="val 9524"/>
+            </a:avLst>
+          </a:prstGeom>
+          <a:solidFill xmlns:a="http://schemas.openxmlformats.org/drawingml/2006/main">
+            <a:schemeClr val="tx2"/>
+          </a:solidFill>
+        </p:spPr>
+      </p:sp>
+      <p:sp>
+        <p:nvSpPr>
+          <p:cNvPr id="8" name="Text 6">
+            <a:extLst xmlns:a="http://schemas.openxmlformats.org/drawingml/2006/main">
+              <a:ext uri="{FF2B5EF4-FFF2-40B4-BE49-F238E27FC236}">
+                <a16:creationId xmlns:a16="http://schemas.microsoft.com/office/drawing/2014/main" id="{CE696A82-1D0E-4B07-BC70-ACF6F2471003}"/>
+              </a:ext>
+            </a:extLst>
+          </p:cNvPr>
+          <p:cNvSpPr>
+            <a:spLocks xmlns:a="http://schemas.openxmlformats.org/drawingml/2006/main" noGrp="1"/>
+          </p:cNvSpPr>
+          <p:nvPr/>
+        </p:nvSpPr>
+        <p:spPr>
+          <a:xfrm xmlns:a="http://schemas.openxmlformats.org/drawingml/2006/main">
+            <a:off x="4517136" y="1783080"/>
+            <a:ext cx="1600200" cy="960120"/>
+          </a:xfrm>
+          <a:prstGeom xmlns:a="http://schemas.openxmlformats.org/drawingml/2006/main" prst="rect">
+            <a:avLst/>
+          </a:prstGeom>
+          <a:noFill xmlns:a="http://schemas.openxmlformats.org/drawingml/2006/main"/>
+        </p:spPr>
+        <p:txBody>
+          <a:bodyPr xmlns:a="http://schemas.openxmlformats.org/drawingml/2006/main" wrap="square" lIns="0" tIns="0" rIns="0" bIns="0" anchor="ctr"/>
+          <a:lstStyle xmlns:a="http://schemas.openxmlformats.org/drawingml/2006/main"/>
+          <a:p xmlns:a="http://schemas.openxmlformats.org/drawingml/2006/main">
+            <a:pPr marL="0" indent="0">
+              <a:buNone/>
+            </a:pPr>
+            <a:r>
+              <a:rPr sz="3000" b="1">
+                <a:solidFill>
+                  <a:schemeClr val="accent5"/>
+                </a:solidFill>
+              </a:rPr>
+              <a:t>4</a:t>
+            </a:r>
+            <a:endParaRPr sz="3000"/>
+          </a:p>
+        </p:txBody>
+      </p:sp>
+      <p:sp>
+        <p:nvSpPr>
+          <p:cNvPr id="9" name="Text 7">
+            <a:extLst xmlns:a="http://schemas.openxmlformats.org/drawingml/2006/main">
+              <a:ext uri="{FF2B5EF4-FFF2-40B4-BE49-F238E27FC236}">
+                <a16:creationId xmlns:a16="http://schemas.microsoft.com/office/drawing/2014/main" id="{1207F869-1A8A-4165-BEB7-44092934CC06}"/>
+              </a:ext>
+            </a:extLst>
+          </p:cNvPr>
+          <p:cNvSpPr>
+            <a:spLocks xmlns:a="http://schemas.openxmlformats.org/drawingml/2006/main" noGrp="1"/>
+          </p:cNvSpPr>
+          <p:nvPr/>
+        </p:nvSpPr>
+        <p:spPr>
+          <a:xfrm xmlns:a="http://schemas.openxmlformats.org/drawingml/2006/main">
+            <a:off x="6117336" y="1828800"/>
+            <a:ext cx="1600200" cy="868680"/>
+          </a:xfrm>
+          <a:prstGeom xmlns:a="http://schemas.openxmlformats.org/drawingml/2006/main" prst="rect">
+            <a:avLst/>
+          </a:prstGeom>
+          <a:noFill xmlns:a="http://schemas.openxmlformats.org/drawingml/2006/main"/>
+        </p:spPr>
+        <p:txBody>
+          <a:bodyPr xmlns:a="http://schemas.openxmlformats.org/drawingml/2006/main" wrap="square" lIns="0" tIns="0" rIns="0" bIns="0" anchor="ctr"/>
+          <a:lstStyle xmlns:a="http://schemas.openxmlformats.org/drawingml/2006/main"/>
+          <a:p xmlns:a="http://schemas.openxmlformats.org/drawingml/2006/main">
+            <a:pPr marL="0" indent="0">
+              <a:buNone/>
+            </a:pPr>
+            <a:r>
+              <a:rPr sz="1100">
+                <a:solidFill>
+                  <a:schemeClr val="bg2"/>
+                </a:solidFill>
+              </a:rPr>
+              <a:t>test profiles ready for LinuxONE: 20 to 16,000 patients</a:t>
+            </a:r>
+            <a:endParaRPr sz="1100"/>
+          </a:p>
+        </p:txBody>
+      </p:sp>
+      <p:sp>
+        <p:nvSpPr>
+          <p:cNvPr id="10" name="222">
+            <a:extLst xmlns:a="http://schemas.openxmlformats.org/drawingml/2006/main">
+              <a:ext uri="{FF2B5EF4-FFF2-40B4-BE49-F238E27FC236}">
+                <a16:creationId xmlns:a16="http://schemas.microsoft.com/office/drawing/2014/main" id="{55EF02D7-8155-49C3-A3FA-97FB89D9A58C}"/>
+              </a:ext>
+            </a:extLst>
+          </p:cNvPr>
+          <p:cNvSpPr>
+            <a:spLocks xmlns:a="http://schemas.openxmlformats.org/drawingml/2006/main" noGrp="1"/>
+          </p:cNvSpPr>
+          <p:nvPr/>
+        </p:nvSpPr>
+        <p:spPr>
+          <a:xfrm xmlns:a="http://schemas.openxmlformats.org/drawingml/2006/main">
+            <a:off x="8119872" y="1783080"/>
+            <a:ext cx="3520440" cy="960120"/>
+          </a:xfrm>
+          <a:prstGeom xmlns:a="http://schemas.openxmlformats.org/drawingml/2006/main" prst="roundRect">
+            <a:avLst>
+              <a:gd name="adj" fmla="val 9524"/>
+            </a:avLst>
+          </a:prstGeom>
+          <a:solidFill xmlns:a="http://schemas.openxmlformats.org/drawingml/2006/main">
+            <a:schemeClr val="tx2"/>
+          </a:solidFill>
+        </p:spPr>
+      </p:sp>
+      <p:sp>
+        <p:nvSpPr>
+          <p:cNvPr id="11" name="Text 9">
+            <a:extLst xmlns:a="http://schemas.openxmlformats.org/drawingml/2006/main">
+              <a:ext uri="{FF2B5EF4-FFF2-40B4-BE49-F238E27FC236}">
+                <a16:creationId xmlns:a16="http://schemas.microsoft.com/office/drawing/2014/main" id="{B394A62B-9F83-4191-8537-C51D027A16D3}"/>
+              </a:ext>
+            </a:extLst>
+          </p:cNvPr>
+          <p:cNvSpPr>
+            <a:spLocks xmlns:a="http://schemas.openxmlformats.org/drawingml/2006/main" noGrp="1"/>
+          </p:cNvSpPr>
+          <p:nvPr/>
+        </p:nvSpPr>
+        <p:spPr>
+          <a:xfrm xmlns:a="http://schemas.openxmlformats.org/drawingml/2006/main">
+            <a:off x="8302752" y="1783080"/>
+            <a:ext cx="1600200" cy="960120"/>
+          </a:xfrm>
+          <a:prstGeom xmlns:a="http://schemas.openxmlformats.org/drawingml/2006/main" prst="rect">
+            <a:avLst/>
+          </a:prstGeom>
+          <a:noFill xmlns:a="http://schemas.openxmlformats.org/drawingml/2006/main"/>
+        </p:spPr>
+        <p:txBody>
+          <a:bodyPr xmlns:a="http://schemas.openxmlformats.org/drawingml/2006/main" wrap="square" lIns="0" tIns="0" rIns="0" bIns="0" anchor="ctr"/>
+          <a:lstStyle xmlns:a="http://schemas.openxmlformats.org/drawingml/2006/main"/>
+          <a:p xmlns:a="http://schemas.openxmlformats.org/drawingml/2006/main">
+            <a:pPr marL="0" indent="0">
+              <a:buNone/>
+            </a:pPr>
+            <a:r>
+              <a:rPr sz="3000" b="1">
+                <a:solidFill>
+                  <a:schemeClr val="accent5"/>
+                </a:solidFill>
+              </a:rPr>
+              <a:t>222</a:t>
+            </a:r>
+            <a:endParaRPr sz="3000"/>
+          </a:p>
+        </p:txBody>
+      </p:sp>
+      <p:sp>
+        <p:nvSpPr>
+          <p:cNvPr id="12" name="Text 10">
+            <a:extLst xmlns:a="http://schemas.openxmlformats.org/drawingml/2006/main">
+              <a:ext uri="{FF2B5EF4-FFF2-40B4-BE49-F238E27FC236}">
+                <a16:creationId xmlns:a16="http://schemas.microsoft.com/office/drawing/2014/main" id="{EA0BF3AB-F17E-46FE-B05B-1404BD5A20DE}"/>
+              </a:ext>
+            </a:extLst>
+          </p:cNvPr>
+          <p:cNvSpPr>
+            <a:spLocks xmlns:a="http://schemas.openxmlformats.org/drawingml/2006/main" noGrp="1"/>
+          </p:cNvSpPr>
+          <p:nvPr/>
+        </p:nvSpPr>
+        <p:spPr>
+          <a:xfrm xmlns:a="http://schemas.openxmlformats.org/drawingml/2006/main">
+            <a:off x="9902952" y="1828800"/>
+            <a:ext cx="1600200" cy="868680"/>
+          </a:xfrm>
+          <a:prstGeom xmlns:a="http://schemas.openxmlformats.org/drawingml/2006/main" prst="rect">
+            <a:avLst/>
+          </a:prstGeom>
+          <a:noFill xmlns:a="http://schemas.openxmlformats.org/drawingml/2006/main"/>
+        </p:spPr>
+        <p:txBody>
+          <a:bodyPr xmlns:a="http://schemas.openxmlformats.org/drawingml/2006/main" wrap="square" lIns="0" tIns="0" rIns="0" bIns="0" anchor="ctr"/>
+          <a:lstStyle xmlns:a="http://schemas.openxmlformats.org/drawingml/2006/main"/>
+          <a:p xmlns:a="http://schemas.openxmlformats.org/drawingml/2006/main">
+            <a:pPr marL="0" indent="0">
+              <a:buNone/>
+            </a:pPr>
+            <a:r>
+              <a:rPr sz="1100">
+                <a:solidFill>
+                  <a:schemeClr val="bg2"/>
+                </a:solidFill>
+              </a:rPr>
+              <a:t>weekly forecast series ready for capacity and budget planning</a:t>
+            </a:r>
+            <a:endParaRPr sz="1100"/>
+          </a:p>
+        </p:txBody>
+      </p:sp>
+      <p:sp>
+        <p:nvSpPr>
+          <p:cNvPr id="13" name="conector">
+            <a:extLst xmlns:a="http://schemas.openxmlformats.org/drawingml/2006/main">
+              <a:ext uri="{FF2B5EF4-FFF2-40B4-BE49-F238E27FC236}">
+                <a16:creationId xmlns:a16="http://schemas.microsoft.com/office/drawing/2014/main" id="{FB0E6C64-14D6-4A41-A1ED-3E768F170DC5}"/>
+              </a:ext>
+            </a:extLst>
+          </p:cNvPr>
+          <p:cNvSpPr>
+            <a:spLocks xmlns:a="http://schemas.openxmlformats.org/drawingml/2006/main" noGrp="1"/>
+          </p:cNvSpPr>
+          <p:nvPr/>
+        </p:nvSpPr>
+        <p:spPr>
+          <a:xfrm xmlns:a="http://schemas.openxmlformats.org/drawingml/2006/main">
+            <a:off x="777240" y="3493008"/>
+            <a:ext cx="0" cy="274320"/>
+          </a:xfrm>
+          <a:prstGeom xmlns:a="http://schemas.openxmlformats.org/drawingml/2006/main" prst="line">
+            <a:avLst/>
+          </a:prstGeom>
+          <a:noFill xmlns:a="http://schemas.openxmlformats.org/drawingml/2006/main"/>
+          <a:ln xmlns:a="http://schemas.openxmlformats.org/drawingml/2006/main" w="19050">
+            <a:solidFill>
+              <a:schemeClr val="accent5"/>
+            </a:solidFill>
+            <a:prstDash val="dash"/>
+          </a:ln>
+        </p:spPr>
+      </p:sp>
+      <p:sp>
+        <p:nvSpPr>
+          <p:cNvPr id="14" name="paso 1">
+            <a:extLst xmlns:a="http://schemas.openxmlformats.org/drawingml/2006/main">
+              <a:ext uri="{FF2B5EF4-FFF2-40B4-BE49-F238E27FC236}">
+                <a16:creationId xmlns:a16="http://schemas.microsoft.com/office/drawing/2014/main" id="{B20B6246-4475-4131-888A-3C1EE22FF08E}"/>
+              </a:ext>
+            </a:extLst>
+          </p:cNvPr>
+          <p:cNvSpPr>
+            <a:spLocks xmlns:a="http://schemas.openxmlformats.org/drawingml/2006/main" noGrp="1"/>
+          </p:cNvSpPr>
+          <p:nvPr/>
+        </p:nvSpPr>
+        <p:spPr>
+          <a:xfrm xmlns:a="http://schemas.openxmlformats.org/drawingml/2006/main">
+            <a:off x="548640" y="3017520"/>
+            <a:ext cx="457200" cy="457200"/>
+          </a:xfrm>
+          <a:prstGeom xmlns:a="http://schemas.openxmlformats.org/drawingml/2006/main" prst="ellipse">
+            <a:avLst/>
+          </a:prstGeom>
+          <a:solidFill xmlns:a="http://schemas.openxmlformats.org/drawingml/2006/main">
+            <a:schemeClr val="accent1"/>
+          </a:solidFill>
+        </p:spPr>
+      </p:sp>
+      <p:sp>
+        <p:nvSpPr>
+          <p:cNvPr id="15" name="Text 13">
+            <a:extLst xmlns:a="http://schemas.openxmlformats.org/drawingml/2006/main">
+              <a:ext uri="{FF2B5EF4-FFF2-40B4-BE49-F238E27FC236}">
+                <a16:creationId xmlns:a16="http://schemas.microsoft.com/office/drawing/2014/main" id="{41CC5E54-AC20-4425-A6E7-86ABFCED5C05}"/>
+              </a:ext>
+            </a:extLst>
+          </p:cNvPr>
+          <p:cNvSpPr>
+            <a:spLocks xmlns:a="http://schemas.openxmlformats.org/drawingml/2006/main" noGrp="1"/>
+          </p:cNvSpPr>
+          <p:nvPr/>
+        </p:nvSpPr>
+        <p:spPr>
+          <a:xfrm xmlns:a="http://schemas.openxmlformats.org/drawingml/2006/main">
+            <a:off x="548640" y="3017520"/>
+            <a:ext cx="457200" cy="457200"/>
+          </a:xfrm>
+          <a:prstGeom xmlns:a="http://schemas.openxmlformats.org/drawingml/2006/main" prst="rect">
+            <a:avLst/>
+          </a:prstGeom>
+          <a:noFill xmlns:a="http://schemas.openxmlformats.org/drawingml/2006/main"/>
+        </p:spPr>
+        <p:txBody>
+          <a:bodyPr xmlns:a="http://schemas.openxmlformats.org/drawingml/2006/main" wrap="square" lIns="0" tIns="0" rIns="0" bIns="0" anchor="ctr"/>
+          <a:lstStyle xmlns:a="http://schemas.openxmlformats.org/drawingml/2006/main"/>
+          <a:p xmlns:a="http://schemas.openxmlformats.org/drawingml/2006/main">
+            <a:pPr marL="0" indent="0" algn="ctr">
+              <a:buNone/>
+            </a:pPr>
+            <a:r>
+              <a:rPr sz="1600" b="1">
+                <a:solidFill>
+                  <a:schemeClr val="bg1"/>
+                </a:solidFill>
+              </a:rPr>
+              <a:t>1</a:t>
+            </a:r>
+            <a:endParaRPr sz="1600"/>
+          </a:p>
+        </p:txBody>
+      </p:sp>
+      <p:sp>
+        <p:nvSpPr>
+          <p:cNvPr id="16" name="Text 14">
+            <a:extLst xmlns:a="http://schemas.openxmlformats.org/drawingml/2006/main">
+              <a:ext uri="{FF2B5EF4-FFF2-40B4-BE49-F238E27FC236}">
+                <a16:creationId xmlns:a16="http://schemas.microsoft.com/office/drawing/2014/main" id="{48A08C5C-56AA-4EBF-B2FD-0990EB3F52AE}"/>
+              </a:ext>
+            </a:extLst>
+          </p:cNvPr>
+          <p:cNvSpPr>
+            <a:spLocks xmlns:a="http://schemas.openxmlformats.org/drawingml/2006/main" noGrp="1"/>
+          </p:cNvSpPr>
+          <p:nvPr/>
+        </p:nvSpPr>
+        <p:spPr>
+          <a:xfrm xmlns:a="http://schemas.openxmlformats.org/drawingml/2006/main">
+            <a:off x="1188720" y="2990088"/>
+            <a:ext cx="4754880" cy="292608"/>
+          </a:xfrm>
+          <a:prstGeom xmlns:a="http://schemas.openxmlformats.org/drawingml/2006/main" prst="rect">
+            <a:avLst/>
+          </a:prstGeom>
+          <a:noFill xmlns:a="http://schemas.openxmlformats.org/drawingml/2006/main"/>
+        </p:spPr>
+        <p:txBody>
+          <a:bodyPr xmlns:a="http://schemas.openxmlformats.org/drawingml/2006/main" wrap="square" lIns="0" tIns="0" rIns="0" bIns="0" anchor="ctr"/>
+          <a:lstStyle xmlns:a="http://schemas.openxmlformats.org/drawingml/2006/main"/>
+          <a:p xmlns:a="http://schemas.openxmlformats.org/drawingml/2006/main">
+            <a:pPr marL="0" indent="0">
+              <a:buNone/>
+            </a:pPr>
+            <a:r>
+              <a:rPr sz="1400" b="1">
+                <a:solidFill>
+                  <a:schemeClr val="bg1"/>
+                </a:solidFill>
+              </a:rPr>
+              <a:t>Oct 2026 · Datathon MVP</a:t>
+            </a:r>
+            <a:endParaRPr sz="1400"/>
+          </a:p>
+        </p:txBody>
+      </p:sp>
+      <p:sp>
+        <p:nvSpPr>
+          <p:cNvPr id="17" name="Text 15">
+            <a:extLst xmlns:a="http://schemas.openxmlformats.org/drawingml/2006/main">
+              <a:ext uri="{FF2B5EF4-FFF2-40B4-BE49-F238E27FC236}">
+                <a16:creationId xmlns:a16="http://schemas.microsoft.com/office/drawing/2014/main" id="{343A8BF2-9A36-4F9E-A8C7-036378FBE170}"/>
+              </a:ext>
+            </a:extLst>
+          </p:cNvPr>
+          <p:cNvSpPr>
+            <a:spLocks xmlns:a="http://schemas.openxmlformats.org/drawingml/2006/main" noGrp="1"/>
+          </p:cNvSpPr>
+          <p:nvPr/>
+        </p:nvSpPr>
+        <p:spPr>
+          <a:xfrm xmlns:a="http://schemas.openxmlformats.org/drawingml/2006/main">
+            <a:off x="1188720" y="3282696"/>
+            <a:ext cx="4754880" cy="384048"/>
+          </a:xfrm>
+          <a:prstGeom xmlns:a="http://schemas.openxmlformats.org/drawingml/2006/main" prst="rect">
+            <a:avLst/>
+          </a:prstGeom>
+          <a:noFill xmlns:a="http://schemas.openxmlformats.org/drawingml/2006/main"/>
+        </p:spPr>
+        <p:txBody>
+          <a:bodyPr xmlns:a="http://schemas.openxmlformats.org/drawingml/2006/main" wrap="square" lIns="0" tIns="0" rIns="0" bIns="0" anchor="t"/>
+          <a:lstStyle xmlns:a="http://schemas.openxmlformats.org/drawingml/2006/main"/>
+          <a:p xmlns:a="http://schemas.openxmlformats.org/drawingml/2006/main">
+            <a:pPr marL="0" indent="0">
+              <a:buNone/>
+            </a:pPr>
+            <a:r>
+              <a:rPr sz="1200">
+                <a:solidFill>
+                  <a:schemeClr val="bg2"/>
+                </a:solidFill>
+              </a:rPr>
+              <a:t>Encrypted screening MVP; LinuxONE runs recorded with logs and CI checks</a:t>
+            </a:r>
+            <a:endParaRPr sz="1200"/>
+          </a:p>
+        </p:txBody>
+      </p:sp>
+      <p:sp>
+        <p:nvSpPr>
+          <p:cNvPr id="18" name="conector">
+            <a:extLst xmlns:a="http://schemas.openxmlformats.org/drawingml/2006/main">
+              <a:ext uri="{FF2B5EF4-FFF2-40B4-BE49-F238E27FC236}">
+                <a16:creationId xmlns:a16="http://schemas.microsoft.com/office/drawing/2014/main" id="{D1B83B55-12E1-48D8-8A22-CA1D5E5E0851}"/>
+              </a:ext>
+            </a:extLst>
+          </p:cNvPr>
+          <p:cNvSpPr>
+            <a:spLocks xmlns:a="http://schemas.openxmlformats.org/drawingml/2006/main" noGrp="1"/>
+          </p:cNvSpPr>
+          <p:nvPr/>
+        </p:nvSpPr>
+        <p:spPr>
+          <a:xfrm xmlns:a="http://schemas.openxmlformats.org/drawingml/2006/main">
+            <a:off x="777240" y="4242816"/>
+            <a:ext cx="0" cy="274320"/>
+          </a:xfrm>
+          <a:prstGeom xmlns:a="http://schemas.openxmlformats.org/drawingml/2006/main" prst="line">
+            <a:avLst/>
+          </a:prstGeom>
+          <a:noFill xmlns:a="http://schemas.openxmlformats.org/drawingml/2006/main"/>
+          <a:ln xmlns:a="http://schemas.openxmlformats.org/drawingml/2006/main" w="19050">
+            <a:solidFill>
+              <a:schemeClr val="accent5"/>
+            </a:solidFill>
+            <a:prstDash val="dash"/>
+          </a:ln>
+        </p:spPr>
+      </p:sp>
+      <p:sp>
+        <p:nvSpPr>
+          <p:cNvPr id="19" name="paso 2">
+            <a:extLst xmlns:a="http://schemas.openxmlformats.org/drawingml/2006/main">
+              <a:ext uri="{FF2B5EF4-FFF2-40B4-BE49-F238E27FC236}">
+                <a16:creationId xmlns:a16="http://schemas.microsoft.com/office/drawing/2014/main" id="{E661DC74-84BD-491B-B090-592C5AA9D385}"/>
+              </a:ext>
+            </a:extLst>
+          </p:cNvPr>
+          <p:cNvSpPr>
+            <a:spLocks xmlns:a="http://schemas.openxmlformats.org/drawingml/2006/main" noGrp="1"/>
+          </p:cNvSpPr>
+          <p:nvPr/>
+        </p:nvSpPr>
+        <p:spPr>
+          <a:xfrm xmlns:a="http://schemas.openxmlformats.org/drawingml/2006/main">
+            <a:off x="548640" y="3767328"/>
+            <a:ext cx="457200" cy="457200"/>
+          </a:xfrm>
+          <a:prstGeom xmlns:a="http://schemas.openxmlformats.org/drawingml/2006/main" prst="ellipse">
+            <a:avLst/>
+          </a:prstGeom>
+          <a:solidFill xmlns:a="http://schemas.openxmlformats.org/drawingml/2006/main">
+            <a:schemeClr val="accent1"/>
+          </a:solidFill>
+        </p:spPr>
+      </p:sp>
+      <p:sp>
+        <p:nvSpPr>
+          <p:cNvPr id="20" name="Text 18">
+            <a:extLst xmlns:a="http://schemas.openxmlformats.org/drawingml/2006/main">
+              <a:ext uri="{FF2B5EF4-FFF2-40B4-BE49-F238E27FC236}">
+                <a16:creationId xmlns:a16="http://schemas.microsoft.com/office/drawing/2014/main" id="{C42B77C1-DD0C-4985-BE7F-B88E08D78C9D}"/>
+              </a:ext>
+            </a:extLst>
+          </p:cNvPr>
+          <p:cNvSpPr>
+            <a:spLocks xmlns:a="http://schemas.openxmlformats.org/drawingml/2006/main" noGrp="1"/>
+          </p:cNvSpPr>
+          <p:nvPr/>
+        </p:nvSpPr>
+        <p:spPr>
+          <a:xfrm xmlns:a="http://schemas.openxmlformats.org/drawingml/2006/main">
+            <a:off x="548640" y="3767328"/>
+            <a:ext cx="457200" cy="457200"/>
+          </a:xfrm>
+          <a:prstGeom xmlns:a="http://schemas.openxmlformats.org/drawingml/2006/main" prst="rect">
+            <a:avLst/>
+          </a:prstGeom>
+          <a:noFill xmlns:a="http://schemas.openxmlformats.org/drawingml/2006/main"/>
+        </p:spPr>
+        <p:txBody>
+          <a:bodyPr xmlns:a="http://schemas.openxmlformats.org/drawingml/2006/main" wrap="square" lIns="0" tIns="0" rIns="0" bIns="0" anchor="ctr"/>
+          <a:lstStyle xmlns:a="http://schemas.openxmlformats.org/drawingml/2006/main"/>
+          <a:p xmlns:a="http://schemas.openxmlformats.org/drawingml/2006/main">
+            <a:pPr marL="0" indent="0" algn="ctr">
+              <a:buNone/>
+            </a:pPr>
+            <a:r>
+              <a:rPr sz="1600" b="1">
+                <a:solidFill>
+                  <a:schemeClr val="bg1"/>
+                </a:solidFill>
+              </a:rPr>
+              <a:t>2</a:t>
+            </a:r>
+            <a:endParaRPr sz="1600"/>
+          </a:p>
+        </p:txBody>
+      </p:sp>
+      <p:sp>
+        <p:nvSpPr>
+          <p:cNvPr id="21" name="Text 19">
+            <a:extLst xmlns:a="http://schemas.openxmlformats.org/drawingml/2006/main">
+              <a:ext uri="{FF2B5EF4-FFF2-40B4-BE49-F238E27FC236}">
+                <a16:creationId xmlns:a16="http://schemas.microsoft.com/office/drawing/2014/main" id="{5A8C9266-8697-4DC6-811F-2FAAE8B5993F}"/>
+              </a:ext>
+            </a:extLst>
+          </p:cNvPr>
+          <p:cNvSpPr>
+            <a:spLocks xmlns:a="http://schemas.openxmlformats.org/drawingml/2006/main" noGrp="1"/>
+          </p:cNvSpPr>
+          <p:nvPr/>
+        </p:nvSpPr>
+        <p:spPr>
+          <a:xfrm xmlns:a="http://schemas.openxmlformats.org/drawingml/2006/main">
+            <a:off x="1188720" y="3739896"/>
+            <a:ext cx="4754880" cy="292608"/>
+          </a:xfrm>
+          <a:prstGeom xmlns:a="http://schemas.openxmlformats.org/drawingml/2006/main" prst="rect">
+            <a:avLst/>
+          </a:prstGeom>
+          <a:noFill xmlns:a="http://schemas.openxmlformats.org/drawingml/2006/main"/>
+        </p:spPr>
+        <p:txBody>
+          <a:bodyPr xmlns:a="http://schemas.openxmlformats.org/drawingml/2006/main" wrap="square" lIns="0" tIns="0" rIns="0" bIns="0" anchor="ctr"/>
+          <a:lstStyle xmlns:a="http://schemas.openxmlformats.org/drawingml/2006/main"/>
+          <a:p xmlns:a="http://schemas.openxmlformats.org/drawingml/2006/main">
+            <a:pPr marL="0" indent="0">
+              <a:buNone/>
+            </a:pPr>
+            <a:r>
+              <a:rPr sz="1400" b="1">
+                <a:solidFill>
+                  <a:schemeClr val="bg1"/>
+                </a:solidFill>
+              </a:rPr>
+              <a:t>Q1 2027 · Calibrate for Mexico</a:t>
+            </a:r>
+            <a:endParaRPr sz="1400"/>
+          </a:p>
+        </p:txBody>
+      </p:sp>
+      <p:sp>
+        <p:nvSpPr>
+          <p:cNvPr id="22" name="Text 20">
+            <a:extLst xmlns:a="http://schemas.openxmlformats.org/drawingml/2006/main">
+              <a:ext uri="{FF2B5EF4-FFF2-40B4-BE49-F238E27FC236}">
+                <a16:creationId xmlns:a16="http://schemas.microsoft.com/office/drawing/2014/main" id="{A65400F7-27C0-48D5-9AD8-6E6ECB8451AD}"/>
+              </a:ext>
+            </a:extLst>
+          </p:cNvPr>
+          <p:cNvSpPr>
+            <a:spLocks xmlns:a="http://schemas.openxmlformats.org/drawingml/2006/main" noGrp="1"/>
+          </p:cNvSpPr>
+          <p:nvPr/>
+        </p:nvSpPr>
+        <p:spPr>
+          <a:xfrm xmlns:a="http://schemas.openxmlformats.org/drawingml/2006/main">
+            <a:off x="1188720" y="4032504"/>
+            <a:ext cx="4754880" cy="384048"/>
+          </a:xfrm>
+          <a:prstGeom xmlns:a="http://schemas.openxmlformats.org/drawingml/2006/main" prst="rect">
+            <a:avLst/>
+          </a:prstGeom>
+          <a:noFill xmlns:a="http://schemas.openxmlformats.org/drawingml/2006/main"/>
+        </p:spPr>
+        <p:txBody>
+          <a:bodyPr xmlns:a="http://schemas.openxmlformats.org/drawingml/2006/main" wrap="square" lIns="0" tIns="0" rIns="0" bIns="0" anchor="t"/>
+          <a:lstStyle xmlns:a="http://schemas.openxmlformats.org/drawingml/2006/main"/>
+          <a:p xmlns:a="http://schemas.openxmlformats.org/drawingml/2006/main">
+            <a:pPr marL="0" indent="0">
+              <a:buNone/>
+            </a:pPr>
+            <a:r>
+              <a:rPr sz="1200">
+                <a:solidFill>
+                  <a:schemeClr val="bg2"/>
+                </a:solidFill>
+              </a:rPr>
+              <a:t>Recalibrate on Mexican data (ENSANUT) and benchmark s390x at scale</a:t>
+            </a:r>
+            <a:endParaRPr sz="1200"/>
+          </a:p>
+        </p:txBody>
+      </p:sp>
+      <p:sp>
+        <p:nvSpPr>
+          <p:cNvPr id="23" name="conector">
+            <a:extLst xmlns:a="http://schemas.openxmlformats.org/drawingml/2006/main">
+              <a:ext uri="{FF2B5EF4-FFF2-40B4-BE49-F238E27FC236}">
+                <a16:creationId xmlns:a16="http://schemas.microsoft.com/office/drawing/2014/main" id="{88745128-50ED-4238-8ABF-DC68B8212344}"/>
+              </a:ext>
+            </a:extLst>
+          </p:cNvPr>
+          <p:cNvSpPr>
+            <a:spLocks xmlns:a="http://schemas.openxmlformats.org/drawingml/2006/main" noGrp="1"/>
+          </p:cNvSpPr>
+          <p:nvPr/>
+        </p:nvSpPr>
+        <p:spPr>
+          <a:xfrm xmlns:a="http://schemas.openxmlformats.org/drawingml/2006/main">
+            <a:off x="777240" y="4992624"/>
+            <a:ext cx="0" cy="274320"/>
+          </a:xfrm>
+          <a:prstGeom xmlns:a="http://schemas.openxmlformats.org/drawingml/2006/main" prst="line">
+            <a:avLst/>
+          </a:prstGeom>
+          <a:noFill xmlns:a="http://schemas.openxmlformats.org/drawingml/2006/main"/>
+          <a:ln xmlns:a="http://schemas.openxmlformats.org/drawingml/2006/main" w="19050">
+            <a:solidFill>
+              <a:schemeClr val="accent5"/>
+            </a:solidFill>
+            <a:prstDash val="dash"/>
+          </a:ln>
+        </p:spPr>
+      </p:sp>
+      <p:sp>
+        <p:nvSpPr>
+          <p:cNvPr id="24" name="paso 3">
+            <a:extLst xmlns:a="http://schemas.openxmlformats.org/drawingml/2006/main">
+              <a:ext uri="{FF2B5EF4-FFF2-40B4-BE49-F238E27FC236}">
+                <a16:creationId xmlns:a16="http://schemas.microsoft.com/office/drawing/2014/main" id="{5AF7996F-81F4-41CB-9C00-2DBD9AF91D87}"/>
+              </a:ext>
+            </a:extLst>
+          </p:cNvPr>
+          <p:cNvSpPr>
+            <a:spLocks xmlns:a="http://schemas.openxmlformats.org/drawingml/2006/main" noGrp="1"/>
+          </p:cNvSpPr>
+          <p:nvPr/>
+        </p:nvSpPr>
+        <p:spPr>
+          <a:xfrm xmlns:a="http://schemas.openxmlformats.org/drawingml/2006/main">
+            <a:off x="548640" y="4517136"/>
+            <a:ext cx="457200" cy="457200"/>
+          </a:xfrm>
+          <a:prstGeom xmlns:a="http://schemas.openxmlformats.org/drawingml/2006/main" prst="ellipse">
+            <a:avLst/>
+          </a:prstGeom>
+          <a:solidFill xmlns:a="http://schemas.openxmlformats.org/drawingml/2006/main">
+            <a:schemeClr val="accent1"/>
+          </a:solidFill>
+        </p:spPr>
+      </p:sp>
+      <p:sp>
+        <p:nvSpPr>
+          <p:cNvPr id="25" name="Text 23">
+            <a:extLst xmlns:a="http://schemas.openxmlformats.org/drawingml/2006/main">
+              <a:ext uri="{FF2B5EF4-FFF2-40B4-BE49-F238E27FC236}">
+                <a16:creationId xmlns:a16="http://schemas.microsoft.com/office/drawing/2014/main" id="{8EFC69D7-A5A6-41F6-A5A0-E3FB688FE902}"/>
+              </a:ext>
+            </a:extLst>
+          </p:cNvPr>
+          <p:cNvSpPr>
+            <a:spLocks xmlns:a="http://schemas.openxmlformats.org/drawingml/2006/main" noGrp="1"/>
+          </p:cNvSpPr>
+          <p:nvPr/>
+        </p:nvSpPr>
+        <p:spPr>
+          <a:xfrm xmlns:a="http://schemas.openxmlformats.org/drawingml/2006/main">
+            <a:off x="548640" y="4517136"/>
+            <a:ext cx="457200" cy="457200"/>
+          </a:xfrm>
+          <a:prstGeom xmlns:a="http://schemas.openxmlformats.org/drawingml/2006/main" prst="rect">
+            <a:avLst/>
+          </a:prstGeom>
+          <a:noFill xmlns:a="http://schemas.openxmlformats.org/drawingml/2006/main"/>
+        </p:spPr>
+        <p:txBody>
+          <a:bodyPr xmlns:a="http://schemas.openxmlformats.org/drawingml/2006/main" wrap="square" lIns="0" tIns="0" rIns="0" bIns="0" anchor="ctr"/>
+          <a:lstStyle xmlns:a="http://schemas.openxmlformats.org/drawingml/2006/main"/>
+          <a:p xmlns:a="http://schemas.openxmlformats.org/drawingml/2006/main">
+            <a:pPr marL="0" indent="0" algn="ctr">
+              <a:buNone/>
+            </a:pPr>
+            <a:r>
+              <a:rPr sz="1600" b="1">
+                <a:solidFill>
+                  <a:schemeClr val="bg1"/>
+                </a:solidFill>
+              </a:rPr>
+              <a:t>3</a:t>
+            </a:r>
+            <a:endParaRPr sz="1600"/>
+          </a:p>
+        </p:txBody>
+      </p:sp>
+      <p:sp>
+        <p:nvSpPr>
+          <p:cNvPr id="26" name="Text 24">
+            <a:extLst xmlns:a="http://schemas.openxmlformats.org/drawingml/2006/main">
+              <a:ext uri="{FF2B5EF4-FFF2-40B4-BE49-F238E27FC236}">
+                <a16:creationId xmlns:a16="http://schemas.microsoft.com/office/drawing/2014/main" id="{B276AEAC-162E-422A-9703-217C1CBAD153}"/>
+              </a:ext>
+            </a:extLst>
+          </p:cNvPr>
+          <p:cNvSpPr>
+            <a:spLocks xmlns:a="http://schemas.openxmlformats.org/drawingml/2006/main" noGrp="1"/>
+          </p:cNvSpPr>
+          <p:nvPr/>
+        </p:nvSpPr>
+        <p:spPr>
+          <a:xfrm xmlns:a="http://schemas.openxmlformats.org/drawingml/2006/main">
+            <a:off x="1188720" y="4489704"/>
+            <a:ext cx="4754880" cy="292608"/>
+          </a:xfrm>
+          <a:prstGeom xmlns:a="http://schemas.openxmlformats.org/drawingml/2006/main" prst="rect">
+            <a:avLst/>
+          </a:prstGeom>
+          <a:noFill xmlns:a="http://schemas.openxmlformats.org/drawingml/2006/main"/>
+        </p:spPr>
+        <p:txBody>
+          <a:bodyPr xmlns:a="http://schemas.openxmlformats.org/drawingml/2006/main" wrap="square" lIns="0" tIns="0" rIns="0" bIns="0" anchor="ctr"/>
+          <a:lstStyle xmlns:a="http://schemas.openxmlformats.org/drawingml/2006/main"/>
+          <a:p xmlns:a="http://schemas.openxmlformats.org/drawingml/2006/main">
+            <a:pPr marL="0" indent="0">
+              <a:buNone/>
+            </a:pPr>
+            <a:r>
+              <a:rPr sz="1400" b="1">
+                <a:solidFill>
+                  <a:schemeClr val="bg1"/>
+                </a:solidFill>
+              </a:rPr>
+              <a:t>Q2 2027 · Hospital pilot</a:t>
+            </a:r>
+            <a:endParaRPr sz="1400"/>
+          </a:p>
+        </p:txBody>
+      </p:sp>
+      <p:sp>
+        <p:nvSpPr>
+          <p:cNvPr id="27" name="Text 25">
+            <a:extLst xmlns:a="http://schemas.openxmlformats.org/drawingml/2006/main">
+              <a:ext uri="{FF2B5EF4-FFF2-40B4-BE49-F238E27FC236}">
+                <a16:creationId xmlns:a16="http://schemas.microsoft.com/office/drawing/2014/main" id="{BB2C4072-759B-4306-8B51-29C31CD34B0B}"/>
+              </a:ext>
+            </a:extLst>
+          </p:cNvPr>
+          <p:cNvSpPr>
+            <a:spLocks xmlns:a="http://schemas.openxmlformats.org/drawingml/2006/main" noGrp="1"/>
+          </p:cNvSpPr>
+          <p:nvPr/>
+        </p:nvSpPr>
+        <p:spPr>
+          <a:xfrm xmlns:a="http://schemas.openxmlformats.org/drawingml/2006/main">
+            <a:off x="1188720" y="4782312"/>
+            <a:ext cx="4754880" cy="384048"/>
+          </a:xfrm>
+          <a:prstGeom xmlns:a="http://schemas.openxmlformats.org/drawingml/2006/main" prst="rect">
+            <a:avLst/>
+          </a:prstGeom>
+          <a:noFill xmlns:a="http://schemas.openxmlformats.org/drawingml/2006/main"/>
+        </p:spPr>
+        <p:txBody>
+          <a:bodyPr xmlns:a="http://schemas.openxmlformats.org/drawingml/2006/main" wrap="square" lIns="0" tIns="0" rIns="0" bIns="0" anchor="t"/>
+          <a:lstStyle xmlns:a="http://schemas.openxmlformats.org/drawingml/2006/main"/>
+          <a:p xmlns:a="http://schemas.openxmlformats.org/drawingml/2006/main">
+            <a:pPr marL="0" indent="0">
+              <a:buNone/>
+            </a:pPr>
+            <a:r>
+              <a:rPr sz="1200">
+                <a:solidFill>
+                  <a:schemeClr val="bg2"/>
+                </a:solidFill>
+              </a:rPr>
+              <a:t>Hospital container on site, risk service on LinuxONE; de-identified records</a:t>
+            </a:r>
+            <a:endParaRPr sz="1200"/>
+          </a:p>
+        </p:txBody>
+      </p:sp>
+      <p:sp>
+        <p:nvSpPr>
+          <p:cNvPr id="28" name="paso 4">
+            <a:extLst xmlns:a="http://schemas.openxmlformats.org/drawingml/2006/main">
+              <a:ext uri="{FF2B5EF4-FFF2-40B4-BE49-F238E27FC236}">
+                <a16:creationId xmlns:a16="http://schemas.microsoft.com/office/drawing/2014/main" id="{4E22729E-6EC3-4972-8B8C-CC0996F9CCF1}"/>
+              </a:ext>
+            </a:extLst>
+          </p:cNvPr>
+          <p:cNvSpPr>
+            <a:spLocks xmlns:a="http://schemas.openxmlformats.org/drawingml/2006/main" noGrp="1"/>
+          </p:cNvSpPr>
+          <p:nvPr/>
+        </p:nvSpPr>
+        <p:spPr>
+          <a:xfrm xmlns:a="http://schemas.openxmlformats.org/drawingml/2006/main">
+            <a:off x="548640" y="5266944"/>
+            <a:ext cx="457200" cy="457200"/>
+          </a:xfrm>
+          <a:prstGeom xmlns:a="http://schemas.openxmlformats.org/drawingml/2006/main" prst="ellipse">
+            <a:avLst/>
+          </a:prstGeom>
+          <a:solidFill xmlns:a="http://schemas.openxmlformats.org/drawingml/2006/main">
+            <a:schemeClr val="accent1"/>
+          </a:solidFill>
+        </p:spPr>
+      </p:sp>
+      <p:sp>
+        <p:nvSpPr>
+          <p:cNvPr id="29" name="Text 27">
+            <a:extLst xmlns:a="http://schemas.openxmlformats.org/drawingml/2006/main">
+              <a:ext uri="{FF2B5EF4-FFF2-40B4-BE49-F238E27FC236}">
+                <a16:creationId xmlns:a16="http://schemas.microsoft.com/office/drawing/2014/main" id="{67F8C2C1-D674-4FBA-BCF9-F6F8118DE65D}"/>
+              </a:ext>
+            </a:extLst>
+          </p:cNvPr>
+          <p:cNvSpPr>
+            <a:spLocks xmlns:a="http://schemas.openxmlformats.org/drawingml/2006/main" noGrp="1"/>
+          </p:cNvSpPr>
+          <p:nvPr/>
+        </p:nvSpPr>
+        <p:spPr>
+          <a:xfrm xmlns:a="http://schemas.openxmlformats.org/drawingml/2006/main">
+            <a:off x="548640" y="5266944"/>
+            <a:ext cx="457200" cy="457200"/>
+          </a:xfrm>
+          <a:prstGeom xmlns:a="http://schemas.openxmlformats.org/drawingml/2006/main" prst="rect">
+            <a:avLst/>
+          </a:prstGeom>
+          <a:noFill xmlns:a="http://schemas.openxmlformats.org/drawingml/2006/main"/>
+        </p:spPr>
+        <p:txBody>
+          <a:bodyPr xmlns:a="http://schemas.openxmlformats.org/drawingml/2006/main" wrap="square" lIns="0" tIns="0" rIns="0" bIns="0" anchor="ctr"/>
+          <a:lstStyle xmlns:a="http://schemas.openxmlformats.org/drawingml/2006/main"/>
+          <a:p xmlns:a="http://schemas.openxmlformats.org/drawingml/2006/main">
+            <a:pPr marL="0" indent="0" algn="ctr">
+              <a:buNone/>
+            </a:pPr>
+            <a:r>
+              <a:rPr sz="1600" b="1">
+                <a:solidFill>
+                  <a:schemeClr val="bg1"/>
+                </a:solidFill>
+              </a:rPr>
+              <a:t>4</a:t>
+            </a:r>
+            <a:endParaRPr sz="1600"/>
+          </a:p>
+        </p:txBody>
+      </p:sp>
+      <p:sp>
+        <p:nvSpPr>
+          <p:cNvPr id="30" name="Text 28">
+            <a:extLst xmlns:a="http://schemas.openxmlformats.org/drawingml/2006/main">
+              <a:ext uri="{FF2B5EF4-FFF2-40B4-BE49-F238E27FC236}">
+                <a16:creationId xmlns:a16="http://schemas.microsoft.com/office/drawing/2014/main" id="{2BBB1881-04FB-4CA5-BA21-4C92316E4731}"/>
+              </a:ext>
+            </a:extLst>
+          </p:cNvPr>
+          <p:cNvSpPr>
+            <a:spLocks xmlns:a="http://schemas.openxmlformats.org/drawingml/2006/main" noGrp="1"/>
+          </p:cNvSpPr>
+          <p:nvPr/>
+        </p:nvSpPr>
+        <p:spPr>
+          <a:xfrm xmlns:a="http://schemas.openxmlformats.org/drawingml/2006/main">
+            <a:off x="1188720" y="5239512"/>
+            <a:ext cx="4754880" cy="292608"/>
+          </a:xfrm>
+          <a:prstGeom xmlns:a="http://schemas.openxmlformats.org/drawingml/2006/main" prst="rect">
+            <a:avLst/>
+          </a:prstGeom>
+          <a:noFill xmlns:a="http://schemas.openxmlformats.org/drawingml/2006/main"/>
+        </p:spPr>
+        <p:txBody>
+          <a:bodyPr xmlns:a="http://schemas.openxmlformats.org/drawingml/2006/main" wrap="square" lIns="0" tIns="0" rIns="0" bIns="0" anchor="ctr"/>
+          <a:lstStyle xmlns:a="http://schemas.openxmlformats.org/drawingml/2006/main"/>
+          <a:p xmlns:a="http://schemas.openxmlformats.org/drawingml/2006/main">
+            <a:pPr marL="0" indent="0">
+              <a:buNone/>
+            </a:pPr>
+            <a:r>
+              <a:rPr sz="1400" b="1">
+                <a:solidFill>
+                  <a:schemeClr val="bg1"/>
+                </a:solidFill>
+              </a:rPr>
+              <a:t>Q4 2027 · Scale</a:t>
+            </a:r>
+            <a:endParaRPr sz="1400"/>
+          </a:p>
+        </p:txBody>
+      </p:sp>
+      <p:sp>
+        <p:nvSpPr>
+          <p:cNvPr id="31" name="Text 29">
+            <a:extLst xmlns:a="http://schemas.openxmlformats.org/drawingml/2006/main">
+              <a:ext uri="{FF2B5EF4-FFF2-40B4-BE49-F238E27FC236}">
+                <a16:creationId xmlns:a16="http://schemas.microsoft.com/office/drawing/2014/main" id="{0AB77F81-8D4C-467D-8AA3-42FE77048006}"/>
+              </a:ext>
+            </a:extLst>
+          </p:cNvPr>
+          <p:cNvSpPr>
+            <a:spLocks xmlns:a="http://schemas.openxmlformats.org/drawingml/2006/main" noGrp="1"/>
+          </p:cNvSpPr>
+          <p:nvPr/>
+        </p:nvSpPr>
+        <p:spPr>
+          <a:xfrm xmlns:a="http://schemas.openxmlformats.org/drawingml/2006/main">
+            <a:off x="1188720" y="5532120"/>
+            <a:ext cx="4754880" cy="384048"/>
+          </a:xfrm>
+          <a:prstGeom xmlns:a="http://schemas.openxmlformats.org/drawingml/2006/main" prst="rect">
+            <a:avLst/>
+          </a:prstGeom>
+          <a:noFill xmlns:a="http://schemas.openxmlformats.org/drawingml/2006/main"/>
+        </p:spPr>
+        <p:txBody>
+          <a:bodyPr xmlns:a="http://schemas.openxmlformats.org/drawingml/2006/main" wrap="square" lIns="0" tIns="0" rIns="0" bIns="0" anchor="t"/>
+          <a:lstStyle xmlns:a="http://schemas.openxmlformats.org/drawingml/2006/main"/>
+          <a:p xmlns:a="http://schemas.openxmlformats.org/drawingml/2006/main">
+            <a:pPr marL="0" indent="0">
+              <a:buNone/>
+            </a:pPr>
+            <a:r>
+              <a:rPr sz="1200">
+                <a:solidFill>
+                  <a:schemeClr val="bg2"/>
+                </a:solidFill>
+              </a:rPr>
+              <a:t>Non-linear models with CKKS, Granite explanations at the hospital, forecasts on LinuxONE</a:t>
+            </a:r>
+            <a:endParaRPr sz="1200"/>
+          </a:p>
+        </p:txBody>
+      </p:sp>
+      <p:sp>
+        <p:nvSpPr>
+          <p:cNvPr id="32" name="Text 30">
+            <a:extLst xmlns:a="http://schemas.openxmlformats.org/drawingml/2006/main">
+              <a:ext uri="{FF2B5EF4-FFF2-40B4-BE49-F238E27FC236}">
+                <a16:creationId xmlns:a16="http://schemas.microsoft.com/office/drawing/2014/main" id="{7FEF0A0A-7ACA-4D2B-A43E-82C24CE44D1D}"/>
+              </a:ext>
+            </a:extLst>
+          </p:cNvPr>
+          <p:cNvSpPr>
+            <a:spLocks xmlns:a="http://schemas.openxmlformats.org/drawingml/2006/main" noGrp="1"/>
+          </p:cNvSpPr>
+          <p:nvPr/>
+        </p:nvSpPr>
+        <p:spPr>
+          <a:xfrm xmlns:a="http://schemas.openxmlformats.org/drawingml/2006/main">
+            <a:off x="6263640" y="3017520"/>
+            <a:ext cx="5376672" cy="274320"/>
+          </a:xfrm>
+          <a:prstGeom xmlns:a="http://schemas.openxmlformats.org/drawingml/2006/main" prst="rect">
+            <a:avLst/>
+          </a:prstGeom>
+          <a:noFill xmlns:a="http://schemas.openxmlformats.org/drawingml/2006/main"/>
+        </p:spPr>
+        <p:txBody>
+          <a:bodyPr xmlns:a="http://schemas.openxmlformats.org/drawingml/2006/main" wrap="square" lIns="0" tIns="0" rIns="0" bIns="0" anchor="t"/>
+          <a:lstStyle xmlns:a="http://schemas.openxmlformats.org/drawingml/2006/main"/>
+          <a:p xmlns:a="http://schemas.openxmlformats.org/drawingml/2006/main">
+            <a:pPr marL="0" indent="0">
+              <a:buNone/>
+            </a:pPr>
+            <a:r>
+              <a:rPr sz="1100" b="1" spc="100">
+                <a:solidFill>
+                  <a:schemeClr val="accent5"/>
+                </a:solidFill>
+              </a:rPr>
+              <a:t>WHAT IT TAKES</a:t>
+            </a:r>
+            <a:endParaRPr sz="1100"/>
+          </a:p>
+        </p:txBody>
+      </p:sp>
+      <p:sp>
+        <p:nvSpPr>
+          <p:cNvPr id="33" name="Métricas">
+            <a:extLst xmlns:a="http://schemas.openxmlformats.org/drawingml/2006/main">
+              <a:ext uri="{FF2B5EF4-FFF2-40B4-BE49-F238E27FC236}">
+                <a16:creationId xmlns:a16="http://schemas.microsoft.com/office/drawing/2014/main" id="{EC880691-5CEA-45FE-920D-8D3CC074F18D}"/>
+              </a:ext>
+            </a:extLst>
+          </p:cNvPr>
+          <p:cNvSpPr>
+            <a:spLocks xmlns:a="http://schemas.openxmlformats.org/drawingml/2006/main" noGrp="1"/>
+          </p:cNvSpPr>
+          <p:nvPr/>
+        </p:nvSpPr>
+        <p:spPr>
+          <a:xfrm xmlns:a="http://schemas.openxmlformats.org/drawingml/2006/main">
+            <a:off x="6263640" y="3383280"/>
+            <a:ext cx="5376672" cy="1078992"/>
+          </a:xfrm>
+          <a:prstGeom xmlns:a="http://schemas.openxmlformats.org/drawingml/2006/main" prst="roundRect">
+            <a:avLst>
+              <a:gd name="adj" fmla="val 8475"/>
+            </a:avLst>
+          </a:prstGeom>
+          <a:solidFill xmlns:a="http://schemas.openxmlformats.org/drawingml/2006/main">
+            <a:schemeClr val="accent2">
+              <a:alpha val="15000"/>
+            </a:schemeClr>
+          </a:solidFill>
+          <a:ln xmlns:a="http://schemas.openxmlformats.org/drawingml/2006/main" w="9525">
+            <a:solidFill>
+              <a:schemeClr val="accent2">
+                <a:alpha val="70000"/>
+              </a:schemeClr>
+            </a:solidFill>
+            <a:prstDash val="solid"/>
+          </a:ln>
+        </p:spPr>
+      </p:sp>
+      <p:sp>
+        <p:nvSpPr>
+          <p:cNvPr id="34" name="Métricas círculo">
+            <a:extLst xmlns:a="http://schemas.openxmlformats.org/drawingml/2006/main">
+              <a:ext uri="{FF2B5EF4-FFF2-40B4-BE49-F238E27FC236}">
+                <a16:creationId xmlns:a16="http://schemas.microsoft.com/office/drawing/2014/main" id="{A3ABE300-192A-40E0-82FA-2BFC08D29B68}"/>
+              </a:ext>
+            </a:extLst>
+          </p:cNvPr>
+          <p:cNvSpPr>
+            <a:spLocks xmlns:a="http://schemas.openxmlformats.org/drawingml/2006/main" noGrp="1"/>
+          </p:cNvSpPr>
+          <p:nvPr/>
+        </p:nvSpPr>
+        <p:spPr>
+          <a:xfrm xmlns:a="http://schemas.openxmlformats.org/drawingml/2006/main">
+            <a:off x="6419088" y="3657600"/>
+            <a:ext cx="530352" cy="530352"/>
+          </a:xfrm>
+          <a:prstGeom xmlns:a="http://schemas.openxmlformats.org/drawingml/2006/main" prst="ellipse">
+            <a:avLst/>
+          </a:prstGeom>
+          <a:solidFill xmlns:a="http://schemas.openxmlformats.org/drawingml/2006/main">
+            <a:schemeClr val="accent2"/>
+          </a:solidFill>
+        </p:spPr>
+      </p:sp>
+      <p:pic>
+        <p:nvPicPr>
+          <p:cNvPr id="35" name="Métricas ícono">
+            <a:extLst xmlns:a="http://schemas.openxmlformats.org/drawingml/2006/main">
+              <a:ext uri="{FF2B5EF4-FFF2-40B4-BE49-F238E27FC236}">
+                <a16:creationId xmlns:a16="http://schemas.microsoft.com/office/drawing/2014/main" id="{93A76CF4-6837-4974-9A8F-11030472E5D5}"/>
+              </a:ext>
+            </a:extLst>
+          </p:cNvPr>
+          <p:cNvPicPr>
+            <a:picLocks xmlns:a="http://schemas.openxmlformats.org/drawingml/2006/main" noChangeAspect="1"/>
+          </p:cNvPicPr>
+          <p:nvPr/>
+        </p:nvPicPr>
+        <p:blipFill>
+          <a:blip xmlns:r="http://schemas.openxmlformats.org/officeDocument/2006/relationships" xmlns:a="http://schemas.openxmlformats.org/drawingml/2006/main" r:embed="Rfc0de45e0c384224"/>
+          <a:stretch xmlns:a="http://schemas.openxmlformats.org/drawingml/2006/main">
+            <a:fillRect l="0" t="0" r="0" b="0"/>
+          </a:stretch>
+        </p:blipFill>
+        <p:spPr>
+          <a:xfrm xmlns:a="http://schemas.openxmlformats.org/drawingml/2006/main">
+            <a:off x="6535765" y="3774277"/>
+            <a:ext cx="296997" cy="296997"/>
+          </a:xfrm>
+          <a:prstGeom xmlns:a="http://schemas.openxmlformats.org/drawingml/2006/main" prst="rect">
+            <a:avLst/>
+          </a:prstGeom>
+        </p:spPr>
+      </p:pic>
+      <p:sp>
+        <p:nvSpPr>
+          <p:cNvPr id="36" name="Text 33">
+            <a:extLst xmlns:a="http://schemas.openxmlformats.org/drawingml/2006/main">
+              <a:ext uri="{FF2B5EF4-FFF2-40B4-BE49-F238E27FC236}">
+                <a16:creationId xmlns:a16="http://schemas.microsoft.com/office/drawing/2014/main" id="{D8184D06-E015-45DA-8D6C-65FA5A71592C}"/>
+              </a:ext>
+            </a:extLst>
+          </p:cNvPr>
+          <p:cNvSpPr>
+            <a:spLocks xmlns:a="http://schemas.openxmlformats.org/drawingml/2006/main" noGrp="1"/>
+          </p:cNvSpPr>
+          <p:nvPr/>
+        </p:nvSpPr>
+        <p:spPr>
+          <a:xfrm xmlns:a="http://schemas.openxmlformats.org/drawingml/2006/main">
+            <a:off x="7114032" y="3493008"/>
+            <a:ext cx="4389120" cy="329184"/>
+          </a:xfrm>
+          <a:prstGeom xmlns:a="http://schemas.openxmlformats.org/drawingml/2006/main" prst="rect">
+            <a:avLst/>
+          </a:prstGeom>
+          <a:noFill xmlns:a="http://schemas.openxmlformats.org/drawingml/2006/main"/>
+        </p:spPr>
+        <p:txBody>
+          <a:bodyPr xmlns:a="http://schemas.openxmlformats.org/drawingml/2006/main" wrap="square" lIns="0" tIns="0" rIns="0" bIns="0" anchor="ctr"/>
+          <a:lstStyle xmlns:a="http://schemas.openxmlformats.org/drawingml/2006/main"/>
+          <a:p xmlns:a="http://schemas.openxmlformats.org/drawingml/2006/main">
+            <a:pPr marL="0" indent="0">
+              <a:buNone/>
+            </a:pPr>
+            <a:r>
+              <a:rPr sz="1500" b="1">
+                <a:solidFill>
+                  <a:schemeClr val="bg1"/>
+                </a:solidFill>
+              </a:rPr>
+              <a:t>Partners</a:t>
+            </a:r>
+            <a:endParaRPr sz="1500"/>
+          </a:p>
+        </p:txBody>
+      </p:sp>
+      <p:sp>
+        <p:nvSpPr>
+          <p:cNvPr id="37" name="Text 34">
+            <a:extLst xmlns:a="http://schemas.openxmlformats.org/drawingml/2006/main">
+              <a:ext uri="{FF2B5EF4-FFF2-40B4-BE49-F238E27FC236}">
+                <a16:creationId xmlns:a16="http://schemas.microsoft.com/office/drawing/2014/main" id="{8CF8D52A-8C74-4D4F-B439-458EBCBF7362}"/>
+              </a:ext>
+            </a:extLst>
+          </p:cNvPr>
+          <p:cNvSpPr>
+            <a:spLocks xmlns:a="http://schemas.openxmlformats.org/drawingml/2006/main" noGrp="1"/>
+          </p:cNvSpPr>
+          <p:nvPr/>
+        </p:nvSpPr>
+        <p:spPr>
+          <a:xfrm xmlns:a="http://schemas.openxmlformats.org/drawingml/2006/main">
+            <a:off x="7114032" y="3840480"/>
+            <a:ext cx="4389120" cy="566928"/>
+          </a:xfrm>
+          <a:prstGeom xmlns:a="http://schemas.openxmlformats.org/drawingml/2006/main" prst="rect">
+            <a:avLst/>
+          </a:prstGeom>
+          <a:noFill xmlns:a="http://schemas.openxmlformats.org/drawingml/2006/main"/>
+        </p:spPr>
+        <p:txBody>
+          <a:bodyPr xmlns:a="http://schemas.openxmlformats.org/drawingml/2006/main" wrap="square" lIns="0" tIns="0" rIns="0" bIns="0" anchor="t"/>
+          <a:lstStyle xmlns:a="http://schemas.openxmlformats.org/drawingml/2006/main"/>
+          <a:p xmlns:a="http://schemas.openxmlformats.org/drawingml/2006/main">
+            <a:pPr marL="0" indent="0">
+              <a:buNone/>
+            </a:pPr>
+            <a:r>
+              <a:rPr sz="1200">
+                <a:solidFill>
+                  <a:schemeClr val="bg2"/>
+                </a:solidFill>
+              </a:rPr>
+              <a:t>A public hospital or clinic network for the pilot, LinuxONE capacity and a sourced unit cost for budgets.</a:t>
+            </a:r>
+            <a:endParaRPr sz="1200"/>
+          </a:p>
+        </p:txBody>
+      </p:sp>
+      <p:sp>
+        <p:nvSpPr>
+          <p:cNvPr id="38" name="Límites">
+            <a:extLst xmlns:a="http://schemas.openxmlformats.org/drawingml/2006/main">
+              <a:ext uri="{FF2B5EF4-FFF2-40B4-BE49-F238E27FC236}">
+                <a16:creationId xmlns:a16="http://schemas.microsoft.com/office/drawing/2014/main" id="{5C92B429-B5E6-48F6-9A8C-549EB31593BF}"/>
+              </a:ext>
+            </a:extLst>
+          </p:cNvPr>
+          <p:cNvSpPr>
+            <a:spLocks xmlns:a="http://schemas.openxmlformats.org/drawingml/2006/main" noGrp="1"/>
+          </p:cNvSpPr>
+          <p:nvPr/>
+        </p:nvSpPr>
+        <p:spPr>
+          <a:xfrm xmlns:a="http://schemas.openxmlformats.org/drawingml/2006/main">
+            <a:off x="6263640" y="4590288"/>
+            <a:ext cx="5376672" cy="1078992"/>
+          </a:xfrm>
+          <a:prstGeom xmlns:a="http://schemas.openxmlformats.org/drawingml/2006/main" prst="roundRect">
+            <a:avLst>
+              <a:gd name="adj" fmla="val 8475"/>
+            </a:avLst>
+          </a:prstGeom>
+          <a:solidFill xmlns:a="http://schemas.openxmlformats.org/drawingml/2006/main">
+            <a:schemeClr val="accent4">
+              <a:alpha val="15000"/>
+            </a:schemeClr>
+          </a:solidFill>
+          <a:ln xmlns:a="http://schemas.openxmlformats.org/drawingml/2006/main" w="9525">
+            <a:solidFill>
+              <a:schemeClr val="accent4">
+                <a:alpha val="70000"/>
+              </a:schemeClr>
+            </a:solidFill>
+            <a:prstDash val="solid"/>
+          </a:ln>
+        </p:spPr>
+      </p:sp>
+      <p:sp>
+        <p:nvSpPr>
+          <p:cNvPr id="39" name="Límites círculo">
+            <a:extLst xmlns:a="http://schemas.openxmlformats.org/drawingml/2006/main">
+              <a:ext uri="{FF2B5EF4-FFF2-40B4-BE49-F238E27FC236}">
+                <a16:creationId xmlns:a16="http://schemas.microsoft.com/office/drawing/2014/main" id="{E4AA23A6-055A-4D05-9959-328F73D3878A}"/>
+              </a:ext>
+            </a:extLst>
+          </p:cNvPr>
+          <p:cNvSpPr>
+            <a:spLocks xmlns:a="http://schemas.openxmlformats.org/drawingml/2006/main" noGrp="1"/>
+          </p:cNvSpPr>
+          <p:nvPr/>
+        </p:nvSpPr>
+        <p:spPr>
+          <a:xfrm xmlns:a="http://schemas.openxmlformats.org/drawingml/2006/main">
+            <a:off x="6419088" y="4864608"/>
+            <a:ext cx="530352" cy="530352"/>
+          </a:xfrm>
+          <a:prstGeom xmlns:a="http://schemas.openxmlformats.org/drawingml/2006/main" prst="ellipse">
+            <a:avLst/>
+          </a:prstGeom>
+          <a:solidFill xmlns:a="http://schemas.openxmlformats.org/drawingml/2006/main">
+            <a:schemeClr val="accent4"/>
+          </a:solidFill>
+        </p:spPr>
+      </p:sp>
+      <p:pic>
+        <p:nvPicPr>
+          <p:cNvPr id="40" name="Límites ícono">
+            <a:extLst xmlns:a="http://schemas.openxmlformats.org/drawingml/2006/main">
+              <a:ext uri="{FF2B5EF4-FFF2-40B4-BE49-F238E27FC236}">
+                <a16:creationId xmlns:a16="http://schemas.microsoft.com/office/drawing/2014/main" id="{095FC878-48BA-4748-B77E-322C211299C6}"/>
+              </a:ext>
+            </a:extLst>
+          </p:cNvPr>
+          <p:cNvPicPr>
+            <a:picLocks xmlns:a="http://schemas.openxmlformats.org/drawingml/2006/main" noChangeAspect="1"/>
+          </p:cNvPicPr>
+          <p:nvPr/>
+        </p:nvPicPr>
+        <p:blipFill>
+          <a:blip xmlns:r="http://schemas.openxmlformats.org/officeDocument/2006/relationships" xmlns:a="http://schemas.openxmlformats.org/drawingml/2006/main" r:embed="R8e1cb59c3188473c"/>
+          <a:stretch xmlns:a="http://schemas.openxmlformats.org/drawingml/2006/main">
+            <a:fillRect l="0" t="0" r="0" b="0"/>
+          </a:stretch>
+        </p:blipFill>
+        <p:spPr>
+          <a:xfrm xmlns:a="http://schemas.openxmlformats.org/drawingml/2006/main">
+            <a:off x="6535765" y="4981285"/>
+            <a:ext cx="296997" cy="296997"/>
+          </a:xfrm>
+          <a:prstGeom xmlns:a="http://schemas.openxmlformats.org/drawingml/2006/main" prst="rect">
+            <a:avLst/>
+          </a:prstGeom>
+        </p:spPr>
+      </p:pic>
+      <p:sp>
+        <p:nvSpPr>
+          <p:cNvPr id="41" name="Text 37">
+            <a:extLst xmlns:a="http://schemas.openxmlformats.org/drawingml/2006/main">
+              <a:ext uri="{FF2B5EF4-FFF2-40B4-BE49-F238E27FC236}">
+                <a16:creationId xmlns:a16="http://schemas.microsoft.com/office/drawing/2014/main" id="{16742B53-8B34-4477-8001-76AC7441D4F1}"/>
+              </a:ext>
+            </a:extLst>
+          </p:cNvPr>
+          <p:cNvSpPr>
+            <a:spLocks xmlns:a="http://schemas.openxmlformats.org/drawingml/2006/main" noGrp="1"/>
+          </p:cNvSpPr>
+          <p:nvPr/>
+        </p:nvSpPr>
+        <p:spPr>
+          <a:xfrm xmlns:a="http://schemas.openxmlformats.org/drawingml/2006/main">
+            <a:off x="7114032" y="4700016"/>
+            <a:ext cx="4389120" cy="329184"/>
+          </a:xfrm>
+          <a:prstGeom xmlns:a="http://schemas.openxmlformats.org/drawingml/2006/main" prst="rect">
+            <a:avLst/>
+          </a:prstGeom>
+          <a:noFill xmlns:a="http://schemas.openxmlformats.org/drawingml/2006/main"/>
+        </p:spPr>
+        <p:txBody>
+          <a:bodyPr xmlns:a="http://schemas.openxmlformats.org/drawingml/2006/main" wrap="square" lIns="0" tIns="0" rIns="0" bIns="0" anchor="ctr"/>
+          <a:lstStyle xmlns:a="http://schemas.openxmlformats.org/drawingml/2006/main"/>
+          <a:p xmlns:a="http://schemas.openxmlformats.org/drawingml/2006/main">
+            <a:pPr marL="0" indent="0">
+              <a:buNone/>
+            </a:pPr>
+            <a:r>
+              <a:rPr sz="1500" b="1">
+                <a:solidFill>
+                  <a:schemeClr val="bg1"/>
+                </a:solidFill>
+              </a:rPr>
+              <a:t>Gates before clinical use</a:t>
+            </a:r>
+            <a:endParaRPr sz="1500"/>
+          </a:p>
+        </p:txBody>
+      </p:sp>
+      <p:sp>
+        <p:nvSpPr>
+          <p:cNvPr id="42" name="Text 38">
+            <a:extLst xmlns:a="http://schemas.openxmlformats.org/drawingml/2006/main">
+              <a:ext uri="{FF2B5EF4-FFF2-40B4-BE49-F238E27FC236}">
+                <a16:creationId xmlns:a16="http://schemas.microsoft.com/office/drawing/2014/main" id="{18408005-2C13-4A63-A10B-F3B3AA0B3E39}"/>
+              </a:ext>
+            </a:extLst>
+          </p:cNvPr>
+          <p:cNvSpPr>
+            <a:spLocks xmlns:a="http://schemas.openxmlformats.org/drawingml/2006/main" noGrp="1"/>
+          </p:cNvSpPr>
+          <p:nvPr/>
+        </p:nvSpPr>
+        <p:spPr>
+          <a:xfrm xmlns:a="http://schemas.openxmlformats.org/drawingml/2006/main">
+            <a:off x="7114032" y="5047488"/>
+            <a:ext cx="4389120" cy="566928"/>
+          </a:xfrm>
+          <a:prstGeom xmlns:a="http://schemas.openxmlformats.org/drawingml/2006/main" prst="rect">
+            <a:avLst/>
+          </a:prstGeom>
+          <a:noFill xmlns:a="http://schemas.openxmlformats.org/drawingml/2006/main"/>
+        </p:spPr>
+        <p:txBody>
+          <a:bodyPr xmlns:a="http://schemas.openxmlformats.org/drawingml/2006/main" wrap="square" lIns="0" tIns="0" rIns="0" bIns="0" anchor="t"/>
+          <a:lstStyle xmlns:a="http://schemas.openxmlformats.org/drawingml/2006/main"/>
+          <a:p xmlns:a="http://schemas.openxmlformats.org/drawingml/2006/main">
+            <a:pPr marL="0" indent="0">
+              <a:buNone/>
+            </a:pPr>
+            <a:r>
+              <a:rPr sz="1200">
+                <a:solidFill>
+                  <a:schemeClr val="bg2"/>
+                </a:solidFill>
+              </a:rPr>
+              <a:t>Clinical validation in Mexico, legal and privacy review, an independent security audit and a stronger host trust model.</a:t>
+            </a:r>
+            <a:endParaRPr sz="1200"/>
+          </a:p>
+        </p:txBody>
+      </p:sp>
+      <p:sp>
+        <p:nvSpPr>
+          <p:cNvPr id="43" name="Text 39">
+            <a:extLst xmlns:a="http://schemas.openxmlformats.org/drawingml/2006/main">
+              <a:ext uri="{FF2B5EF4-FFF2-40B4-BE49-F238E27FC236}">
+                <a16:creationId xmlns:a16="http://schemas.microsoft.com/office/drawing/2014/main" id="{33CB5153-62BB-444E-9C8B-7D05308C2B51}"/>
+              </a:ext>
+            </a:extLst>
+          </p:cNvPr>
+          <p:cNvSpPr>
+            <a:spLocks xmlns:a="http://schemas.openxmlformats.org/drawingml/2006/main" noGrp="1"/>
+          </p:cNvSpPr>
+          <p:nvPr/>
+        </p:nvSpPr>
+        <p:spPr>
+          <a:xfrm xmlns:a="http://schemas.openxmlformats.org/drawingml/2006/main">
+            <a:off x="548640" y="6089904"/>
+            <a:ext cx="11091672" cy="256032"/>
+          </a:xfrm>
+          <a:prstGeom xmlns:a="http://schemas.openxmlformats.org/drawingml/2006/main" prst="rect">
+            <a:avLst/>
+          </a:prstGeom>
+          <a:noFill xmlns:a="http://schemas.openxmlformats.org/drawingml/2006/main"/>
+        </p:spPr>
+        <p:txBody>
+          <a:bodyPr xmlns:a="http://schemas.openxmlformats.org/drawingml/2006/main" wrap="square" lIns="0" tIns="0" rIns="0" bIns="0" anchor="t"/>
+          <a:lstStyle xmlns:a="http://schemas.openxmlformats.org/drawingml/2006/main"/>
+          <a:p xmlns:a="http://schemas.openxmlformats.org/drawingml/2006/main">
+            <a:pPr marL="0" indent="0">
+              <a:buNone/>
+            </a:pPr>
+            <a:r>
+              <a:rPr sz="1000">
+                <a:solidFill>
+                  <a:schemeClr val="accent6"/>
+                </a:solidFill>
+              </a:rPr>
+              <a:t>A plan, not a commitment: dates assume partner access and funding.</a:t>
+            </a:r>
+            <a:endParaRPr sz="1000"/>
+          </a:p>
+        </p:txBody>
+      </p:sp>
+      <p:sp>
+        <p:nvSpPr>
+          <p:cNvPr id="44" name="Slide Number Placeholder 0">
+            <a:extLst xmlns:a="http://schemas.openxmlformats.org/drawingml/2006/main">
+              <a:ext uri="{FF2B5EF4-FFF2-40B4-BE49-F238E27FC236}">
+                <a16:creationId xmlns:a16="http://schemas.microsoft.com/office/drawing/2014/main" id="{B14CA5A1-588A-4FE4-B866-557619FFB856}"/>
+              </a:ext>
+            </a:extLst>
+          </p:cNvPr>
+          <p:cNvSpPr>
+            <a:spLocks xmlns:a="http://schemas.openxmlformats.org/drawingml/2006/main" noGrp="1"/>
+          </p:cNvSpPr>
+          <p:nvPr>
+            <p:ph type="sldNum" idx="4294967295"/>
+          </p:nvPr>
+        </p:nvSpPr>
+        <p:spPr>
+          <a:xfrm xmlns:a="http://schemas.openxmlformats.org/drawingml/2006/main">
+            <a:off x="11183112" y="6400800"/>
+            <a:ext cx="457200" cy="274320"/>
+          </a:xfrm>
+          <a:prstGeom xmlns:a="http://schemas.openxmlformats.org/drawingml/2006/main" prst="rect">
+            <a:avLst/>
+          </a:prstGeom>
+        </p:spPr>
+        <p:txBody>
+          <a:bodyPr xmlns:a="http://schemas.openxmlformats.org/drawingml/2006/main"/>
+          <a:lstStyle xmlns:a="http://schemas.openxmlformats.org/drawingml/2006/main">
+            <a:lvl1pPr>
+              <a:buNone/>
+              <a:defRPr sz="900">
+                <a:solidFill>
+                  <a:schemeClr val="accent6"/>
+                </a:solidFill>
+              </a:defRPr>
+            </a:lvl1pPr>
+          </a:lstStyle>
+          <a:p xmlns:a="http://schemas.openxmlformats.org/drawingml/2006/main">
+            <a:pPr algn="r">
+              <a:buNone/>
+            </a:pPr>
+            <a:fld id="{F7021451-1387-4CA6-816F-3879F97B5CBC}" type="slidenum">
+              <a:rPr b="0"/>
+              <a:t>9</a:t>
+            </a:fld>
+            <a:endParaRPr/>
+          </a:p>
+        </p:txBody>
+      </p:sp>
+    </p:spTree>
+    <p:extLst>
+      <p:ext uri="{BB962C8B-B14F-4D97-AF65-F5344CB8AC3E}">
+        <p14:creationId xmlns:p14="http://schemas.microsoft.com/office/powerpoint/2010/main" val="714427936"/>
       </p:ext>
     </p:extLst>
   </p:cSld>
@@ -11925,7 +13742,7 @@
                   <a:schemeClr val="accent5"/>
                 </a:solidFill>
               </a:rPr>
-              <a:t>07 · IMPACT · AI FOR GOOD</a:t>
+              <a:t>09 · IMPACT · AI FOR GOOD</a:t>
             </a:r>
             <a:endParaRPr sz="1200"/>
           </a:p>
@@ -12976,7 +14793,7 @@
             </a:pPr>
             <a:fld id="{F7021451-1387-4CA6-816F-3879F97B5CBC}" type="slidenum">
               <a:rPr b="0"/>
-              <a:t>8</a:t>
+              <a:t>10</a:t>
             </a:fld>
             <a:endParaRPr/>
           </a:p>
@@ -12986,6 +14803,977 @@
     <p:extLst>
       <p:ext uri="{BB962C8B-B14F-4D97-AF65-F5344CB8AC3E}">
         <p14:creationId xmlns:p14="http://schemas.microsoft.com/office/powerpoint/2010/main" val="1008111892"/>
+      </p:ext>
+    </p:extLst>
+  </p:cSld>
+</p:sld>
+</file>
+
+<file path=ppt/slides/slide9.xml><?xml version="1.0" encoding="utf-8"?>
+<p:sld xmlns:p="http://schemas.openxmlformats.org/presentationml/2006/main">
+  <p:cSld>
+    <p:spTree>
+      <p:nvGrpSpPr>
+        <p:cNvPr id="1" name=""/>
+        <p:cNvGrpSpPr/>
+        <p:nvPr/>
+      </p:nvGrpSpPr>
+      <p:grpSpPr>
+        <a:xfrm xmlns:a="http://schemas.openxmlformats.org/drawingml/2006/main"/>
+      </p:grpSpPr>
+      <p:sp>
+        <p:nvSpPr>
+          <p:cNvPr id="2" name="Text 1">
+            <a:extLst xmlns:a="http://schemas.openxmlformats.org/drawingml/2006/main">
+              <a:ext uri="{FF2B5EF4-FFF2-40B4-BE49-F238E27FC236}">
+                <a16:creationId xmlns:a16="http://schemas.microsoft.com/office/drawing/2014/main" id="{AB675727-45C6-4D40-A1C1-EE3223BF19F8}"/>
+              </a:ext>
+            </a:extLst>
+          </p:cNvPr>
+          <p:cNvSpPr>
+            <a:spLocks xmlns:a="http://schemas.openxmlformats.org/drawingml/2006/main" noGrp="1"/>
+          </p:cNvSpPr>
+          <p:nvPr>
+            <p:ph type="body" idx="101" hasCustomPrompt="1"/>
+          </p:nvPr>
+        </p:nvSpPr>
+        <p:spPr>
+          <a:xfrm xmlns:a="http://schemas.openxmlformats.org/drawingml/2006/main">
+            <a:off x="768096" y="411480"/>
+            <a:ext cx="8229600" cy="310896"/>
+          </a:xfrm>
+          <a:prstGeom xmlns:a="http://schemas.openxmlformats.org/drawingml/2006/main" prst="rect">
+            <a:avLst/>
+          </a:prstGeom>
+          <a:noFill xmlns:a="http://schemas.openxmlformats.org/drawingml/2006/main"/>
+        </p:spPr>
+        <p:txBody>
+          <a:bodyPr xmlns:a="http://schemas.openxmlformats.org/drawingml/2006/main" wrap="square" lIns="0" tIns="0" rIns="0" bIns="0" anchor="ctr"/>
+          <a:lstStyle xmlns:a="http://schemas.openxmlformats.org/drawingml/2006/main"/>
+          <a:p xmlns:a="http://schemas.openxmlformats.org/drawingml/2006/main">
+            <a:pPr marL="0" indent="0">
+              <a:buNone/>
+            </a:pPr>
+            <a:r>
+              <a:rPr sz="1200" b="1" spc="200">
+                <a:solidFill>
+                  <a:schemeClr val="accent5"/>
+                </a:solidFill>
+              </a:rPr>
+              <a:t>07 · TIME-SERIES FORECAST (E5)</a:t>
+            </a:r>
+            <a:endParaRPr sz="1200"/>
+          </a:p>
+        </p:txBody>
+      </p:sp>
+      <p:sp>
+        <p:nvSpPr>
+          <p:cNvPr id="3" name="Text 1">
+            <a:extLst xmlns:a="http://schemas.openxmlformats.org/drawingml/2006/main">
+              <a:ext uri="{FF2B5EF4-FFF2-40B4-BE49-F238E27FC236}">
+                <a16:creationId xmlns:a16="http://schemas.microsoft.com/office/drawing/2014/main" id="{7613E905-00E0-427C-AFCA-AC3A97BF44D2}"/>
+              </a:ext>
+            </a:extLst>
+          </p:cNvPr>
+          <p:cNvSpPr>
+            <a:spLocks xmlns:a="http://schemas.openxmlformats.org/drawingml/2006/main" noGrp="1"/>
+          </p:cNvSpPr>
+          <p:nvPr>
+            <p:ph type="title" idx="102" hasCustomPrompt="1"/>
+          </p:nvPr>
+        </p:nvSpPr>
+        <p:spPr>
+          <a:xfrm xmlns:a="http://schemas.openxmlformats.org/drawingml/2006/main">
+            <a:off x="548640" y="777240"/>
+            <a:ext cx="11091672" cy="731520"/>
+          </a:xfrm>
+          <a:prstGeom xmlns:a="http://schemas.openxmlformats.org/drawingml/2006/main" prst="rect">
+            <a:avLst/>
+          </a:prstGeom>
+          <a:noFill xmlns:a="http://schemas.openxmlformats.org/drawingml/2006/main"/>
+        </p:spPr>
+        <p:txBody>
+          <a:bodyPr xmlns:a="http://schemas.openxmlformats.org/drawingml/2006/main" wrap="square" lIns="0" tIns="0" rIns="0" bIns="0" anchor="t"/>
+          <a:lstStyle xmlns:a="http://schemas.openxmlformats.org/drawingml/2006/main"/>
+          <a:p xmlns:a="http://schemas.openxmlformats.org/drawingml/2006/main">
+            <a:pPr marL="0" indent="0" algn="l">
+              <a:buNone/>
+            </a:pPr>
+            <a:r>
+              <a:rPr sz="3000" b="1">
+                <a:solidFill>
+                  <a:schemeClr val="bg1"/>
+                </a:solidFill>
+              </a:rPr>
+              <a:t>Plan demand: weekly diabetes forecasts by state</a:t>
+            </a:r>
+            <a:endParaRPr sz="3000"/>
+          </a:p>
+        </p:txBody>
+      </p:sp>
+      <p:pic>
+        <p:nvPicPr>
+          <p:cNvPr id="4" name="Captura real de la demo">
+            <a:extLst xmlns:a="http://schemas.openxmlformats.org/drawingml/2006/main">
+              <a:ext uri="{FF2B5EF4-FFF2-40B4-BE49-F238E27FC236}">
+                <a16:creationId xmlns:a16="http://schemas.microsoft.com/office/drawing/2014/main" id="{9791C1D6-1D0E-4261-BC3F-109D1A7DA917}"/>
+              </a:ext>
+            </a:extLst>
+          </p:cNvPr>
+          <p:cNvPicPr>
+            <a:picLocks xmlns:a="http://schemas.openxmlformats.org/drawingml/2006/main" noChangeAspect="1"/>
+          </p:cNvPicPr>
+          <p:nvPr/>
+        </p:nvPicPr>
+        <p:blipFill>
+          <a:blip xmlns:r="http://schemas.openxmlformats.org/officeDocument/2006/relationships" xmlns:a="http://schemas.openxmlformats.org/drawingml/2006/main" r:embed="Re50bd47dc23f4fbe"/>
+          <a:stretch xmlns:a="http://schemas.openxmlformats.org/drawingml/2006/main"/>
+        </p:blipFill>
+        <p:spPr>
+          <a:xfrm xmlns:a="http://schemas.openxmlformats.org/drawingml/2006/main">
+            <a:off x="694748" y="1691640"/>
+            <a:ext cx="5633095" cy="4114800"/>
+          </a:xfrm>
+          <a:prstGeom xmlns:a="http://schemas.openxmlformats.org/drawingml/2006/main" prst="rect">
+            <a:avLst/>
+          </a:prstGeom>
+        </p:spPr>
+      </p:pic>
+      <p:sp>
+        <p:nvSpPr>
+          <p:cNvPr id="5" name="Text 2">
+            <a:extLst xmlns:a="http://schemas.openxmlformats.org/drawingml/2006/main">
+              <a:ext uri="{FF2B5EF4-FFF2-40B4-BE49-F238E27FC236}">
+                <a16:creationId xmlns:a16="http://schemas.microsoft.com/office/drawing/2014/main" id="{956218E3-8D87-4D95-B1BC-7374C4CB8593}"/>
+              </a:ext>
+            </a:extLst>
+          </p:cNvPr>
+          <p:cNvSpPr>
+            <a:spLocks xmlns:a="http://schemas.openxmlformats.org/drawingml/2006/main" noGrp="1"/>
+          </p:cNvSpPr>
+          <p:nvPr/>
+        </p:nvSpPr>
+        <p:spPr>
+          <a:xfrm xmlns:a="http://schemas.openxmlformats.org/drawingml/2006/main">
+            <a:off x="548640" y="5852160"/>
+            <a:ext cx="5925312" cy="256032"/>
+          </a:xfrm>
+          <a:prstGeom xmlns:a="http://schemas.openxmlformats.org/drawingml/2006/main" prst="rect">
+            <a:avLst/>
+          </a:prstGeom>
+          <a:noFill xmlns:a="http://schemas.openxmlformats.org/drawingml/2006/main"/>
+        </p:spPr>
+        <p:txBody>
+          <a:bodyPr xmlns:a="http://schemas.openxmlformats.org/drawingml/2006/main" wrap="square" lIns="0" tIns="0" rIns="0" bIns="0" anchor="t"/>
+          <a:lstStyle xmlns:a="http://schemas.openxmlformats.org/drawingml/2006/main"/>
+          <a:p xmlns:a="http://schemas.openxmlformats.org/drawingml/2006/main">
+            <a:pPr marL="0" indent="0">
+              <a:buNone/>
+            </a:pPr>
+            <a:r>
+              <a:rPr sz="1000">
+                <a:solidFill>
+                  <a:schemeClr val="accent6"/>
+                </a:solidFill>
+              </a:rPr>
+              <a:t>Live dashboard · Type 2 · national · all sexes · antimarrulla-tamizaje.netlify.app/forecast</a:t>
+            </a:r>
+            <a:endParaRPr sz="1000"/>
+          </a:p>
+        </p:txBody>
+      </p:sp>
+      <p:sp>
+        <p:nvSpPr>
+          <p:cNvPr id="6" name="2,000 de 2,000">
+            <a:extLst xmlns:a="http://schemas.openxmlformats.org/drawingml/2006/main">
+              <a:ext uri="{FF2B5EF4-FFF2-40B4-BE49-F238E27FC236}">
+                <a16:creationId xmlns:a16="http://schemas.microsoft.com/office/drawing/2014/main" id="{7CE73FB1-5AAE-44CE-9A90-D2568710A9C9}"/>
+              </a:ext>
+            </a:extLst>
+          </p:cNvPr>
+          <p:cNvSpPr>
+            <a:spLocks xmlns:a="http://schemas.openxmlformats.org/drawingml/2006/main" noGrp="1"/>
+          </p:cNvSpPr>
+          <p:nvPr/>
+        </p:nvSpPr>
+        <p:spPr>
+          <a:xfrm xmlns:a="http://schemas.openxmlformats.org/drawingml/2006/main">
+            <a:off x="6720840" y="1691640"/>
+            <a:ext cx="4919472" cy="877824"/>
+          </a:xfrm>
+          <a:prstGeom xmlns:a="http://schemas.openxmlformats.org/drawingml/2006/main" prst="roundRect">
+            <a:avLst>
+              <a:gd name="adj" fmla="val 10417"/>
+            </a:avLst>
+          </a:prstGeom>
+          <a:solidFill xmlns:a="http://schemas.openxmlformats.org/drawingml/2006/main">
+            <a:schemeClr val="accent1">
+              <a:alpha val="15000"/>
+            </a:schemeClr>
+          </a:solidFill>
+        </p:spPr>
+      </p:sp>
+      <p:sp>
+        <p:nvSpPr>
+          <p:cNvPr id="7" name="2,000 de 2,000 círculo">
+            <a:extLst xmlns:a="http://schemas.openxmlformats.org/drawingml/2006/main">
+              <a:ext uri="{FF2B5EF4-FFF2-40B4-BE49-F238E27FC236}">
+                <a16:creationId xmlns:a16="http://schemas.microsoft.com/office/drawing/2014/main" id="{4326DF7E-32FB-4955-B3B0-BCA4CF3D8F2A}"/>
+              </a:ext>
+            </a:extLst>
+          </p:cNvPr>
+          <p:cNvSpPr>
+            <a:spLocks xmlns:a="http://schemas.openxmlformats.org/drawingml/2006/main" noGrp="1"/>
+          </p:cNvSpPr>
+          <p:nvPr/>
+        </p:nvSpPr>
+        <p:spPr>
+          <a:xfrm xmlns:a="http://schemas.openxmlformats.org/drawingml/2006/main">
+            <a:off x="6858000" y="1874520"/>
+            <a:ext cx="512064" cy="512064"/>
+          </a:xfrm>
+          <a:prstGeom xmlns:a="http://schemas.openxmlformats.org/drawingml/2006/main" prst="ellipse">
+            <a:avLst/>
+          </a:prstGeom>
+          <a:solidFill xmlns:a="http://schemas.openxmlformats.org/drawingml/2006/main">
+            <a:schemeClr val="accent1"/>
+          </a:solidFill>
+        </p:spPr>
+      </p:sp>
+      <p:pic>
+        <p:nvPicPr>
+          <p:cNvPr id="8" name="2,000 de 2,000 ícono">
+            <a:extLst xmlns:a="http://schemas.openxmlformats.org/drawingml/2006/main">
+              <a:ext uri="{FF2B5EF4-FFF2-40B4-BE49-F238E27FC236}">
+                <a16:creationId xmlns:a16="http://schemas.microsoft.com/office/drawing/2014/main" id="{83EE3D52-7428-4BA5-94D8-80E06A68DC54}"/>
+              </a:ext>
+            </a:extLst>
+          </p:cNvPr>
+          <p:cNvPicPr>
+            <a:picLocks xmlns:a="http://schemas.openxmlformats.org/drawingml/2006/main" noChangeAspect="1"/>
+          </p:cNvPicPr>
+          <p:nvPr/>
+        </p:nvPicPr>
+        <p:blipFill>
+          <a:blip xmlns:r="http://schemas.openxmlformats.org/officeDocument/2006/relationships" xmlns:a="http://schemas.openxmlformats.org/drawingml/2006/main" r:embed="R32ced3a6cefc4d7f"/>
+          <a:stretch xmlns:a="http://schemas.openxmlformats.org/drawingml/2006/main">
+            <a:fillRect l="0" t="0" r="0" b="0"/>
+          </a:stretch>
+        </p:blipFill>
+        <p:spPr>
+          <a:xfrm xmlns:a="http://schemas.openxmlformats.org/drawingml/2006/main">
+            <a:off x="6970654" y="1987174"/>
+            <a:ext cx="286756" cy="286756"/>
+          </a:xfrm>
+          <a:prstGeom xmlns:a="http://schemas.openxmlformats.org/drawingml/2006/main" prst="rect">
+            <a:avLst/>
+          </a:prstGeom>
+        </p:spPr>
+      </p:pic>
+      <p:sp>
+        <p:nvSpPr>
+          <p:cNvPr id="9" name="Text 5">
+            <a:extLst xmlns:a="http://schemas.openxmlformats.org/drawingml/2006/main">
+              <a:ext uri="{FF2B5EF4-FFF2-40B4-BE49-F238E27FC236}">
+                <a16:creationId xmlns:a16="http://schemas.microsoft.com/office/drawing/2014/main" id="{E3248989-0352-4093-9B04-DD8173E6B903}"/>
+              </a:ext>
+            </a:extLst>
+          </p:cNvPr>
+          <p:cNvSpPr>
+            <a:spLocks xmlns:a="http://schemas.openxmlformats.org/drawingml/2006/main" noGrp="1"/>
+          </p:cNvSpPr>
+          <p:nvPr/>
+        </p:nvSpPr>
+        <p:spPr>
+          <a:xfrm xmlns:a="http://schemas.openxmlformats.org/drawingml/2006/main">
+            <a:off x="7498080" y="1746504"/>
+            <a:ext cx="4023360" cy="365760"/>
+          </a:xfrm>
+          <a:prstGeom xmlns:a="http://schemas.openxmlformats.org/drawingml/2006/main" prst="rect">
+            <a:avLst/>
+          </a:prstGeom>
+          <a:noFill xmlns:a="http://schemas.openxmlformats.org/drawingml/2006/main"/>
+        </p:spPr>
+        <p:txBody>
+          <a:bodyPr xmlns:a="http://schemas.openxmlformats.org/drawingml/2006/main" wrap="square" lIns="0" tIns="0" rIns="0" bIns="0" anchor="ctr"/>
+          <a:lstStyle xmlns:a="http://schemas.openxmlformats.org/drawingml/2006/main"/>
+          <a:p xmlns:a="http://schemas.openxmlformats.org/drawingml/2006/main">
+            <a:pPr marL="0" indent="0">
+              <a:buNone/>
+            </a:pPr>
+            <a:r>
+              <a:rPr sz="1700" b="1">
+                <a:solidFill>
+                  <a:schemeClr val="bg1"/>
+                </a:solidFill>
+              </a:rPr>
+              <a:t>222 weekly series</a:t>
+            </a:r>
+            <a:endParaRPr sz="1700"/>
+          </a:p>
+        </p:txBody>
+      </p:sp>
+      <p:sp>
+        <p:nvSpPr>
+          <p:cNvPr id="10" name="Text 6">
+            <a:extLst xmlns:a="http://schemas.openxmlformats.org/drawingml/2006/main">
+              <a:ext uri="{FF2B5EF4-FFF2-40B4-BE49-F238E27FC236}">
+                <a16:creationId xmlns:a16="http://schemas.microsoft.com/office/drawing/2014/main" id="{261B7668-C5D4-44B4-ABCE-9D21CA0C599A}"/>
+              </a:ext>
+            </a:extLst>
+          </p:cNvPr>
+          <p:cNvSpPr>
+            <a:spLocks xmlns:a="http://schemas.openxmlformats.org/drawingml/2006/main" noGrp="1"/>
+          </p:cNvSpPr>
+          <p:nvPr/>
+        </p:nvSpPr>
+        <p:spPr>
+          <a:xfrm xmlns:a="http://schemas.openxmlformats.org/drawingml/2006/main">
+            <a:off x="7498080" y="2112264"/>
+            <a:ext cx="4023360" cy="402336"/>
+          </a:xfrm>
+          <a:prstGeom xmlns:a="http://schemas.openxmlformats.org/drawingml/2006/main" prst="rect">
+            <a:avLst/>
+          </a:prstGeom>
+          <a:noFill xmlns:a="http://schemas.openxmlformats.org/drawingml/2006/main"/>
+        </p:spPr>
+        <p:txBody>
+          <a:bodyPr xmlns:a="http://schemas.openxmlformats.org/drawingml/2006/main" wrap="square" lIns="0" tIns="0" rIns="0" bIns="0" anchor="t"/>
+          <a:lstStyle xmlns:a="http://schemas.openxmlformats.org/drawingml/2006/main"/>
+          <a:p xmlns:a="http://schemas.openxmlformats.org/drawingml/2006/main">
+            <a:pPr marL="0" indent="0">
+              <a:buNone/>
+            </a:pPr>
+            <a:r>
+              <a:rPr sz="1100">
+                <a:solidFill>
+                  <a:schemeClr val="bg2"/>
+                </a:solidFill>
+              </a:rPr>
+              <a:t>T1/T2 × national, 4 regions and 32 states × men/women/all, reconciled top-down</a:t>
+            </a:r>
+            <a:endParaRPr sz="1100"/>
+          </a:p>
+        </p:txBody>
+      </p:sp>
+      <p:sp>
+        <p:nvSpPr>
+          <p:cNvPr id="11" name="SMAPE 13% national">
+            <a:extLst xmlns:a="http://schemas.openxmlformats.org/drawingml/2006/main">
+              <a:ext uri="{FF2B5EF4-FFF2-40B4-BE49-F238E27FC236}">
+                <a16:creationId xmlns:a16="http://schemas.microsoft.com/office/drawing/2014/main" id="{37D825E5-7C1D-48C8-9B91-B337403F2C6D}"/>
+              </a:ext>
+            </a:extLst>
+          </p:cNvPr>
+          <p:cNvSpPr>
+            <a:spLocks xmlns:a="http://schemas.openxmlformats.org/drawingml/2006/main" noGrp="1"/>
+          </p:cNvSpPr>
+          <p:nvPr/>
+        </p:nvSpPr>
+        <p:spPr>
+          <a:xfrm xmlns:a="http://schemas.openxmlformats.org/drawingml/2006/main">
+            <a:off x="6720840" y="2697480"/>
+            <a:ext cx="4919472" cy="877824"/>
+          </a:xfrm>
+          <a:prstGeom xmlns:a="http://schemas.openxmlformats.org/drawingml/2006/main" prst="roundRect">
+            <a:avLst>
+              <a:gd name="adj" fmla="val 10417"/>
+            </a:avLst>
+          </a:prstGeom>
+          <a:solidFill xmlns:a="http://schemas.openxmlformats.org/drawingml/2006/main">
+            <a:schemeClr val="accent1">
+              <a:alpha val="15000"/>
+            </a:schemeClr>
+          </a:solidFill>
+        </p:spPr>
+      </p:sp>
+      <p:sp>
+        <p:nvSpPr>
+          <p:cNvPr id="12" name="SMAPE 13% national círculo">
+            <a:extLst xmlns:a="http://schemas.openxmlformats.org/drawingml/2006/main">
+              <a:ext uri="{FF2B5EF4-FFF2-40B4-BE49-F238E27FC236}">
+                <a16:creationId xmlns:a16="http://schemas.microsoft.com/office/drawing/2014/main" id="{E00F4279-DA0D-497A-9FDF-78FC0146727F}"/>
+              </a:ext>
+            </a:extLst>
+          </p:cNvPr>
+          <p:cNvSpPr>
+            <a:spLocks xmlns:a="http://schemas.openxmlformats.org/drawingml/2006/main" noGrp="1"/>
+          </p:cNvSpPr>
+          <p:nvPr/>
+        </p:nvSpPr>
+        <p:spPr>
+          <a:xfrm xmlns:a="http://schemas.openxmlformats.org/drawingml/2006/main">
+            <a:off x="6858000" y="2880360"/>
+            <a:ext cx="512064" cy="512064"/>
+          </a:xfrm>
+          <a:prstGeom xmlns:a="http://schemas.openxmlformats.org/drawingml/2006/main" prst="ellipse">
+            <a:avLst/>
+          </a:prstGeom>
+          <a:solidFill xmlns:a="http://schemas.openxmlformats.org/drawingml/2006/main">
+            <a:schemeClr val="accent1"/>
+          </a:solidFill>
+        </p:spPr>
+      </p:sp>
+      <p:pic>
+        <p:nvPicPr>
+          <p:cNvPr id="13" name="SMAPE 13% national ícono">
+            <a:extLst xmlns:a="http://schemas.openxmlformats.org/drawingml/2006/main">
+              <a:ext uri="{FF2B5EF4-FFF2-40B4-BE49-F238E27FC236}">
+                <a16:creationId xmlns:a16="http://schemas.microsoft.com/office/drawing/2014/main" id="{80085199-5FD1-42CF-8586-4640A66E8539}"/>
+              </a:ext>
+            </a:extLst>
+          </p:cNvPr>
+          <p:cNvPicPr>
+            <a:picLocks xmlns:a="http://schemas.openxmlformats.org/drawingml/2006/main" noChangeAspect="1"/>
+          </p:cNvPicPr>
+          <p:nvPr/>
+        </p:nvPicPr>
+        <p:blipFill>
+          <a:blip xmlns:r="http://schemas.openxmlformats.org/officeDocument/2006/relationships" xmlns:a="http://schemas.openxmlformats.org/drawingml/2006/main" r:embed="R5f5d1304621848b8"/>
+          <a:stretch xmlns:a="http://schemas.openxmlformats.org/drawingml/2006/main">
+            <a:fillRect l="0" t="0" r="0" b="0"/>
+          </a:stretch>
+        </p:blipFill>
+        <p:spPr>
+          <a:xfrm xmlns:a="http://schemas.openxmlformats.org/drawingml/2006/main">
+            <a:off x="6970654" y="2993014"/>
+            <a:ext cx="286756" cy="286756"/>
+          </a:xfrm>
+          <a:prstGeom xmlns:a="http://schemas.openxmlformats.org/drawingml/2006/main" prst="rect">
+            <a:avLst/>
+          </a:prstGeom>
+        </p:spPr>
+      </p:pic>
+      <p:sp>
+        <p:nvSpPr>
+          <p:cNvPr id="14" name="Text 9">
+            <a:extLst xmlns:a="http://schemas.openxmlformats.org/drawingml/2006/main">
+              <a:ext uri="{FF2B5EF4-FFF2-40B4-BE49-F238E27FC236}">
+                <a16:creationId xmlns:a16="http://schemas.microsoft.com/office/drawing/2014/main" id="{E57C77C6-985E-413D-A351-949649F46735}"/>
+              </a:ext>
+            </a:extLst>
+          </p:cNvPr>
+          <p:cNvSpPr>
+            <a:spLocks xmlns:a="http://schemas.openxmlformats.org/drawingml/2006/main" noGrp="1"/>
+          </p:cNvSpPr>
+          <p:nvPr/>
+        </p:nvSpPr>
+        <p:spPr>
+          <a:xfrm xmlns:a="http://schemas.openxmlformats.org/drawingml/2006/main">
+            <a:off x="7498080" y="2752344"/>
+            <a:ext cx="4023360" cy="365760"/>
+          </a:xfrm>
+          <a:prstGeom xmlns:a="http://schemas.openxmlformats.org/drawingml/2006/main" prst="rect">
+            <a:avLst/>
+          </a:prstGeom>
+          <a:noFill xmlns:a="http://schemas.openxmlformats.org/drawingml/2006/main"/>
+        </p:spPr>
+        <p:txBody>
+          <a:bodyPr xmlns:a="http://schemas.openxmlformats.org/drawingml/2006/main" wrap="square" lIns="0" tIns="0" rIns="0" bIns="0" anchor="ctr"/>
+          <a:lstStyle xmlns:a="http://schemas.openxmlformats.org/drawingml/2006/main"/>
+          <a:p xmlns:a="http://schemas.openxmlformats.org/drawingml/2006/main">
+            <a:pPr marL="0" indent="0">
+              <a:buNone/>
+            </a:pPr>
+            <a:r>
+              <a:rPr sz="1700" b="1">
+                <a:solidFill>
+                  <a:schemeClr val="bg1"/>
+                </a:solidFill>
+              </a:rPr>
+              <a:t>SMAPE 13% national</a:t>
+            </a:r>
+            <a:endParaRPr sz="1700"/>
+          </a:p>
+        </p:txBody>
+      </p:sp>
+      <p:sp>
+        <p:nvSpPr>
+          <p:cNvPr id="15" name="Text 10">
+            <a:extLst xmlns:a="http://schemas.openxmlformats.org/drawingml/2006/main">
+              <a:ext uri="{FF2B5EF4-FFF2-40B4-BE49-F238E27FC236}">
+                <a16:creationId xmlns:a16="http://schemas.microsoft.com/office/drawing/2014/main" id="{AAF6A046-2F22-4F2E-8802-37C78E6CDC4F}"/>
+              </a:ext>
+            </a:extLst>
+          </p:cNvPr>
+          <p:cNvSpPr>
+            <a:spLocks xmlns:a="http://schemas.openxmlformats.org/drawingml/2006/main" noGrp="1"/>
+          </p:cNvSpPr>
+          <p:nvPr/>
+        </p:nvSpPr>
+        <p:spPr>
+          <a:xfrm xmlns:a="http://schemas.openxmlformats.org/drawingml/2006/main">
+            <a:off x="7498080" y="3118104"/>
+            <a:ext cx="4023360" cy="402336"/>
+          </a:xfrm>
+          <a:prstGeom xmlns:a="http://schemas.openxmlformats.org/drawingml/2006/main" prst="rect">
+            <a:avLst/>
+          </a:prstGeom>
+          <a:noFill xmlns:a="http://schemas.openxmlformats.org/drawingml/2006/main"/>
+        </p:spPr>
+        <p:txBody>
+          <a:bodyPr xmlns:a="http://schemas.openxmlformats.org/drawingml/2006/main" wrap="square" lIns="0" tIns="0" rIns="0" bIns="0" anchor="t"/>
+          <a:lstStyle xmlns:a="http://schemas.openxmlformats.org/drawingml/2006/main"/>
+          <a:p xmlns:a="http://schemas.openxmlformats.org/drawingml/2006/main">
+            <a:pPr marL="0" indent="0">
+              <a:buNone/>
+            </a:pPr>
+            <a:r>
+              <a:rPr sz="1100">
+                <a:solidFill>
+                  <a:schemeClr val="bg2"/>
+                </a:solidFill>
+              </a:rPr>
+              <a:t>nested out-of-sample test, weeks 12–63; regions 25%, states 60% (sparse type 1)</a:t>
+            </a:r>
+            <a:endParaRPr sz="1100"/>
+          </a:p>
+        </p:txBody>
+      </p:sp>
+      <p:sp>
+        <p:nvSpPr>
+          <p:cNvPr id="16" name="129 ms (p50)">
+            <a:extLst xmlns:a="http://schemas.openxmlformats.org/drawingml/2006/main">
+              <a:ext uri="{FF2B5EF4-FFF2-40B4-BE49-F238E27FC236}">
+                <a16:creationId xmlns:a16="http://schemas.microsoft.com/office/drawing/2014/main" id="{2B2729FC-8028-4E60-AC24-AF472CC25151}"/>
+              </a:ext>
+            </a:extLst>
+          </p:cNvPr>
+          <p:cNvSpPr>
+            <a:spLocks xmlns:a="http://schemas.openxmlformats.org/drawingml/2006/main" noGrp="1"/>
+          </p:cNvSpPr>
+          <p:nvPr/>
+        </p:nvSpPr>
+        <p:spPr>
+          <a:xfrm xmlns:a="http://schemas.openxmlformats.org/drawingml/2006/main">
+            <a:off x="6720840" y="3703320"/>
+            <a:ext cx="4919472" cy="877824"/>
+          </a:xfrm>
+          <a:prstGeom xmlns:a="http://schemas.openxmlformats.org/drawingml/2006/main" prst="roundRect">
+            <a:avLst>
+              <a:gd name="adj" fmla="val 10417"/>
+            </a:avLst>
+          </a:prstGeom>
+          <a:solidFill xmlns:a="http://schemas.openxmlformats.org/drawingml/2006/main">
+            <a:schemeClr val="accent1">
+              <a:alpha val="15000"/>
+            </a:schemeClr>
+          </a:solidFill>
+        </p:spPr>
+      </p:sp>
+      <p:sp>
+        <p:nvSpPr>
+          <p:cNvPr id="17" name="129 ms (p50) círculo">
+            <a:extLst xmlns:a="http://schemas.openxmlformats.org/drawingml/2006/main">
+              <a:ext uri="{FF2B5EF4-FFF2-40B4-BE49-F238E27FC236}">
+                <a16:creationId xmlns:a16="http://schemas.microsoft.com/office/drawing/2014/main" id="{1EF0AFFD-6B6A-4E8C-B91D-53F832900A77}"/>
+              </a:ext>
+            </a:extLst>
+          </p:cNvPr>
+          <p:cNvSpPr>
+            <a:spLocks xmlns:a="http://schemas.openxmlformats.org/drawingml/2006/main" noGrp="1"/>
+          </p:cNvSpPr>
+          <p:nvPr/>
+        </p:nvSpPr>
+        <p:spPr>
+          <a:xfrm xmlns:a="http://schemas.openxmlformats.org/drawingml/2006/main">
+            <a:off x="6858000" y="3886200"/>
+            <a:ext cx="512064" cy="512064"/>
+          </a:xfrm>
+          <a:prstGeom xmlns:a="http://schemas.openxmlformats.org/drawingml/2006/main" prst="ellipse">
+            <a:avLst/>
+          </a:prstGeom>
+          <a:solidFill xmlns:a="http://schemas.openxmlformats.org/drawingml/2006/main">
+            <a:schemeClr val="accent1"/>
+          </a:solidFill>
+        </p:spPr>
+      </p:sp>
+      <p:pic>
+        <p:nvPicPr>
+          <p:cNvPr id="18" name="129 ms (p50) ícono">
+            <a:extLst xmlns:a="http://schemas.openxmlformats.org/drawingml/2006/main">
+              <a:ext uri="{FF2B5EF4-FFF2-40B4-BE49-F238E27FC236}">
+                <a16:creationId xmlns:a16="http://schemas.microsoft.com/office/drawing/2014/main" id="{36FF8D49-4112-4026-A04C-128B1D92F464}"/>
+              </a:ext>
+            </a:extLst>
+          </p:cNvPr>
+          <p:cNvPicPr>
+            <a:picLocks xmlns:a="http://schemas.openxmlformats.org/drawingml/2006/main" noChangeAspect="1"/>
+          </p:cNvPicPr>
+          <p:nvPr/>
+        </p:nvPicPr>
+        <p:blipFill>
+          <a:blip xmlns:r="http://schemas.openxmlformats.org/officeDocument/2006/relationships" xmlns:a="http://schemas.openxmlformats.org/drawingml/2006/main" r:embed="R5ef65c5779194fe7"/>
+          <a:stretch xmlns:a="http://schemas.openxmlformats.org/drawingml/2006/main">
+            <a:fillRect l="0" t="0" r="0" b="0"/>
+          </a:stretch>
+        </p:blipFill>
+        <p:spPr>
+          <a:xfrm xmlns:a="http://schemas.openxmlformats.org/drawingml/2006/main">
+            <a:off x="6970654" y="3998854"/>
+            <a:ext cx="286756" cy="286756"/>
+          </a:xfrm>
+          <a:prstGeom xmlns:a="http://schemas.openxmlformats.org/drawingml/2006/main" prst="rect">
+            <a:avLst/>
+          </a:prstGeom>
+        </p:spPr>
+      </p:pic>
+      <p:sp>
+        <p:nvSpPr>
+          <p:cNvPr id="19" name="Text 13">
+            <a:extLst xmlns:a="http://schemas.openxmlformats.org/drawingml/2006/main">
+              <a:ext uri="{FF2B5EF4-FFF2-40B4-BE49-F238E27FC236}">
+                <a16:creationId xmlns:a16="http://schemas.microsoft.com/office/drawing/2014/main" id="{C417450E-D581-48B5-8767-2EA3E2E61C6E}"/>
+              </a:ext>
+            </a:extLst>
+          </p:cNvPr>
+          <p:cNvSpPr>
+            <a:spLocks xmlns:a="http://schemas.openxmlformats.org/drawingml/2006/main" noGrp="1"/>
+          </p:cNvSpPr>
+          <p:nvPr/>
+        </p:nvSpPr>
+        <p:spPr>
+          <a:xfrm xmlns:a="http://schemas.openxmlformats.org/drawingml/2006/main">
+            <a:off x="7498080" y="3758184"/>
+            <a:ext cx="4023360" cy="365760"/>
+          </a:xfrm>
+          <a:prstGeom xmlns:a="http://schemas.openxmlformats.org/drawingml/2006/main" prst="rect">
+            <a:avLst/>
+          </a:prstGeom>
+          <a:noFill xmlns:a="http://schemas.openxmlformats.org/drawingml/2006/main"/>
+        </p:spPr>
+        <p:txBody>
+          <a:bodyPr xmlns:a="http://schemas.openxmlformats.org/drawingml/2006/main" wrap="square" lIns="0" tIns="0" rIns="0" bIns="0" anchor="ctr"/>
+          <a:lstStyle xmlns:a="http://schemas.openxmlformats.org/drawingml/2006/main"/>
+          <a:p xmlns:a="http://schemas.openxmlformats.org/drawingml/2006/main">
+            <a:pPr marL="0" indent="0">
+              <a:buNone/>
+            </a:pPr>
+            <a:r>
+              <a:rPr sz="1700" b="1">
+                <a:solidFill>
+                  <a:schemeClr val="bg1"/>
+                </a:solidFill>
+              </a:rPr>
+              <a:t>52 weeks ahead</a:t>
+            </a:r>
+            <a:endParaRPr sz="1700"/>
+          </a:p>
+        </p:txBody>
+      </p:sp>
+      <p:sp>
+        <p:nvSpPr>
+          <p:cNvPr id="20" name="Text 14">
+            <a:extLst xmlns:a="http://schemas.openxmlformats.org/drawingml/2006/main">
+              <a:ext uri="{FF2B5EF4-FFF2-40B4-BE49-F238E27FC236}">
+                <a16:creationId xmlns:a16="http://schemas.microsoft.com/office/drawing/2014/main" id="{8FC20039-96AE-4834-A624-03E28BF05507}"/>
+              </a:ext>
+            </a:extLst>
+          </p:cNvPr>
+          <p:cNvSpPr>
+            <a:spLocks xmlns:a="http://schemas.openxmlformats.org/drawingml/2006/main" noGrp="1"/>
+          </p:cNvSpPr>
+          <p:nvPr/>
+        </p:nvSpPr>
+        <p:spPr>
+          <a:xfrm xmlns:a="http://schemas.openxmlformats.org/drawingml/2006/main">
+            <a:off x="7498080" y="4123944"/>
+            <a:ext cx="4023360" cy="402336"/>
+          </a:xfrm>
+          <a:prstGeom xmlns:a="http://schemas.openxmlformats.org/drawingml/2006/main" prst="rect">
+            <a:avLst/>
+          </a:prstGeom>
+          <a:noFill xmlns:a="http://schemas.openxmlformats.org/drawingml/2006/main"/>
+        </p:spPr>
+        <p:txBody>
+          <a:bodyPr xmlns:a="http://schemas.openxmlformats.org/drawingml/2006/main" wrap="square" lIns="0" tIns="0" rIns="0" bIns="0" anchor="t"/>
+          <a:lstStyle xmlns:a="http://schemas.openxmlformats.org/drawingml/2006/main"/>
+          <a:p xmlns:a="http://schemas.openxmlformats.org/drawingml/2006/main">
+            <a:pPr marL="0" indent="0">
+              <a:buNone/>
+            </a:pPr>
+            <a:r>
+              <a:rPr sz="1100">
+                <a:solidFill>
+                  <a:schemeClr val="bg2"/>
+                </a:solidFill>
+              </a:rPr>
+              <a:t>Oct 19, 2026 – Oct 11, 2027 after an 11-week nowcast; ETS or seasonal naive per series</a:t>
+            </a:r>
+            <a:endParaRPr sz="1100"/>
+          </a:p>
+        </p:txBody>
+      </p:sp>
+      <p:sp>
+        <p:nvSpPr>
+          <p:cNvPr id="21" name="Budget = cases × cost">
+            <a:extLst xmlns:a="http://schemas.openxmlformats.org/drawingml/2006/main">
+              <a:ext uri="{FF2B5EF4-FFF2-40B4-BE49-F238E27FC236}">
+                <a16:creationId xmlns:a16="http://schemas.microsoft.com/office/drawing/2014/main" id="{60C7EE51-4110-4BD6-AA06-1022932EF1C0}"/>
+              </a:ext>
+            </a:extLst>
+          </p:cNvPr>
+          <p:cNvSpPr>
+            <a:spLocks xmlns:a="http://schemas.openxmlformats.org/drawingml/2006/main" noGrp="1"/>
+          </p:cNvSpPr>
+          <p:nvPr/>
+        </p:nvSpPr>
+        <p:spPr>
+          <a:xfrm xmlns:a="http://schemas.openxmlformats.org/drawingml/2006/main">
+            <a:off x="6720840" y="4709160"/>
+            <a:ext cx="4919472" cy="877824"/>
+          </a:xfrm>
+          <a:prstGeom xmlns:a="http://schemas.openxmlformats.org/drawingml/2006/main" prst="roundRect">
+            <a:avLst>
+              <a:gd name="adj" fmla="val 10417"/>
+            </a:avLst>
+          </a:prstGeom>
+          <a:solidFill xmlns:a="http://schemas.openxmlformats.org/drawingml/2006/main">
+            <a:schemeClr val="accent1">
+              <a:alpha val="15000"/>
+            </a:schemeClr>
+          </a:solidFill>
+        </p:spPr>
+      </p:sp>
+      <p:sp>
+        <p:nvSpPr>
+          <p:cNvPr id="22" name="Budget = cases × cost círculo">
+            <a:extLst xmlns:a="http://schemas.openxmlformats.org/drawingml/2006/main">
+              <a:ext uri="{FF2B5EF4-FFF2-40B4-BE49-F238E27FC236}">
+                <a16:creationId xmlns:a16="http://schemas.microsoft.com/office/drawing/2014/main" id="{41095B4A-AE0B-4A0C-B98C-4EBB205BBFA6}"/>
+              </a:ext>
+            </a:extLst>
+          </p:cNvPr>
+          <p:cNvSpPr>
+            <a:spLocks xmlns:a="http://schemas.openxmlformats.org/drawingml/2006/main" noGrp="1"/>
+          </p:cNvSpPr>
+          <p:nvPr/>
+        </p:nvSpPr>
+        <p:spPr>
+          <a:xfrm xmlns:a="http://schemas.openxmlformats.org/drawingml/2006/main">
+            <a:off x="6858000" y="4892040"/>
+            <a:ext cx="512064" cy="512064"/>
+          </a:xfrm>
+          <a:prstGeom xmlns:a="http://schemas.openxmlformats.org/drawingml/2006/main" prst="ellipse">
+            <a:avLst/>
+          </a:prstGeom>
+          <a:solidFill xmlns:a="http://schemas.openxmlformats.org/drawingml/2006/main">
+            <a:schemeClr val="accent1"/>
+          </a:solidFill>
+        </p:spPr>
+      </p:sp>
+      <p:pic>
+        <p:nvPicPr>
+          <p:cNvPr id="23" name="Budget = cases × cost ícono">
+            <a:extLst xmlns:a="http://schemas.openxmlformats.org/drawingml/2006/main">
+              <a:ext uri="{FF2B5EF4-FFF2-40B4-BE49-F238E27FC236}">
+                <a16:creationId xmlns:a16="http://schemas.microsoft.com/office/drawing/2014/main" id="{7F3D9260-3149-442F-8770-3F62B522D0F1}"/>
+              </a:ext>
+            </a:extLst>
+          </p:cNvPr>
+          <p:cNvPicPr>
+            <a:picLocks xmlns:a="http://schemas.openxmlformats.org/drawingml/2006/main" noChangeAspect="1"/>
+          </p:cNvPicPr>
+          <p:nvPr/>
+        </p:nvPicPr>
+        <p:blipFill>
+          <a:blip xmlns:r="http://schemas.openxmlformats.org/officeDocument/2006/relationships" xmlns:a="http://schemas.openxmlformats.org/drawingml/2006/main" r:embed="R4baf8ec1ec68463f"/>
+          <a:stretch xmlns:a="http://schemas.openxmlformats.org/drawingml/2006/main">
+            <a:fillRect l="0" t="0" r="0" b="0"/>
+          </a:stretch>
+        </p:blipFill>
+        <p:spPr>
+          <a:xfrm xmlns:a="http://schemas.openxmlformats.org/drawingml/2006/main">
+            <a:off x="6970654" y="5004694"/>
+            <a:ext cx="286756" cy="286756"/>
+          </a:xfrm>
+          <a:prstGeom xmlns:a="http://schemas.openxmlformats.org/drawingml/2006/main" prst="rect">
+            <a:avLst/>
+          </a:prstGeom>
+        </p:spPr>
+      </p:pic>
+      <p:sp>
+        <p:nvSpPr>
+          <p:cNvPr id="24" name="Text 17">
+            <a:extLst xmlns:a="http://schemas.openxmlformats.org/drawingml/2006/main">
+              <a:ext uri="{FF2B5EF4-FFF2-40B4-BE49-F238E27FC236}">
+                <a16:creationId xmlns:a16="http://schemas.microsoft.com/office/drawing/2014/main" id="{1275C137-C6F7-4E94-AB80-197B491E98D2}"/>
+              </a:ext>
+            </a:extLst>
+          </p:cNvPr>
+          <p:cNvSpPr>
+            <a:spLocks xmlns:a="http://schemas.openxmlformats.org/drawingml/2006/main" noGrp="1"/>
+          </p:cNvSpPr>
+          <p:nvPr/>
+        </p:nvSpPr>
+        <p:spPr>
+          <a:xfrm xmlns:a="http://schemas.openxmlformats.org/drawingml/2006/main">
+            <a:off x="7498080" y="4764024"/>
+            <a:ext cx="4023360" cy="365760"/>
+          </a:xfrm>
+          <a:prstGeom xmlns:a="http://schemas.openxmlformats.org/drawingml/2006/main" prst="rect">
+            <a:avLst/>
+          </a:prstGeom>
+          <a:noFill xmlns:a="http://schemas.openxmlformats.org/drawingml/2006/main"/>
+        </p:spPr>
+        <p:txBody>
+          <a:bodyPr xmlns:a="http://schemas.openxmlformats.org/drawingml/2006/main" wrap="square" lIns="0" tIns="0" rIns="0" bIns="0" anchor="ctr"/>
+          <a:lstStyle xmlns:a="http://schemas.openxmlformats.org/drawingml/2006/main"/>
+          <a:p xmlns:a="http://schemas.openxmlformats.org/drawingml/2006/main">
+            <a:pPr marL="0" indent="0">
+              <a:buNone/>
+            </a:pPr>
+            <a:r>
+              <a:rPr sz="1700" b="1">
+                <a:solidFill>
+                  <a:schemeClr val="bg1"/>
+                </a:solidFill>
+              </a:rPr>
+              <a:t>Budget = cases × cost</a:t>
+            </a:r>
+            <a:endParaRPr sz="1700"/>
+          </a:p>
+        </p:txBody>
+      </p:sp>
+      <p:sp>
+        <p:nvSpPr>
+          <p:cNvPr id="25" name="Text 18">
+            <a:extLst xmlns:a="http://schemas.openxmlformats.org/drawingml/2006/main">
+              <a:ext uri="{FF2B5EF4-FFF2-40B4-BE49-F238E27FC236}">
+                <a16:creationId xmlns:a16="http://schemas.microsoft.com/office/drawing/2014/main" id="{ABCABECA-0125-4198-A58A-221CB8CB3349}"/>
+              </a:ext>
+            </a:extLst>
+          </p:cNvPr>
+          <p:cNvSpPr>
+            <a:spLocks xmlns:a="http://schemas.openxmlformats.org/drawingml/2006/main" noGrp="1"/>
+          </p:cNvSpPr>
+          <p:nvPr/>
+        </p:nvSpPr>
+        <p:spPr>
+          <a:xfrm xmlns:a="http://schemas.openxmlformats.org/drawingml/2006/main">
+            <a:off x="7498080" y="5129784"/>
+            <a:ext cx="4023360" cy="402336"/>
+          </a:xfrm>
+          <a:prstGeom xmlns:a="http://schemas.openxmlformats.org/drawingml/2006/main" prst="rect">
+            <a:avLst/>
+          </a:prstGeom>
+          <a:noFill xmlns:a="http://schemas.openxmlformats.org/drawingml/2006/main"/>
+        </p:spPr>
+        <p:txBody>
+          <a:bodyPr xmlns:a="http://schemas.openxmlformats.org/drawingml/2006/main" wrap="square" lIns="0" tIns="0" rIns="0" bIns="0" anchor="t"/>
+          <a:lstStyle xmlns:a="http://schemas.openxmlformats.org/drawingml/2006/main"/>
+          <a:p xmlns:a="http://schemas.openxmlformats.org/drawingml/2006/main">
+            <a:pPr marL="0" indent="0">
+              <a:buNone/>
+            </a:pPr>
+            <a:r>
+              <a:rPr sz="1100">
+                <a:solidFill>
+                  <a:schemeClr val="bg2"/>
+                </a:solidFill>
+              </a:rPr>
+              <a:t>shown only with a sourced unit cost; no cost is assumed</a:t>
+            </a:r>
+            <a:endParaRPr sz="1100"/>
+          </a:p>
+        </p:txBody>
+      </p:sp>
+      <p:sp>
+        <p:nvSpPr>
+          <p:cNvPr id="26" name="Text 19">
+            <a:extLst xmlns:a="http://schemas.openxmlformats.org/drawingml/2006/main">
+              <a:ext uri="{FF2B5EF4-FFF2-40B4-BE49-F238E27FC236}">
+                <a16:creationId xmlns:a16="http://schemas.microsoft.com/office/drawing/2014/main" id="{18A1E4D6-A93C-46F3-BEA5-070896256DA1}"/>
+              </a:ext>
+            </a:extLst>
+          </p:cNvPr>
+          <p:cNvSpPr>
+            <a:spLocks xmlns:a="http://schemas.openxmlformats.org/drawingml/2006/main" noGrp="1"/>
+          </p:cNvSpPr>
+          <p:nvPr/>
+        </p:nvSpPr>
+        <p:spPr>
+          <a:xfrm xmlns:a="http://schemas.openxmlformats.org/drawingml/2006/main">
+            <a:off x="6720840" y="5760720"/>
+            <a:ext cx="4919472" cy="411480"/>
+          </a:xfrm>
+          <a:prstGeom xmlns:a="http://schemas.openxmlformats.org/drawingml/2006/main" prst="rect">
+            <a:avLst/>
+          </a:prstGeom>
+          <a:noFill xmlns:a="http://schemas.openxmlformats.org/drawingml/2006/main"/>
+        </p:spPr>
+        <p:txBody>
+          <a:bodyPr xmlns:a="http://schemas.openxmlformats.org/drawingml/2006/main" wrap="square" lIns="0" tIns="0" rIns="0" bIns="0" anchor="t"/>
+          <a:lstStyle xmlns:a="http://schemas.openxmlformats.org/drawingml/2006/main"/>
+          <a:p xmlns:a="http://schemas.openxmlformats.org/drawingml/2006/main">
+            <a:pPr marL="0" indent="0">
+              <a:buNone/>
+            </a:pPr>
+            <a:r>
+              <a:rPr sz="1000">
+                <a:solidFill>
+                  <a:schemeClr val="accent4"/>
+                </a:solidFill>
+              </a:rPr>
+              <a:t>EXPLORATORY · SINAVE-notified cases, not all cases · nominal 80% bands cover ≈64% in practice · public aggregates, no patient data · not yet run on LinuxONE.</a:t>
+            </a:r>
+            <a:endParaRPr sz="1000"/>
+          </a:p>
+        </p:txBody>
+      </p:sp>
+      <p:sp>
+        <p:nvSpPr>
+          <p:cNvPr id="27" name="Slide Number Placeholder 0">
+            <a:extLst xmlns:a="http://schemas.openxmlformats.org/drawingml/2006/main">
+              <a:ext uri="{FF2B5EF4-FFF2-40B4-BE49-F238E27FC236}">
+                <a16:creationId xmlns:a16="http://schemas.microsoft.com/office/drawing/2014/main" id="{36E123FC-56CD-4511-8432-2489215E3D9C}"/>
+              </a:ext>
+            </a:extLst>
+          </p:cNvPr>
+          <p:cNvSpPr>
+            <a:spLocks xmlns:a="http://schemas.openxmlformats.org/drawingml/2006/main" noGrp="1"/>
+          </p:cNvSpPr>
+          <p:nvPr>
+            <p:ph type="sldNum" idx="4294967295"/>
+          </p:nvPr>
+        </p:nvSpPr>
+        <p:spPr>
+          <a:xfrm xmlns:a="http://schemas.openxmlformats.org/drawingml/2006/main">
+            <a:off x="11183112" y="6400800"/>
+            <a:ext cx="457200" cy="274320"/>
+          </a:xfrm>
+          <a:prstGeom xmlns:a="http://schemas.openxmlformats.org/drawingml/2006/main" prst="rect">
+            <a:avLst/>
+          </a:prstGeom>
+        </p:spPr>
+        <p:txBody>
+          <a:bodyPr xmlns:a="http://schemas.openxmlformats.org/drawingml/2006/main"/>
+          <a:lstStyle xmlns:a="http://schemas.openxmlformats.org/drawingml/2006/main">
+            <a:lvl1pPr>
+              <a:buNone/>
+              <a:defRPr sz="900">
+                <a:solidFill>
+                  <a:schemeClr val="accent6"/>
+                </a:solidFill>
+              </a:defRPr>
+            </a:lvl1pPr>
+          </a:lstStyle>
+          <a:p xmlns:a="http://schemas.openxmlformats.org/drawingml/2006/main">
+            <a:pPr algn="r">
+              <a:buNone/>
+            </a:pPr>
+            <a:fld id="{F7021451-1387-4CA6-816F-3879F97B5CBC}" type="slidenum">
+              <a:rPr b="0"/>
+              <a:t>8</a:t>
+            </a:fld>
+            <a:endParaRPr/>
+          </a:p>
+        </p:txBody>
+      </p:sp>
+    </p:spTree>
+    <p:extLst>
+      <p:ext uri="{BB962C8B-B14F-4D97-AF65-F5344CB8AC3E}">
+        <p14:creationId xmlns:p14="http://schemas.microsoft.com/office/powerpoint/2010/main" val="470167264"/>
       </p:ext>
     </p:extLst>
   </p:cSld>

</xml_diff>